<commit_message>
Checkpoint FASE 2 v3: dialogos N1/N2 educativos (produccion en curso)
Co-Authored-By: Claude Opus 4.8 <noreply@anthropic.com>
Claude-Session: https://claude.ai/code/session_01UvCPDpSUkU2UKG6kCugktD
</commit_message>
<xml_diff>
--- a/Curso Gas B/00 - El Reglamento de Gas - estructura, ambito y generalidades/00 - El Reglamento de Gas - Vídeo 1.pptx
+++ b/Curso Gas B/00 - El Reglamento de Gas - estructura, ambito y generalidades/00 - El Reglamento de Gas - Vídeo 1.pptx
@@ -19,6 +19,7 @@
     <p:sldId id="267" r:id="rId19"/>
     <p:sldId id="268" r:id="rId20"/>
     <p:sldId id="269" r:id="rId21"/>
+    <p:sldId id="270" r:id="rId22"/>
   </p:sldIdLst>
   <p:sldSz cx="12191695" cy="6858000" type="screen4x3"/>
   <p:notesSz cx="6858000" cy="9144000"/>
@@ -520,7 +521,7 @@
           </a:p>
           <a:p>
             <a:r>
-              <a:t>N2: Manda un único texto, el Reglamento técnico de distribución y utilización de combustibles gaseosos, el famoso Real Decreto novecientos diecinueve. En este primer vídeo vemos para qué sirve, a qué instalaciones se aplica y, sobre todo, el vocabulario exacto con el que vas a trabajar todo el curso. Dominar estas definiciones es tener media asignatura ganada, porque son las palabras que aparecen en el boletín, en el examen y en cada avería que te encuentres.</a:t>
+              <a:t>N2: Manda un único texto: el Reglamento técnico de distribución y utilización de combustibles gaseosos, el famoso Real Decreto novecientos diecinueve. Todo tu oficio se apoya en él. En este primer vídeo vemos para qué sirve, a qué instalaciones se aplica y, sobre todo, el vocabulario exacto con el que vas a trabajar. Domina estas definiciones y tienes media asignatura ganada, porque son las palabras que aparecen en el boletín, en el examen y en cada avería que pises.</a:t>
             </a:r>
           </a:p>
         </p:txBody>
@@ -590,12 +591,12 @@
           <a:lstStyle/>
           <a:p>
             <a:r>
-              <a:t>N1: ¿Cómo colocas los tres tramos sin equivocarte?</a:t>
-            </a:r>
-          </a:p>
-          <a:p>
-            <a:r>
-              <a:t>N2: El gas entra y va pasando por tres tramos encajados, siempre en el mismo orden. Primero la acometida interior, de la calle al edificio; luego la instalación común, el montante que sube por el edificio y es compartido; y por último la instalación individual, lo que entra en cada vivienda hasta cada aparato. Cada tramo empieza justo donde acaba el anterior. Si te imaginas el gas subiendo por la escalera y entrando en tu piso, colocas los tres tramos sin fallar.</a:t>
+              <a:t>N1: ¿Cómo colocas los tres tramos sin equivocarte nunca?</a:t>
+            </a:r>
+          </a:p>
+          <a:p>
+            <a:r>
+              <a:t>N2: El gas entra y va pasando por tres tramos encajados, siempre en el mismo orden, como muñecas rusas. Primero la acometida interior, de la calle al edificio. Luego la instalación común, el montante que sube por el edificio y es compartido por los vecinos. Y por último la instalación individual, lo que entra en cada vivienda hasta cada aparato. Cada tramo empieza justo donde acaba el anterior. Si te imaginas el gas subiendo por la escalera y entrando en tu piso, colocas los tres tramos sin fallar. Y saber en qué tramo estás decide quién lo mantiene y quién lo inspecciona.</a:t>
             </a:r>
           </a:p>
         </p:txBody>
@@ -665,12 +666,12 @@
           <a:lstStyle/>
           <a:p>
             <a:r>
-              <a:t>N1: ¿Siempre hay tres tramos?</a:t>
-            </a:r>
-          </a:p>
-          <a:p>
-            <a:r>
-              <a:t>N2: No siempre. La propia definición dice 'en su caso más general', porque no todas las instalaciones tienen los tres. En una vivienda unifamiliar, un chalé con el contador en la valla, no hay instalación común ni acometida interior: va casi todo directo a la instalación individual. Así que no te agobies si en una instalación real falta un tramo; es completamente normal. Lo importante es reconocer qué tramo tienes delante para saber qué le corresponde.</a:t>
+              <a:t>N1: ¿Siempre están los tres tramos?</a:t>
+            </a:r>
+          </a:p>
+          <a:p>
+            <a:r>
+              <a:t>N2: No siempre. La propia definición dice 'en su caso más general', porque no todas las instalaciones tienen los tres. En una vivienda unifamiliar, un chalé con el contador en la valla, no hay instalación común ni acometida interior: va casi todo directo a la instalación individual. Así que no te agobies si en una instalación real falta un tramo; es completamente normal y no es un error. Lo importante es reconocer qué tramo tienes delante para saber qué le corresponde y qué papel te toca firmar.</a:t>
             </a:r>
           </a:p>
         </p:txBody>
@@ -740,12 +741,12 @@
           <a:lstStyle/>
           <a:p>
             <a:r>
-              <a:t>N1: ¿Sabrías separar quién hace qué?</a:t>
-            </a:r>
-          </a:p>
-          <a:p>
-            <a:r>
-              <a:t>N2: La otra mitad del diccionario son las personas, los agentes. Ata cabos: el fabricante hace el producto; la empresa instaladora, que es la razón social, monta y certifica; el instalador, la persona con carné, ejecuta; el distribuidor lleva el gas por la red; el comercializador te lo vende; el titular es el dueño que responde del mantenimiento y el usuario el que lo gasta. Si separas 'tuberías' de 'personas', las preguntas cruzadas del examen dejan de tener trampa, y en obra sabes a quién firmas y a quién avisas.</a:t>
+              <a:t>N1: ¿Sabrías separar quién hace qué en una instalación?</a:t>
+            </a:r>
+          </a:p>
+          <a:p>
+            <a:r>
+              <a:t>N2: La otra mitad del diccionario son las personas, los agentes, y aquí está la trampa clásica del examen. Ata cabos: el fabricante hace el producto. La empresa instaladora, que es la razón social, monta y certifica. El instalador, la persona con carné, ejecuta. El distribuidor lleva el gas por la red. El comercializador te lo vende. El titular es el dueño que responde del mantenimiento y el usuario es el que lo gasta. Si separas 'tuberías' de 'personas', las preguntas cruzadas dejan de tener trampa, y en obra sabes exactamente a quién firmas y a quién avisas.</a:t>
             </a:r>
           </a:p>
         </p:txBody>
@@ -815,12 +816,12 @@
           <a:lstStyle/>
           <a:p>
             <a:r>
-              <a:t>N1: ¿Qué son las tres familias de la norma?</a:t>
-            </a:r>
-          </a:p>
-          <a:p>
-            <a:r>
-              <a:t>N2: Los combustibles gaseosos se clasifican en tres familias por cómo queman. La primera son los gases manufacturados y el aire propanado, casi en desuso; la segunda es el gas natural, el de la ciudad; y la tercera es el GLP, butano y propano. Esto no es trivia: cada aparato está tarado para su gas y su presión. Meterle un gas de otra familia o a otra presión da mala combustión, llama amarilla, ennegrecido y monóxido de carbono. Aquí solo los clasificas; el ajuste vendrá más adelante, pero la causa de media avería de combustión empieza por confundir la familia.</a:t>
+              <a:t>N1: ¿Qué son las tres familias de la norma UNE-EN cuatrocientos treinta y siete?</a:t>
+            </a:r>
+          </a:p>
+          <a:p>
+            <a:r>
+              <a:t>N2: Los combustibles gaseosos se clasifican en tres familias por cómo queman. La primera son los gases manufacturados y el aire propanado, casi en desuso. La segunda es el gas natural, el de la ciudad. Y la tercera es el GLP, butano y propano. Esto no es un dato de relleno: cada aparato está tarado para su gas y su presión. Meterle un gas de otra familia, o a otra presión, da mala combustión, llama amarilla, ennegrecido y monóxido de carbono. Aquí solo los clasificas; el ajuste vendrá más adelante, pero recuerda que la causa de media avería de combustión empieza por confundir la familia.</a:t>
             </a:r>
           </a:p>
         </p:txBody>
@@ -890,12 +891,97 @@
           <a:lstStyle/>
           <a:p>
             <a:r>
-              <a:t>N1: Si te quedas solo con tres cosas de este vídeo, ¿cuáles?</a:t>
-            </a:r>
-          </a:p>
-          <a:p>
-            <a:r>
-              <a:t>N2: Primera: el Reglamento es el tronco y cada ITC una rama, y todo cuelga de dos leyes con un único fin, la seguridad de las personas. Segunda: tu terreno es la instalación receptora, que va de la llave de acometida, excluida, a la llave del aparato, incluida; esa frontera decide qué pruebas y qué firmas. Y tercera: el artículo tercero es tu diccionario, separa las tres partes encajadas, acometida interior, común e individual, de las personas del oficio. Con esas tres ideas no te pierdes en el resto del curso. En el próximo vídeo damos el salto al día a día: materiales y el camino completo hasta que la instalación tiene gas.</a:t>
+              <a:t>N1: Cerramos con un repaso rápido. ¿Te suenan ya los cuatro pilares?</a:t>
+            </a:r>
+          </a:p>
+          <a:p>
+            <a:r>
+              <a:t>N2: Uno, tronco y ramas: lo general en el Reglamento, el detalle en cada ITC. Dos, nueve tipos de instalación, y la letra hache, las receptoras, es tu terreno. Tres, la receptora va de la llave de acometida, excluida, a la llave del aparato, incluida. Y cuatro, el artículo tercero es tu diccionario: separa las tres partes encajadas de las personas del oficio. Si eres capaz de recitar estos cuatro puntos de carrerilla, tienes el vídeo dominado. Repítelos en voz alta una vez antes de seguir.</a:t>
+            </a:r>
+          </a:p>
+        </p:txBody>
+      </p:sp>
+      <p:sp>
+        <p:nvSpPr>
+          <p:cNvPr id="4" name="Slide Number Placeholder 3"/>
+          <p:cNvSpPr>
+            <a:spLocks noGrp="1"/>
+          </p:cNvSpPr>
+          <p:nvPr>
+            <p:ph type="sldNum" idx="5" sz="quarter"/>
+          </p:nvPr>
+        </p:nvSpPr>
+        <p:spPr/>
+      </p:sp>
+    </p:spTree>
+  </p:cSld>
+  <p:clrMapOvr>
+    <a:masterClrMapping/>
+  </p:clrMapOvr>
+</p:notes>
+</file>
+
+<file path=ppt/notesSlides/notesSlide15.xml><?xml version="1.0" encoding="utf-8"?>
+<p:notes xmlns:a="http://schemas.openxmlformats.org/drawingml/2006/main" xmlns:p="http://schemas.openxmlformats.org/presentationml/2006/main" xmlns:r="http://schemas.openxmlformats.org/officeDocument/2006/relationships">
+  <p:cSld>
+    <p:spTree>
+      <p:nvGrpSpPr>
+        <p:cNvPr id="1" name=""/>
+        <p:cNvGrpSpPr/>
+        <p:nvPr/>
+      </p:nvGrpSpPr>
+      <p:grpSpPr>
+        <a:xfrm>
+          <a:off x="0" y="0"/>
+          <a:ext cx="0" cy="0"/>
+          <a:chOff x="0" y="0"/>
+          <a:chExt cx="0" cy="0"/>
+        </a:xfrm>
+      </p:grpSpPr>
+      <p:sp>
+        <p:nvSpPr>
+          <p:cNvPr id="2" name="Slide Image Placeholder 1"/>
+          <p:cNvSpPr>
+            <a:spLocks noGrp="1"/>
+          </p:cNvSpPr>
+          <p:nvPr>
+            <p:ph type="sldImg" idx="2"/>
+          </p:nvPr>
+        </p:nvSpPr>
+        <p:spPr/>
+      </p:sp>
+      <p:sp>
+        <p:nvSpPr>
+          <p:cNvPr id="3" name="Notes Placeholder 2"/>
+          <p:cNvSpPr>
+            <a:spLocks noGrp="1"/>
+          </p:cNvSpPr>
+          <p:nvPr>
+            <p:ph type="body" idx="3" sz="quarter"/>
+          </p:nvPr>
+        </p:nvSpPr>
+        <p:spPr/>
+        <p:txBody>
+          <a:bodyPr/>
+          <a:lstStyle/>
+          <a:p>
+            <a:r>
+              <a:t>N1: Cerramos fuerte. Si te quedas con lo esencial, ¿qué has conquistado hoy?</a:t>
+            </a:r>
+          </a:p>
+          <a:p>
+            <a:r>
+              <a:t>N2: Tres logros que ya son tuyos. Uno: sabes colocar cualquier norma en su sitio, lo general en el tronco del Reglamento y el detalle en la rama de su ITC. Dos: marcas la frontera de tu instalación receptora con una sola frase, de la llave de acometida excluida a la llave del aparato incluida, y con eso ya sabes qué pruebas y qué firmas. Y tres: el artículo tercero ha dejado de ser una lista para convertirse en tu diccionario, con las tres partes encajadas por un lado y las personas del oficio por otro.</a:t>
+            </a:r>
+          </a:p>
+          <a:p>
+            <a:r>
+              <a:t>N1: ¿Y por qué esto vale oro en el examen y en la obra?</a:t>
+            </a:r>
+          </a:p>
+          <a:p>
+            <a:r>
+              <a:t>N2: Porque en el examen te lo preguntan cruzado: te mezclan una parte con un agente, o te ponen una bombona de camping a ver si la cuelas como receptora. Y en la obra decide quién firma el boletín y de qué tramo respondes. Confundir la frontera es dejar un tramo sin probar, y ahí aparece la fuga. Hoy ya eres más gasista que ayer. En el siguiente vídeo damos el salto al día a día: los materiales y el camino completo desde que terminas la instalación hasta que tiene gas. Te espero allí.</a:t>
             </a:r>
           </a:p>
         </p:txBody>
@@ -965,12 +1051,12 @@
           <a:lstStyle/>
           <a:p>
             <a:r>
-              <a:t>N1: ¿Qué tres números resumen este vídeo?</a:t>
-            </a:r>
-          </a:p>
-          <a:p>
-            <a:r>
-              <a:t>N2: Nueve tipos de instalación que el Reglamento mete bajo su paraguas, desde la red de la calle hasta el aparato; tres partes en las que se divide la instalación receptora, que es tu terreno; y veinticuatro definiciones en el artículo tercero, el diccionario del oficio. Si te quedas con estos tres bloques, tienes el esqueleto del vídeo: qué se regula, cuál es tu zona y con qué palabras se nombra todo.</a:t>
+              <a:t>N1: ¿Qué tres números te dan el esqueleto del vídeo?</a:t>
+            </a:r>
+          </a:p>
+          <a:p>
+            <a:r>
+              <a:t>N2: Nueve tipos de instalación que el Reglamento mete bajo su paraguas, desde la red de la calle hasta el aparato. Tres partes en las que se divide la instalación receptora, que es tu terreno del día a día. Y veinticuatro definiciones en el artículo tercero, el diccionario del oficio. Si retienes estos tres bloques, ya sabes qué se regula, cuál es tu zona y con qué palabras se nombra todo. Lo demás cuelga de aquí.</a:t>
             </a:r>
           </a:p>
         </p:txBody>
@@ -1040,7 +1126,7 @@
           <a:lstStyle/>
           <a:p>
             <a:r>
-              <a:t>N1: Si tuvieras que explicar en una frase para qué existe este Reglamento, ¿qué dirías?</a:t>
+              <a:t>N1: Si tuvieras que resumir en una frase para qué existe este Reglamento, ¿qué dirías?</a:t>
             </a:r>
           </a:p>
           <a:p>
@@ -1115,12 +1201,12 @@
           <a:lstStyle/>
           <a:p>
             <a:r>
-              <a:t>N1: ¿De dónde sale cada norma que aplicas en obra?</a:t>
-            </a:r>
-          </a:p>
-          <a:p>
-            <a:r>
-              <a:t>N2: Imagina el Reglamento como el tronco de un árbol y las Instrucciones Técnicas Complementarias, las ITC, como sus ramas. El tronco, el articulado, dice lo que vale para todos; cada rama baja al detalle de su tipo de instalación. Cuando te preguntes 'esto, ¿de dónde sale?', la respuesta casi siempre es: lo general, del tronco; el detalle, de la rama que toque. Y ojo, cumplir el Reglamento no te libra de cumplir otras normas que regulen cosas distintas sobre esa misma instalación, como las de electricidad o incendios.</a:t>
+              <a:t>N1: Cuando dudes de dónde sale una norma, ¿dónde miras?</a:t>
+            </a:r>
+          </a:p>
+          <a:p>
+            <a:r>
+              <a:t>N2: Imagina el Reglamento como el tronco de un árbol y las Instrucciones Técnicas Complementarias, las ITC, como sus ramas. El tronco, el articulado, dice lo que vale para todos. Cada rama baja al detalle de su tipo de instalación. Así, cuando te preguntes 'esto, ¿de dónde sale?', la respuesta casi siempre es: lo general, del tronco; el detalle, de la rama que toque. Y ojo, cumplir el Reglamento no te libra de cumplir otras normas que regulan cosas distintas sobre esa misma instalación, como las de electricidad o las de incendios. Esta lógica de tronco y ramas se repite en todo el curso.</a:t>
             </a:r>
           </a:p>
         </p:txBody>
@@ -1195,7 +1281,7 @@
           </a:p>
           <a:p>
             <a:r>
-              <a:t>N2: Porque un reglamento no nace solo: desarrolla lo que una ley le ordena. La Ley del sector de hidrocarburos manda en el negocio del gas, quién lo distribuye, quién lo comercializa; y la Ley de industria manda en la seguridad industrial. El Reglamento es el manual de instrucciones que baja esas dos leyes al taller, al tubo y a la llave. Si en el examen te preguntan de qué leyes cuelga, ya lo sabes: hidrocarburos e industria.</a:t>
+              <a:t>N2: Porque un reglamento no nace solo: desarrolla lo que una ley le ordena. La Ley del sector de hidrocarburos manda en el negocio del gas, quién lo distribuye y quién lo comercializa. La Ley de industria manda en la seguridad industrial. El Reglamento es el manual de instrucciones que baja esas dos leyes al taller, al tubo y a la llave. Si en el examen te preguntan de qué leyes cuelga, ya lo tienes: hidrocarburos e industria. Y fíjate en el detalle, porque las sanciones tampoco las inventa el Reglamento: te remite a esas dos leyes.</a:t>
             </a:r>
           </a:p>
         </p:txBody>
@@ -1270,7 +1356,7 @@
           </a:p>
           <a:p>
             <a:r>
-              <a:t>N2: El Reglamento cubre nueve tipos, que puedes agrupar así: la red de la calle o distribución por canalización, hasta dieciséis bar; todo el mundo del GLP, es decir las bombonas, los depósitos fijos de los chalés y las plantas de gas natural licuado; las estaciones de servicio para repostar coches a gas; las instalaciones receptoras, que son tu terreno del día a día; y los propios aparatos que queman el gas. De todas, la letra h, las receptoras, es donde vas a vivir como gasista de categoría B.</a:t>
+              <a:t>N2: El Reglamento cubre nueve tipos, que puedes agrupar así para no perderte. Uno, la red de la calle, o distribución por canalización, hasta dieciséis bar. Dos, todo el mundo del GLP: las bombonas, los depósitos fijos de los chalés y las plantas de gas natural licuado. Tres, las estaciones de servicio para repostar coches a gas. Cuatro, las instalaciones receptoras, tu terreno del día a día. Y cinco, los propios aparatos que queman el gas. De las nueve letras, la hache, las receptoras, es donde vas a vivir como gasista de categoría B.</a:t>
             </a:r>
           </a:p>
         </p:txBody>
@@ -1345,7 +1431,7 @@
           </a:p>
           <a:p>
             <a:r>
-              <a:t>N2: El truco de 'incluida o excluida' se entiende con la llave del portal. La llave de acometida es como la llave del portal que pone la compañía: no es tuya, por eso va excluida. Desde ahí hacia dentro, hasta las llaves de conexión de cada aparato, sí es tuyo, por eso van incluidas. Regla de una frase: la receptora empieza donde acaba la acometida y termina en la llave del aparato; el aparato y su latiguillo, fuera. Esto no es un tecnicismo: esa frontera marca qué tramo pruebas con la estanquidad y qué firmas en el boletín.</a:t>
+              <a:t>N2: El truco de 'incluida o excluida' se entiende con la llave del portal. La llave de acometida es como la llave del portal que pone la compañía: no es tuya, por eso va excluida. Desde ahí hacia dentro, hasta las llaves de conexión de cada aparato, sí es tuyo, por eso van incluidas. Regla de una frase: la receptora empieza donde acaba la acometida y termina en la llave del aparato; el aparato y su latiguillo, fuera. Y esto no es un tecnicismo: esa frontera marca qué tramo pruebas con la estanquidad y qué firmas en el boletín. Si dejas un tramo fuera sin probar, ahí es justo donde aparece la fuga que no viste.</a:t>
             </a:r>
           </a:p>
         </p:txBody>
@@ -1415,12 +1501,12 @@
           <a:lstStyle/>
           <a:p>
             <a:r>
-              <a:t>N1: ¿Una bombona de camping es instalación receptora?</a:t>
-            </a:r>
-          </a:p>
-          <a:p>
-            <a:r>
-              <a:t>N2: El límite de quince kilos separa la instalación del cacharro suelto. La bombona pequeña, de menos de quince kilos, con su tubo flexible a un único aparato móvil, no es instalación receptora: es camping-gas y no se legaliza como tal. Pero en cuanto pones tubería fija, varios aparatos o una bombona más grande, ya es instalación receptora y entra el Reglamento entero: certificado y prueba de estanquidad. Muchas chapuzas de campo son justo esto, una instalación fija montada como si fuera camping-gas, sin boletín y sin prueba. Ahí tienes la avería esperando.</a:t>
+              <a:t>N1: Una bombona de camping con su hornillo, ¿es instalación receptora?</a:t>
+            </a:r>
+          </a:p>
+          <a:p>
+            <a:r>
+              <a:t>N2: El límite de quince kilos separa la instalación del cacharro suelto. La bombona pequeña, de menos de quince kilos, con su tubo flexible a un único aparato móvil, no es instalación receptora: es camping-gas y no se legaliza como tal. Pero en cuanto pones tubería fija, varios aparatos o una bombona más grande, ya es instalación receptora y entra el Reglamento entero: certificado y prueba de estanquidad. Muchas chapuzas de campo son exactamente esto, una instalación fija montada como si fuera camping-gas, sin boletín y sin prueba. Ahí tienes la avería esperando a que alguien la encienda.</a:t>
             </a:r>
           </a:p>
         </p:txBody>
@@ -1495,7 +1581,7 @@
           </a:p>
           <a:p>
             <a:r>
-              <a:t>N2: No. Una instalación antigua no se rehace porque salga normativa nueva: se respeta como está, hasta que la tocas. En el momento en que la amplías o la modificas, lo que toques se pone al día. Y aunque no la toques, los controles periódicos, las inspecciones y revisiones, le caen igual. Nadie se libra del control periódico por ser antiguo. Piensa en una vivienda de hace décadas: mientras no metas mano, vive con su reglamento de origen, pero su inspección le toca igual.</a:t>
+              <a:t>N2: No. Una instalación antigua no se rehace porque salga normativa nueva: se respeta como está, hasta que la tocas. En el momento en que la amplías o la modificas, lo que toques se pone al día con la norma actual. Y aunque no la toques, los controles periódicos, las inspecciones y las revisiones, le caen igual. Nadie se libra del control periódico por ser antiguo. Piensa en una vivienda de hace décadas: mientras no metas mano, vive con su reglamento de origen, pero su inspección le toca exactamente igual que a la de al lado.</a:t>
             </a:r>
           </a:p>
         </p:txBody>
@@ -4750,7 +4836,7 @@
                 </a:solidFill>
                 <a:latin typeface="Montserrat"/>
               </a:rPr>
-              <a:t>010 / 014</a:t>
+              <a:t>010 / 015</a:t>
             </a:r>
           </a:p>
         </p:txBody>
@@ -4925,7 +5011,7 @@
                 </a:solidFill>
                 <a:latin typeface="Montserrat"/>
               </a:rPr>
-              <a:t>Instalación común: montante compartido</a:t>
+              <a:t>Instalación común: el montante compartido</a:t>
             </a:r>
           </a:p>
           <a:p>
@@ -5165,7 +5251,7 @@
                 </a:solidFill>
                 <a:latin typeface="Montserrat"/>
               </a:rPr>
-              <a:t>011 / 014</a:t>
+              <a:t>011 / 015</a:t>
             </a:r>
           </a:p>
         </p:txBody>
@@ -5372,7 +5458,7 @@
       </p:sp>
       <p:sp>
         <p:nvSpPr>
-          <p:cNvPr id="8" name="imgph" descr="IMGQ:single family house gas meter"/>
+          <p:cNvPr id="8" name="imgph" descr="IMGQ:single family house gas meter box"/>
           <p:cNvSpPr/>
           <p:nvPr/>
         </p:nvSpPr>
@@ -5458,7 +5544,7 @@
                 </a:solidFill>
                 <a:latin typeface="Montserrat"/>
               </a:rPr>
-              <a:t>single family house gas meter</a:t>
+              <a:t>single family house gas meter box</a:t>
             </a:r>
           </a:p>
         </p:txBody>
@@ -5555,7 +5641,7 @@
                 </a:solidFill>
                 <a:latin typeface="Montserrat"/>
               </a:rPr>
-              <a:t>012 / 014</a:t>
+              <a:t>012 / 015</a:t>
             </a:r>
           </a:p>
         </p:txBody>
@@ -5995,7 +6081,7 @@
                 </a:solidFill>
                 <a:latin typeface="Montserrat"/>
               </a:rPr>
-              <a:t>013 / 014</a:t>
+              <a:t>013 / 015</a:t>
             </a:r>
           </a:p>
         </p:txBody>
@@ -6195,7 +6281,7 @@
                 </a:solidFill>
                 <a:latin typeface="Montserrat"/>
               </a:rPr>
-              <a:t>3.ª familia: GLP (butano y propano)</a:t>
+              <a:t>3.ª familia: GLP, butano y propano</a:t>
             </a:r>
           </a:p>
           <a:p>
@@ -6410,7 +6496,7 @@
                 </a:solidFill>
                 <a:latin typeface="Montserrat"/>
               </a:rPr>
-              <a:t>014 / 014</a:t>
+              <a:t>014 / 015</a:t>
             </a:r>
           </a:p>
         </p:txBody>
@@ -6457,8 +6543,8 @@
         </p:nvSpPr>
         <p:spPr>
           <a:xfrm>
-            <a:off x="822960" y="640080"/>
-            <a:ext cx="10058400" cy="914400"/>
+            <a:off x="822960" y="457200"/>
+            <a:ext cx="8229600" cy="365760"/>
           </a:xfrm>
           <a:prstGeom prst="rect">
             <a:avLst/>
@@ -6472,13 +6558,13 @@
           <a:lstStyle/>
           <a:p>
             <a:r>
-              <a:rPr sz="3000" b="1" i="0">
-                <a:solidFill>
-                  <a:srgbClr val="1E2761"/>
-                </a:solidFill>
-                <a:latin typeface="Montserrat"/>
-              </a:rPr>
-              <a:t>Qué me llevo</a:t>
+              <a:rPr sz="1200" b="1" i="0">
+                <a:solidFill>
+                  <a:srgbClr val="64748B"/>
+                </a:solidFill>
+                <a:latin typeface="Montserrat"/>
+              </a:rPr>
+              <a:t>REPASO RELÁMPAGO</a:t>
             </a:r>
           </a:p>
         </p:txBody>
@@ -6491,8 +6577,8 @@
         </p:nvSpPr>
         <p:spPr>
           <a:xfrm>
-            <a:off x="822960" y="2011680"/>
-            <a:ext cx="10058400" cy="3657600"/>
+            <a:off x="822960" y="868680"/>
+            <a:ext cx="10515600" cy="914400"/>
           </a:xfrm>
           <a:prstGeom prst="rect">
             <a:avLst/>
@@ -6505,22 +6591,56 @@
           </a:bodyPr>
           <a:lstStyle/>
           <a:p>
+            <a:r>
+              <a:rPr sz="2700" b="1" i="0">
+                <a:solidFill>
+                  <a:srgbClr val="1E2761"/>
+                </a:solidFill>
+                <a:latin typeface="Montserrat"/>
+              </a:rPr>
+              <a:t>Fíjalo en treinta segundos</a:t>
+            </a:r>
+          </a:p>
+        </p:txBody>
+      </p:sp>
+      <p:sp>
+        <p:nvSpPr>
+          <p:cNvPr id="7" name="TextBox 6"/>
+          <p:cNvSpPr txBox="1"/>
+          <p:nvPr/>
+        </p:nvSpPr>
+        <p:spPr>
+          <a:xfrm>
+            <a:off x="822960" y="1920240"/>
+            <a:ext cx="4983480" cy="4206240"/>
+          </a:xfrm>
+          <a:prstGeom prst="rect">
+            <a:avLst/>
+          </a:prstGeom>
+          <a:noFill/>
+        </p:spPr>
+        <p:txBody>
+          <a:bodyPr wrap="square">
+            <a:spAutoFit/>
+          </a:bodyPr>
+          <a:lstStyle/>
+          <a:p>
             <a:pPr>
               <a:spcAft>
-                <a:spcPts val="1400"/>
+                <a:spcPts val="1000"/>
               </a:spcAft>
             </a:pPr>
             <a:r>
-              <a:rPr sz="2000" b="1" i="0">
+              <a:rPr sz="1600" b="1" i="0">
                 <a:solidFill>
                   <a:srgbClr val="2E3A80"/>
                 </a:solidFill>
                 <a:latin typeface="Montserrat"/>
               </a:rPr>
-              <a:t>✓  </a:t>
-            </a:r>
-            <a:r>
-              <a:rPr sz="2000" b="0" i="0">
+              <a:t>•  </a:t>
+            </a:r>
+            <a:r>
+              <a:rPr sz="1600" b="0" i="0">
                 <a:solidFill>
                   <a:srgbClr val="1B2330"/>
                 </a:solidFill>
@@ -6532,51 +6652,500 @@
           <a:p>
             <a:pPr>
               <a:spcAft>
-                <a:spcPts val="1400"/>
+                <a:spcPts val="1000"/>
               </a:spcAft>
             </a:pPr>
             <a:r>
-              <a:rPr sz="2000" b="1" i="0">
+              <a:rPr sz="1600" b="1" i="0">
                 <a:solidFill>
                   <a:srgbClr val="2E3A80"/>
                 </a:solidFill>
                 <a:latin typeface="Montserrat"/>
               </a:rPr>
-              <a:t>✓  </a:t>
-            </a:r>
-            <a:r>
-              <a:rPr sz="2000" b="0" i="0">
+              <a:t>•  </a:t>
+            </a:r>
+            <a:r>
+              <a:rPr sz="1600" b="0" i="0">
                 <a:solidFill>
                   <a:srgbClr val="1B2330"/>
                 </a:solidFill>
                 <a:latin typeface="Montserrat"/>
               </a:rPr>
-              <a:t>Receptora: de la acometida a la llave del aparato</a:t>
+              <a:t>Nueve tipos; la h son tus receptoras</a:t>
             </a:r>
           </a:p>
           <a:p>
             <a:pPr>
               <a:spcAft>
-                <a:spcPts val="1400"/>
+                <a:spcPts val="1000"/>
               </a:spcAft>
             </a:pPr>
             <a:r>
+              <a:rPr sz="1600" b="1" i="0">
+                <a:solidFill>
+                  <a:srgbClr val="2E3A80"/>
+                </a:solidFill>
+                <a:latin typeface="Montserrat"/>
+              </a:rPr>
+              <a:t>•  </a:t>
+            </a:r>
+            <a:r>
+              <a:rPr sz="1600" b="0" i="0">
+                <a:solidFill>
+                  <a:srgbClr val="1B2330"/>
+                </a:solidFill>
+                <a:latin typeface="Montserrat"/>
+              </a:rPr>
+              <a:t>Receptora: de acometida a llave de aparato</a:t>
+            </a:r>
+          </a:p>
+          <a:p>
+            <a:pPr>
+              <a:spcAft>
+                <a:spcPts val="1000"/>
+              </a:spcAft>
+            </a:pPr>
+            <a:r>
+              <a:rPr sz="1600" b="1" i="0">
+                <a:solidFill>
+                  <a:srgbClr val="2E3A80"/>
+                </a:solidFill>
+                <a:latin typeface="Montserrat"/>
+              </a:rPr>
+              <a:t>•  </a:t>
+            </a:r>
+            <a:r>
+              <a:rPr sz="1600" b="0" i="0">
+                <a:solidFill>
+                  <a:srgbClr val="1B2330"/>
+                </a:solidFill>
+                <a:latin typeface="Montserrat"/>
+              </a:rPr>
+              <a:t>Artículo 3: tres partes + los agentes</a:t>
+            </a:r>
+          </a:p>
+        </p:txBody>
+      </p:sp>
+      <p:sp>
+        <p:nvSpPr>
+          <p:cNvPr id="8" name="imgph" descr="IMGQ:gas pipe wall bracket detail"/>
+          <p:cNvSpPr/>
+          <p:nvPr/>
+        </p:nvSpPr>
+        <p:spPr>
+          <a:xfrm>
+            <a:off x="5806440" y="1051560"/>
+            <a:ext cx="5298947" cy="4629150"/>
+          </a:xfrm>
+          <a:prstGeom prst="roundRect">
+            <a:avLst/>
+          </a:prstGeom>
+          <a:solidFill>
+            <a:srgbClr val="F3F6FB"/>
+          </a:solidFill>
+          <a:ln w="12700">
+            <a:solidFill>
+              <a:srgbClr val="C7D2E6"/>
+            </a:solidFill>
+          </a:ln>
+          <a:effectLst/>
+        </p:spPr>
+        <p:style>
+          <a:lnRef idx="1">
+            <a:schemeClr val="accent1"/>
+          </a:lnRef>
+          <a:fillRef idx="3">
+            <a:schemeClr val="accent1"/>
+          </a:fillRef>
+          <a:effectRef idx="2">
+            <a:schemeClr val="accent1"/>
+          </a:effectRef>
+          <a:fontRef idx="minor">
+            <a:schemeClr val="lt1"/>
+          </a:fontRef>
+        </p:style>
+        <p:txBody>
+          <a:bodyPr rtlCol="0" anchor="ctr"/>
+          <a:lstStyle/>
+          <a:p>
+            <a:pPr algn="ctr"/>
+          </a:p>
+        </p:txBody>
+      </p:sp>
+      <p:sp>
+        <p:nvSpPr>
+          <p:cNvPr id="9" name="TextBox 8"/>
+          <p:cNvSpPr txBox="1"/>
+          <p:nvPr/>
+        </p:nvSpPr>
+        <p:spPr>
+          <a:xfrm>
+            <a:off x="6080760" y="2726055"/>
+            <a:ext cx="4750307" cy="1280160"/>
+          </a:xfrm>
+          <a:prstGeom prst="rect">
+            <a:avLst/>
+          </a:prstGeom>
+          <a:noFill/>
+        </p:spPr>
+        <p:txBody>
+          <a:bodyPr wrap="square">
+            <a:spAutoFit/>
+          </a:bodyPr>
+          <a:lstStyle/>
+          <a:p>
+            <a:pPr algn="ctr"/>
+            <a:r>
+              <a:rPr sz="1400" b="1" i="0">
+                <a:solidFill>
+                  <a:srgbClr val="64748B"/>
+                </a:solidFill>
+                <a:latin typeface="Montserrat"/>
+              </a:rPr>
+              <a:t>IMAGEN REALISTA</a:t>
+            </a:r>
+          </a:p>
+          <a:p>
+            <a:pPr algn="ctr"/>
+            <a:r>
+              <a:rPr sz="1100" b="0" i="1">
+                <a:solidFill>
+                  <a:srgbClr val="64748B"/>
+                </a:solidFill>
+                <a:latin typeface="Montserrat"/>
+              </a:rPr>
+              <a:t>gas pipe wall bracket detail</a:t>
+            </a:r>
+          </a:p>
+        </p:txBody>
+      </p:sp>
+    </p:spTree>
+  </p:cSld>
+  <p:clrMapOvr>
+    <a:masterClrMapping/>
+  </p:clrMapOvr>
+</p:sld>
+</file>
+
+<file path=ppt/slides/slide15.xml><?xml version="1.0" encoding="utf-8"?>
+<p:sld xmlns:a="http://schemas.openxmlformats.org/drawingml/2006/main" xmlns:p="http://schemas.openxmlformats.org/presentationml/2006/main" xmlns:r="http://schemas.openxmlformats.org/officeDocument/2006/relationships">
+  <p:cSld>
+    <p:spTree>
+      <p:nvGrpSpPr>
+        <p:cNvPr id="1" name=""/>
+        <p:cNvGrpSpPr/>
+        <p:nvPr/>
+      </p:nvGrpSpPr>
+      <p:grpSpPr/>
+      <p:sp>
+        <p:nvSpPr>
+          <p:cNvPr id="2" name="Rectangle 1"/>
+          <p:cNvSpPr/>
+          <p:nvPr/>
+        </p:nvSpPr>
+        <p:spPr>
+          <a:xfrm>
+            <a:off x="0" y="0"/>
+            <a:ext cx="12191695" cy="6858000"/>
+          </a:xfrm>
+          <a:prstGeom prst="rect">
+            <a:avLst/>
+          </a:prstGeom>
+          <a:solidFill>
+            <a:srgbClr val="1E2761"/>
+          </a:solidFill>
+          <a:ln>
+            <a:noFill/>
+          </a:ln>
+          <a:effectLst/>
+        </p:spPr>
+        <p:style>
+          <a:lnRef idx="1">
+            <a:schemeClr val="accent1"/>
+          </a:lnRef>
+          <a:fillRef idx="3">
+            <a:schemeClr val="accent1"/>
+          </a:fillRef>
+          <a:effectRef idx="2">
+            <a:schemeClr val="accent1"/>
+          </a:effectRef>
+          <a:fontRef idx="minor">
+            <a:schemeClr val="lt1"/>
+          </a:fontRef>
+        </p:style>
+        <p:txBody>
+          <a:bodyPr rtlCol="0" anchor="ctr"/>
+          <a:lstStyle/>
+          <a:p>
+            <a:pPr algn="ctr"/>
+          </a:p>
+        </p:txBody>
+      </p:sp>
+      <p:sp>
+        <p:nvSpPr>
+          <p:cNvPr id="3" name="TextBox 2"/>
+          <p:cNvSpPr txBox="1"/>
+          <p:nvPr/>
+        </p:nvSpPr>
+        <p:spPr>
+          <a:xfrm>
+            <a:off x="822960" y="640080"/>
+            <a:ext cx="10515600" cy="457200"/>
+          </a:xfrm>
+          <a:prstGeom prst="rect">
+            <a:avLst/>
+          </a:prstGeom>
+          <a:noFill/>
+        </p:spPr>
+        <p:txBody>
+          <a:bodyPr wrap="square">
+            <a:spAutoFit/>
+          </a:bodyPr>
+          <a:lstStyle/>
+          <a:p>
+            <a:r>
+              <a:rPr sz="1400" b="1" i="0">
+                <a:solidFill>
+                  <a:srgbClr val="CADCFC"/>
+                </a:solidFill>
+                <a:latin typeface="Montserrat"/>
+              </a:rPr>
+              <a:t>LO QUE YA DOMINAS</a:t>
+            </a:r>
+          </a:p>
+        </p:txBody>
+      </p:sp>
+      <p:sp>
+        <p:nvSpPr>
+          <p:cNvPr id="4" name="TextBox 3"/>
+          <p:cNvSpPr txBox="1"/>
+          <p:nvPr/>
+        </p:nvSpPr>
+        <p:spPr>
+          <a:xfrm>
+            <a:off x="822960" y="1143000"/>
+            <a:ext cx="10515600" cy="1097280"/>
+          </a:xfrm>
+          <a:prstGeom prst="rect">
+            <a:avLst/>
+          </a:prstGeom>
+          <a:noFill/>
+        </p:spPr>
+        <p:txBody>
+          <a:bodyPr wrap="square">
+            <a:spAutoFit/>
+          </a:bodyPr>
+          <a:lstStyle/>
+          <a:p>
+            <a:r>
+              <a:rPr sz="3400" b="1" i="0">
+                <a:solidFill>
+                  <a:srgbClr val="FFFFFF"/>
+                </a:solidFill>
+                <a:latin typeface="Montserrat"/>
+              </a:rPr>
+              <a:t>Ya sabes de dónde sale cada norma</a:t>
+            </a:r>
+          </a:p>
+        </p:txBody>
+      </p:sp>
+      <p:sp>
+        <p:nvSpPr>
+          <p:cNvPr id="5" name="TextBox 4"/>
+          <p:cNvSpPr txBox="1"/>
+          <p:nvPr/>
+        </p:nvSpPr>
+        <p:spPr>
+          <a:xfrm>
+            <a:off x="822960" y="2514600"/>
+            <a:ext cx="10515600" cy="2834640"/>
+          </a:xfrm>
+          <a:prstGeom prst="rect">
+            <a:avLst/>
+          </a:prstGeom>
+          <a:noFill/>
+        </p:spPr>
+        <p:txBody>
+          <a:bodyPr wrap="square">
+            <a:spAutoFit/>
+          </a:bodyPr>
+          <a:lstStyle/>
+          <a:p>
+            <a:pPr>
+              <a:spcAft>
+                <a:spcPts val="1200"/>
+              </a:spcAft>
+            </a:pPr>
+            <a:r>
               <a:rPr sz="2000" b="1" i="0">
                 <a:solidFill>
-                  <a:srgbClr val="2E3A80"/>
+                  <a:srgbClr val="CADCFC"/>
                 </a:solidFill>
                 <a:latin typeface="Montserrat"/>
               </a:rPr>
               <a:t>✓  </a:t>
             </a:r>
             <a:r>
-              <a:rPr sz="2000" b="0" i="0">
-                <a:solidFill>
-                  <a:srgbClr val="1B2330"/>
-                </a:solidFill>
-                <a:latin typeface="Montserrat"/>
-              </a:rPr>
-              <a:t>Artículo 3 = diccionario del oficio</a:t>
+              <a:rPr sz="1900" b="0" i="0">
+                <a:solidFill>
+                  <a:srgbClr val="FFFFFF"/>
+                </a:solidFill>
+                <a:latin typeface="Montserrat"/>
+              </a:rPr>
+              <a:t>Colocas cualquier norma: tronco o rama</a:t>
+            </a:r>
+          </a:p>
+          <a:p>
+            <a:pPr>
+              <a:spcAft>
+                <a:spcPts val="1200"/>
+              </a:spcAft>
+            </a:pPr>
+            <a:r>
+              <a:rPr sz="2000" b="1" i="0">
+                <a:solidFill>
+                  <a:srgbClr val="CADCFC"/>
+                </a:solidFill>
+                <a:latin typeface="Montserrat"/>
+              </a:rPr>
+              <a:t>✓  </a:t>
+            </a:r>
+            <a:r>
+              <a:rPr sz="1900" b="0" i="0">
+                <a:solidFill>
+                  <a:srgbClr val="FFFFFF"/>
+                </a:solidFill>
+                <a:latin typeface="Montserrat"/>
+              </a:rPr>
+              <a:t>Marcas tu receptora con una sola frontera</a:t>
+            </a:r>
+          </a:p>
+          <a:p>
+            <a:pPr>
+              <a:spcAft>
+                <a:spcPts val="1200"/>
+              </a:spcAft>
+            </a:pPr>
+            <a:r>
+              <a:rPr sz="2000" b="1" i="0">
+                <a:solidFill>
+                  <a:srgbClr val="CADCFC"/>
+                </a:solidFill>
+                <a:latin typeface="Montserrat"/>
+              </a:rPr>
+              <a:t>✓  </a:t>
+            </a:r>
+            <a:r>
+              <a:rPr sz="1900" b="0" i="0">
+                <a:solidFill>
+                  <a:srgbClr val="FFFFFF"/>
+                </a:solidFill>
+                <a:latin typeface="Montserrat"/>
+              </a:rPr>
+              <a:t>Separas tuberías de personas sin trampa</a:t>
+            </a:r>
+          </a:p>
+          <a:p>
+            <a:pPr>
+              <a:spcAft>
+                <a:spcPts val="1200"/>
+              </a:spcAft>
+            </a:pPr>
+            <a:r>
+              <a:rPr sz="2000" b="1" i="0">
+                <a:solidFill>
+                  <a:srgbClr val="CADCFC"/>
+                </a:solidFill>
+                <a:latin typeface="Montserrat"/>
+              </a:rPr>
+              <a:t>✓  </a:t>
+            </a:r>
+            <a:r>
+              <a:rPr sz="1900" b="0" i="0">
+                <a:solidFill>
+                  <a:srgbClr val="FFFFFF"/>
+                </a:solidFill>
+                <a:latin typeface="Montserrat"/>
+              </a:rPr>
+              <a:t>El artículo 3 ya es tu diccionario</a:t>
+            </a:r>
+          </a:p>
+        </p:txBody>
+      </p:sp>
+      <p:sp>
+        <p:nvSpPr>
+          <p:cNvPr id="6" name="Rounded Rectangle 5"/>
+          <p:cNvSpPr/>
+          <p:nvPr/>
+        </p:nvSpPr>
+        <p:spPr>
+          <a:xfrm>
+            <a:off x="822960" y="5532120"/>
+            <a:ext cx="10515600" cy="777240"/>
+          </a:xfrm>
+          <a:prstGeom prst="roundRect">
+            <a:avLst/>
+          </a:prstGeom>
+          <a:solidFill>
+            <a:srgbClr val="2E3A80"/>
+          </a:solidFill>
+          <a:ln>
+            <a:noFill/>
+          </a:ln>
+          <a:effectLst/>
+        </p:spPr>
+        <p:style>
+          <a:lnRef idx="1">
+            <a:schemeClr val="accent1"/>
+          </a:lnRef>
+          <a:fillRef idx="3">
+            <a:schemeClr val="accent1"/>
+          </a:fillRef>
+          <a:effectRef idx="2">
+            <a:schemeClr val="accent1"/>
+          </a:effectRef>
+          <a:fontRef idx="minor">
+            <a:schemeClr val="lt1"/>
+          </a:fontRef>
+        </p:style>
+        <p:txBody>
+          <a:bodyPr rtlCol="0" anchor="ctr"/>
+          <a:lstStyle/>
+          <a:p>
+            <a:pPr algn="ctr"/>
+          </a:p>
+        </p:txBody>
+      </p:sp>
+      <p:sp>
+        <p:nvSpPr>
+          <p:cNvPr id="7" name="TextBox 6"/>
+          <p:cNvSpPr txBox="1"/>
+          <p:nvPr/>
+        </p:nvSpPr>
+        <p:spPr>
+          <a:xfrm>
+            <a:off x="1051560" y="5605272"/>
+            <a:ext cx="10058400" cy="640080"/>
+          </a:xfrm>
+          <a:prstGeom prst="rect">
+            <a:avLst/>
+          </a:prstGeom>
+          <a:noFill/>
+        </p:spPr>
+        <p:txBody>
+          <a:bodyPr wrap="square">
+            <a:spAutoFit/>
+          </a:bodyPr>
+          <a:lstStyle/>
+          <a:p>
+            <a:r>
+              <a:rPr sz="1500" b="1" i="1">
+                <a:solidFill>
+                  <a:srgbClr val="CADCFC"/>
+                </a:solidFill>
+                <a:latin typeface="Montserrat"/>
+              </a:rPr>
+              <a:t>Hoy ya eres más gasista que ayer. Vamos a por los materiales y el gas.</a:t>
             </a:r>
           </a:p>
         </p:txBody>
@@ -6673,7 +7242,7 @@
                 </a:solidFill>
                 <a:latin typeface="Montserrat"/>
               </a:rPr>
-              <a:t>002 / 014</a:t>
+              <a:t>002 / 015</a:t>
             </a:r>
           </a:p>
         </p:txBody>
@@ -7186,7 +7755,7 @@
                 </a:solidFill>
                 <a:latin typeface="Montserrat"/>
               </a:rPr>
-              <a:t>003 / 014</a:t>
+              <a:t>003 / 015</a:t>
             </a:r>
           </a:p>
         </p:txBody>
@@ -7288,7 +7857,7 @@
                 </a:solidFill>
                 <a:latin typeface="Montserrat"/>
               </a:rPr>
-              <a:t>¿Qué es el Reglamento de Gas?</a:t>
+              <a:t>¿Para qué existe el Reglamento?</a:t>
             </a:r>
           </a:p>
         </p:txBody>
@@ -7576,7 +8145,7 @@
                 </a:solidFill>
                 <a:latin typeface="Montserrat"/>
               </a:rPr>
-              <a:t>004 / 014</a:t>
+              <a:t>004 / 015</a:t>
             </a:r>
           </a:p>
         </p:txBody>
@@ -7678,7 +8247,7 @@
                 </a:solidFill>
                 <a:latin typeface="Montserrat"/>
               </a:rPr>
-              <a:t>Tronco y ramas</a:t>
+              <a:t>El tronco y las ramas</a:t>
             </a:r>
           </a:p>
         </p:txBody>
@@ -7783,7 +8352,7 @@
       </p:sp>
       <p:sp>
         <p:nvSpPr>
-          <p:cNvPr id="8" name="imgph" descr="IMGQ:large tree trunk branches"/>
+          <p:cNvPr id="8" name="imgph" descr="IMGQ:large tree trunk branches sky"/>
           <p:cNvSpPr/>
           <p:nvPr/>
         </p:nvSpPr>
@@ -7869,7 +8438,7 @@
                 </a:solidFill>
                 <a:latin typeface="Montserrat"/>
               </a:rPr>
-              <a:t>large tree trunk branches</a:t>
+              <a:t>large tree trunk branches sky</a:t>
             </a:r>
           </a:p>
         </p:txBody>
@@ -7966,7 +8535,7 @@
                 </a:solidFill>
                 <a:latin typeface="Montserrat"/>
               </a:rPr>
-              <a:t>005 / 014</a:t>
+              <a:t>005 / 015</a:t>
             </a:r>
           </a:p>
         </p:txBody>
@@ -8173,7 +8742,7 @@
       </p:sp>
       <p:sp>
         <p:nvSpPr>
-          <p:cNvPr id="8" name="imgph" descr="IMGQ:law books gavel desk"/>
+          <p:cNvPr id="8" name="imgph" descr="IMGQ:law books stacked wooden desk"/>
           <p:cNvSpPr/>
           <p:nvPr/>
         </p:nvSpPr>
@@ -8259,7 +8828,7 @@
                 </a:solidFill>
                 <a:latin typeface="Montserrat"/>
               </a:rPr>
-              <a:t>law books gavel desk</a:t>
+              <a:t>law books stacked wooden desk</a:t>
             </a:r>
           </a:p>
         </p:txBody>
@@ -8356,7 +8925,7 @@
                 </a:solidFill>
                 <a:latin typeface="Montserrat"/>
               </a:rPr>
-              <a:t>006 / 014</a:t>
+              <a:t>006 / 015</a:t>
             </a:r>
           </a:p>
         </p:txBody>
@@ -8531,7 +9100,7 @@
                 </a:solidFill>
                 <a:latin typeface="Montserrat"/>
               </a:rPr>
-              <a:t>Almacenamiento de GLP: envases, depósitos, GNL</a:t>
+              <a:t>GLP: envases, depósitos fijos, GNL</a:t>
             </a:r>
           </a:p>
           <a:p>
@@ -8613,7 +9182,7 @@
       </p:sp>
       <p:sp>
         <p:nvSpPr>
-          <p:cNvPr id="8" name="imgph" descr="IMGQ:gas meter cabinet street"/>
+          <p:cNvPr id="8" name="imgph" descr="IMGQ:gas meter cabinet building street"/>
           <p:cNvSpPr/>
           <p:nvPr/>
         </p:nvSpPr>
@@ -8699,7 +9268,7 @@
                 </a:solidFill>
                 <a:latin typeface="Montserrat"/>
               </a:rPr>
-              <a:t>gas meter cabinet street</a:t>
+              <a:t>gas meter cabinet building street</a:t>
             </a:r>
           </a:p>
         </p:txBody>
@@ -8796,7 +9365,7 @@
                 </a:solidFill>
                 <a:latin typeface="Montserrat"/>
               </a:rPr>
-              <a:t>007 / 014</a:t>
+              <a:t>007 / 015</a:t>
             </a:r>
           </a:p>
         </p:txBody>
@@ -8898,7 +9467,7 @@
                 </a:solidFill>
                 <a:latin typeface="Montserrat"/>
               </a:rPr>
-              <a:t>¿Dónde empieza y acaba?</a:t>
+              <a:t>¿Dónde empieza y dónde acaba?</a:t>
             </a:r>
           </a:p>
         </p:txBody>
@@ -9021,14 +9590,14 @@
                 </a:solidFill>
                 <a:latin typeface="Montserrat"/>
               </a:rPr>
-              <a:t>Incluida/excluida = de qué respondes</a:t>
-            </a:r>
-          </a:p>
-        </p:txBody>
-      </p:sp>
-      <p:sp>
-        <p:nvSpPr>
-          <p:cNvPr id="8" name="imgph" descr="IMGQ:gas shut off valve pipe"/>
+              <a:t>Incluida/excluida decide de qué respondes</a:t>
+            </a:r>
+          </a:p>
+        </p:txBody>
+      </p:sp>
+      <p:sp>
+        <p:nvSpPr>
+          <p:cNvPr id="8" name="imgph" descr="IMGQ:gas shut off valve copper pipe"/>
           <p:cNvSpPr/>
           <p:nvPr/>
         </p:nvSpPr>
@@ -9114,7 +9683,7 @@
                 </a:solidFill>
                 <a:latin typeface="Montserrat"/>
               </a:rPr>
-              <a:t>gas shut off valve pipe</a:t>
+              <a:t>gas shut off valve copper pipe</a:t>
             </a:r>
           </a:p>
         </p:txBody>
@@ -9211,7 +9780,7 @@
                 </a:solidFill>
                 <a:latin typeface="Montserrat"/>
               </a:rPr>
-              <a:t>008 / 014</a:t>
+              <a:t>008 / 015</a:t>
             </a:r>
           </a:p>
         </p:txBody>
@@ -9279,7 +9848,7 @@
                 </a:solidFill>
                 <a:latin typeface="Montserrat"/>
               </a:rPr>
-              <a:t>ARTÍCULO 2 · EL LÍMITE DE LOS 15 KG</a:t>
+              <a:t>ARTÍCULO 2 · EL LÍMITE DE 15 KG</a:t>
             </a:r>
           </a:p>
         </p:txBody>
@@ -9411,7 +9980,7 @@
                 </a:solidFill>
                 <a:latin typeface="Montserrat"/>
               </a:rPr>
-              <a:t>Dentro = boletín y estanquidad</a:t>
+              <a:t>Dentro = boletín y prueba de estanquidad</a:t>
             </a:r>
           </a:p>
         </p:txBody>
@@ -9601,7 +10170,7 @@
                 </a:solidFill>
                 <a:latin typeface="Montserrat"/>
               </a:rPr>
-              <a:t>009 / 014</a:t>
+              <a:t>009 / 015</a:t>
             </a:r>
           </a:p>
         </p:txBody>
@@ -9801,14 +10370,14 @@
                 </a:solidFill>
                 <a:latin typeface="Montserrat"/>
               </a:rPr>
-              <a:t>Controles periódicos: a todas</a:t>
-            </a:r>
-          </a:p>
-        </p:txBody>
-      </p:sp>
-      <p:sp>
-        <p:nvSpPr>
-          <p:cNvPr id="8" name="imgph" descr="IMGQ:old gas pipe wall building"/>
+              <a:t>Controles periódicos: a todas, sin excepción</a:t>
+            </a:r>
+          </a:p>
+        </p:txBody>
+      </p:sp>
+      <p:sp>
+        <p:nvSpPr>
+          <p:cNvPr id="8" name="imgph" descr="IMGQ:old gas pipe brick wall"/>
           <p:cNvSpPr/>
           <p:nvPr/>
         </p:nvSpPr>
@@ -9894,7 +10463,7 @@
                 </a:solidFill>
                 <a:latin typeface="Montserrat"/>
               </a:rPr>
-              <a:t>old gas pipe wall building</a:t>
+              <a:t>old gas pipe brick wall</a:t>
             </a:r>
           </a:p>
         </p:txBody>

</xml_diff>

<commit_message>
FASE 2 COMPLETA: 49 PowerPoints (829 diapositivas) dialogos N1/N2 educativos + cierre apoteosico
- Plantilla exacta, texto corto en pantalla, notas N1/N2 autodidactas y comprensibles
- Cierre gran final (navy + tagline + conclusion explicada, examen/obra, puente)
- 682 marcos de imagen etiquetados para el script local de fotos
- Verificado 49/49: abren, notas N1/N2 en todas, sin incidencias

Co-Authored-By: Claude Opus 4.8 <noreply@anthropic.com>
Claude-Session: https://claude.ai/code/session_01UvCPDpSUkU2UKG6kCugktD
</commit_message>
<xml_diff>
--- a/Curso Gas B/00 - El Reglamento de Gas - estructura, ambito y generalidades/00 - El Reglamento de Gas - Vídeo 1.pptx
+++ b/Curso Gas B/00 - El Reglamento de Gas - estructura, ambito y generalidades/00 - El Reglamento de Gas - Vídeo 1.pptx
@@ -521,7 +521,7 @@
           </a:p>
           <a:p>
             <a:r>
-              <a:t>N2: Manda un único texto: el Reglamento técnico de distribución y utilización de combustibles gaseosos, el famoso Real Decreto novecientos diecinueve. Todo tu oficio se apoya en él. En este primer vídeo vemos para qué sirve, a qué instalaciones se aplica y, sobre todo, el vocabulario exacto con el que vas a trabajar. Domina estas definiciones y tienes media asignatura ganada, porque son las palabras que aparecen en el boletín, en el examen y en cada avería que pises.</a:t>
+              <a:t>N2: Manda un único texto: el Reglamento técnico de distribución y utilización de combustibles gaseosos, el famoso Real Decreto novecientos diecinueve. Todo tu oficio se apoya en él, así que empezamos por la base. En este primer vídeo vemos tres cosas: para qué sirve, a qué instalaciones se aplica y, la más importante, el vocabulario exacto con el que vas a trabajar. Y te adelanto una idea que te va a ahorrar mucho tiempo: quien domina estas definiciones tiene media asignatura ganada, porque son las mismas palabras que luego aparecen en el boletín que firmas, en la pregunta del examen y en cada avería que pises.</a:t>
             </a:r>
           </a:p>
         </p:txBody>
@@ -591,12 +591,12 @@
           <a:lstStyle/>
           <a:p>
             <a:r>
-              <a:t>N1: ¿Cómo colocas los tres tramos sin equivocarte nunca?</a:t>
-            </a:r>
-          </a:p>
-          <a:p>
-            <a:r>
-              <a:t>N2: El gas entra y va pasando por tres tramos encajados, siempre en el mismo orden, como muñecas rusas. Primero la acometida interior, de la calle al edificio. Luego la instalación común, el montante que sube por el edificio y es compartido por los vecinos. Y por último la instalación individual, lo que entra en cada vivienda hasta cada aparato. Cada tramo empieza justo donde acaba el anterior. Si te imaginas el gas subiendo por la escalera y entrando en tu piso, colocas los tres tramos sin fallar. Y saber en qué tramo estás decide quién lo mantiene y quién lo inspecciona.</a:t>
+              <a:t>N1: ¿Cómo coloco los tres tramos sin equivocarme nunca?</a:t>
+            </a:r>
+          </a:p>
+          <a:p>
+            <a:r>
+              <a:t>N2: Imagínate el gas entrando en un edificio y avanzando por tres tramos encajados, siempre en el mismo orden, como muñecas rusas que salen una de otra. Primero, la acometida interior, que va de la calle al edificio. Después, la instalación común, que es el montante que sube por el edificio y lo comparten los vecinos. Y por último, la instalación individual, lo que entra en cada vivienda y llega hasta cada aparato. La clave es que cada tramo empieza justo donde acaba el anterior, sin huecos ni solapes. Si te imaginas el gas subiendo por la escalera y entrando en tu piso, colocas los tres tramos sin fallar. Y esto sirve para algo muy práctico: saber en qué tramo estás decide quién lo mantiene y quién lo inspecciona, que no siempre es la misma persona.</a:t>
             </a:r>
           </a:p>
         </p:txBody>
@@ -671,7 +671,7 @@
           </a:p>
           <a:p>
             <a:r>
-              <a:t>N2: No siempre. La propia definición dice 'en su caso más general', porque no todas las instalaciones tienen los tres. En una vivienda unifamiliar, un chalé con el contador en la valla, no hay instalación común ni acometida interior: va casi todo directo a la instalación individual. Así que no te agobies si en una instalación real falta un tramo; es completamente normal y no es un error. Lo importante es reconocer qué tramo tienes delante para saber qué le corresponde y qué papel te toca firmar.</a:t>
+              <a:t>N2: No siempre, y es normal que falte alguno. Fíjate en que la propia definición dice 'en su caso más general', y esa coletilla es una pista: significa que no todas las instalaciones tienen los tres tramos. En una vivienda unifamiliar, un chalé con el contador en la valla, no hay instalación común ni acometida interior; va casi todo directo a la instalación individual. Así que no te agobies si en una instalación real echas en falta un tramo, no es un error, es un caso más sencillo. Lo importante, y lo que de verdad te van a exigir, es reconocer qué tramo tienes delante para saber qué le corresponde y qué papel te toca firmar a ti.</a:t>
             </a:r>
           </a:p>
         </p:txBody>
@@ -741,12 +741,12 @@
           <a:lstStyle/>
           <a:p>
             <a:r>
-              <a:t>N1: ¿Sabrías separar quién hace qué en una instalación?</a:t>
-            </a:r>
-          </a:p>
-          <a:p>
-            <a:r>
-              <a:t>N2: La otra mitad del diccionario son las personas, los agentes, y aquí está la trampa clásica del examen. Ata cabos: el fabricante hace el producto. La empresa instaladora, que es la razón social, monta y certifica. El instalador, la persona con carné, ejecuta. El distribuidor lleva el gas por la red. El comercializador te lo vende. El titular es el dueño que responde del mantenimiento y el usuario es el que lo gasta. Si separas 'tuberías' de 'personas', las preguntas cruzadas dejan de tener trampa, y en obra sabes exactamente a quién firmas y a quién avisas.</a:t>
+              <a:t>N1: ¿Sabría separar quién hace qué en una instalación?</a:t>
+            </a:r>
+          </a:p>
+          <a:p>
+            <a:r>
+              <a:t>N2: Aquí está la otra mitad del diccionario y la trampa clásica del examen: hasta ahora hablábamos de tuberías, ahora hablamos de personas, los agentes. Vamos a atar cabos uno a uno. El fabricante hace el producto. La empresa instaladora, que es la razón social, la empresa, monta y certifica. El instalador, que es la persona con carné, es quien ejecuta el trabajo. El distribuidor lleva el gas por la red de la calle. El comercializador es quien te lo vende, con quien tienes el contrato. El titular es el dueño, que responde del mantenimiento, y el usuario es simplemente quien lo gasta. El truco para no fallar es mental: separa siempre 'tuberías' de 'personas'. Cuando el examen te cruce una parte con un agente para liarte, tú ya sabes que son dos listas distintas. Y en obra esto es oro: sabes exactamente a quién firmas y a quién tienes que avisar.</a:t>
             </a:r>
           </a:p>
         </p:txBody>
@@ -821,7 +821,7 @@
           </a:p>
           <a:p>
             <a:r>
-              <a:t>N2: Los combustibles gaseosos se clasifican en tres familias por cómo queman. La primera son los gases manufacturados y el aire propanado, casi en desuso. La segunda es el gas natural, el de la ciudad. Y la tercera es el GLP, butano y propano. Esto no es un dato de relleno: cada aparato está tarado para su gas y su presión. Meterle un gas de otra familia, o a otra presión, da mala combustión, llama amarilla, ennegrecido y monóxido de carbono. Aquí solo los clasificas; el ajuste vendrá más adelante, pero recuerda que la causa de media avería de combustión empieza por confundir la familia.</a:t>
+              <a:t>N2: Es la forma de clasificar los combustibles gaseosos según cómo queman, y son tres familias. La primera son los gases manufacturados y el aire propanado, que hoy están casi en desuso. La segunda es el gas natural, el de la ciudad, el que llega por la tubería de la calle. Y la tercera es el GLP, es decir butano y propano. Esto no es un dato de relleno, atento a por qué importa: cada aparato viene tarado, ajustado, para su gas y su presión. Si le metes un gas de otra familia, o a otra presión, la combustión se estropea y aparece la llama amarilla, el ennegrecido y, lo peligroso, el monóxido de carbono. Aquí solo aprendes a clasificarlos; el ajuste fino vendrá más adelante en el curso. Pero grábate la idea: la causa de media avería de combustión empieza por confundir la familia de gas.</a:t>
             </a:r>
           </a:p>
         </p:txBody>
@@ -891,12 +891,12 @@
           <a:lstStyle/>
           <a:p>
             <a:r>
-              <a:t>N1: Cerramos con un repaso rápido. ¿Te suenan ya los cuatro pilares?</a:t>
-            </a:r>
-          </a:p>
-          <a:p>
-            <a:r>
-              <a:t>N2: Uno, tronco y ramas: lo general en el Reglamento, el detalle en cada ITC. Dos, nueve tipos de instalación, y la letra hache, las receptoras, es tu terreno. Tres, la receptora va de la llave de acometida, excluida, a la llave del aparato, incluida. Y cuatro, el artículo tercero es tu diccionario: separa las tres partes encajadas de las personas del oficio. Si eres capaz de recitar estos cuatro puntos de carrerilla, tienes el vídeo dominado. Repítelos en voz alta una vez antes de seguir.</a:t>
+              <a:t>N1: Cerramos con un repaso rápido. ¿Me suenan ya los cuatro pilares?</a:t>
+            </a:r>
+          </a:p>
+          <a:p>
+            <a:r>
+              <a:t>N2: Vamos a fijarlos en treinta segundos, y te propongo que los repitas en voz alta conmigo. Uno, tronco y ramas: lo general vive en el Reglamento, el detalle en cada ITC. Dos, nueve tipos de instalación, y la letra hache, las receptoras, es tu terreno. Tres, la receptora va de la llave de acometida, que va excluida, a la llave del aparato, que va incluida. Y cuatro, el artículo tercero es tu diccionario, y tiene dos mitades: las tres partes encajadas por un lado y las personas del oficio por otro. Si eres capaz de recitar estos cuatro puntos de carrerilla, tienes el vídeo dominado. Hazlo una vez en voz alta antes de seguir, que lo que se dice se recuerda mejor que lo que solo se lee.</a:t>
             </a:r>
           </a:p>
         </p:txBody>
@@ -966,12 +966,12 @@
           <a:lstStyle/>
           <a:p>
             <a:r>
-              <a:t>N1: Cerramos fuerte. Si te quedas con lo esencial, ¿qué has conquistado hoy?</a:t>
-            </a:r>
-          </a:p>
-          <a:p>
-            <a:r>
-              <a:t>N2: Tres logros que ya son tuyos. Uno: sabes colocar cualquier norma en su sitio, lo general en el tronco del Reglamento y el detalle en la rama de su ITC. Dos: marcas la frontera de tu instalación receptora con una sola frase, de la llave de acometida excluida a la llave del aparato incluida, y con eso ya sabes qué pruebas y qué firmas. Y tres: el artículo tercero ha dejado de ser una lista para convertirse en tu diccionario, con las tres partes encajadas por un lado y las personas del oficio por otro.</a:t>
+              <a:t>N1: Cerramos fuerte. Si me quedo con lo esencial, ¿qué he conquistado hoy?</a:t>
+            </a:r>
+          </a:p>
+          <a:p>
+            <a:r>
+              <a:t>N2: Reconstruyamos el hilo, porque cada pieza encaja con la anterior. Empezaste sabiendo para qué existe el Reglamento: proteger a las personas, y por eso todo se decide hacia el lado más seguro. De ahí saliste con tu primer logro: colocar cualquier norma en su sitio, lo general en el tronco y el detalle en la rama de su ITC. Luego marcaste la frontera de tu instalación receptora con una sola frase, de la llave de acometida excluida a la llave del aparato incluida, y con esa frontera ya sabes qué pruebas y qué firmas. Y por último convertiste el artículo tercero en tu diccionario, separando las tres partes encajadas de las personas del oficio.</a:t>
             </a:r>
           </a:p>
           <a:p>
@@ -981,7 +981,7 @@
           </a:p>
           <a:p>
             <a:r>
-              <a:t>N2: Porque en el examen te lo preguntan cruzado: te mezclan una parte con un agente, o te ponen una bombona de camping a ver si la cuelas como receptora. Y en la obra decide quién firma el boletín y de qué tramo respondes. Confundir la frontera es dejar un tramo sin probar, y ahí aparece la fuga. Hoy ya eres más gasista que ayer. En el siguiente vídeo damos el salto al día a día: los materiales y el camino completo desde que terminas la instalación hasta que tiene gas. Te espero allí.</a:t>
+              <a:t>N2: En el examen te lo van a preguntar cruzado, a mala idea: te mezclan una parte con un agente, o te cuelan una bombona de camping a ver si la clasificas como receptora. Como tú ya separas tuberías de personas y conoces el límite de los quince kilos, no caes. Y en la obra decide cosas serias: quién firma el boletín y de qué tramo respondes tú. Equivocarte de frontera es dejar un tramo sin probar, y ahí es donde aparece la fuga. Así que hoy no has memorizado, has entendido, y eso ya te hace más gasista que ayer. En el siguiente vídeo damos el salto al día a día de verdad: los materiales que puedes usar y el camino completo desde que terminas una instalación hasta que tiene gas. Te espero allí.</a:t>
             </a:r>
           </a:p>
         </p:txBody>
@@ -1051,12 +1051,12 @@
           <a:lstStyle/>
           <a:p>
             <a:r>
-              <a:t>N1: ¿Qué tres números te dan el esqueleto del vídeo?</a:t>
-            </a:r>
-          </a:p>
-          <a:p>
-            <a:r>
-              <a:t>N2: Nueve tipos de instalación que el Reglamento mete bajo su paraguas, desde la red de la calle hasta el aparato. Tres partes en las que se divide la instalación receptora, que es tu terreno del día a día. Y veinticuatro definiciones en el artículo tercero, el diccionario del oficio. Si retienes estos tres bloques, ya sabes qué se regula, cuál es tu zona y con qué palabras se nombra todo. Lo demás cuelga de aquí.</a:t>
+              <a:t>N1: ¿Qué tres números me dan el esqueleto del vídeo?</a:t>
+            </a:r>
+          </a:p>
+          <a:p>
+            <a:r>
+              <a:t>N2: Fíjate en estos tres y no te perderás. Nueve tipos de instalación que el Reglamento mete bajo su paraguas, desde la red de la calle hasta el aparato de tu cocina. Tres partes en las que se divide la instalación receptora, que es tu terreno del día a día. Y veinticuatro definiciones en el artículo tercero, que es, ni más ni menos, el diccionario del oficio. Si retienes estos tres bloques ya sabes qué se regula, cuál es tu zona de trabajo y con qué palabras se nombra todo. El resto del vídeo, y buena parte del curso, cuelga de aquí.</a:t>
             </a:r>
           </a:p>
         </p:txBody>
@@ -1126,12 +1126,12 @@
           <a:lstStyle/>
           <a:p>
             <a:r>
-              <a:t>N1: Si tuvieras que resumir en una frase para qué existe este Reglamento, ¿qué dirías?</a:t>
-            </a:r>
-          </a:p>
-          <a:p>
-            <a:r>
-              <a:t>N2: Su objeto es fijar las condiciones técnicas y las garantías que deben reunir las instalaciones de gas y los aparatos que lo queman, con una única finalidad de fondo: preservar la seguridad de las personas y los bienes. Todo lo demás, cada distancia, cada prueba, cada certificado, cuelga de esa idea. Cuando en obra dudes si algo se hace de una manera o de otra, la brújula es siempre la misma: la opción más segura para quien vive ahí. Por ejemplo, ante una ventilación justita, el Reglamento tira siempre a proteger al usuario.</a:t>
+              <a:t>N1: Si tuviera que resumir en una frase para qué existe este Reglamento, ¿qué diría?</a:t>
+            </a:r>
+          </a:p>
+          <a:p>
+            <a:r>
+              <a:t>N2: Piénsalo así: su objeto es fijar las condiciones técnicas y las garantías que deben reunir las instalaciones de gas y los aparatos que lo queman, con una única finalidad de fondo, que es proteger la seguridad de las personas y los bienes. Quédate con esa palabra, seguridad, porque es la brújula de todo. Cada distancia, cada prueba y cada certificado que verás en el curso nace de ahí. ¿Por qué importa esto en obra? Porque cuando dudes entre hacer algo de una manera o de otra, la respuesta correcta es casi siempre la más segura para quien vive en esa casa. Un ejemplo del día a día: ante una ventilación justita, el Reglamento nunca tira a lo cómodo, tira a proteger al usuario.</a:t>
             </a:r>
           </a:p>
         </p:txBody>
@@ -1201,12 +1201,12 @@
           <a:lstStyle/>
           <a:p>
             <a:r>
-              <a:t>N1: Cuando dudes de dónde sale una norma, ¿dónde miras?</a:t>
-            </a:r>
-          </a:p>
-          <a:p>
-            <a:r>
-              <a:t>N2: Imagina el Reglamento como el tronco de un árbol y las Instrucciones Técnicas Complementarias, las ITC, como sus ramas. El tronco, el articulado, dice lo que vale para todos. Cada rama baja al detalle de su tipo de instalación. Así, cuando te preguntes 'esto, ¿de dónde sale?', la respuesta casi siempre es: lo general, del tronco; el detalle, de la rama que toque. Y ojo, cumplir el Reglamento no te libra de cumplir otras normas que regulan cosas distintas sobre esa misma instalación, como las de electricidad o las de incendios. Esta lógica de tronco y ramas se repite en todo el curso.</a:t>
+              <a:t>N1: Cuando dude de dónde sale una norma, ¿dónde miro?</a:t>
+            </a:r>
+          </a:p>
+          <a:p>
+            <a:r>
+              <a:t>N2: Usa una imagen que ya conoces: un árbol. El Reglamento es el tronco y las Instrucciones Técnicas Complementarias, que llamamos ITC, son las ramas. El tronco, que es el articulado, dice lo que vale para todos por igual. Cada rama, cada ITC, baja al detalle de un tipo concreto de instalación. Con esto tienes un método: cuando en obra te preguntes 'esto, ¿de dónde sale?', la respuesta casi siempre es lo general del tronco y el detalle de la rama que toque. Y un matiz que cae en el examen: cumplir el Reglamento no te libra de cumplir otras normas que regulan cosas distintas sobre esa misma instalación, por ejemplo las de electricidad o las de protección contra incendios. Esta lógica de tronco y ramas se repite en todo el curso, así que grábatela ya.</a:t>
             </a:r>
           </a:p>
         </p:txBody>
@@ -1281,7 +1281,7 @@
           </a:p>
           <a:p>
             <a:r>
-              <a:t>N2: Porque un reglamento no nace solo: desarrolla lo que una ley le ordena. La Ley del sector de hidrocarburos manda en el negocio del gas, quién lo distribuye y quién lo comercializa. La Ley de industria manda en la seguridad industrial. El Reglamento es el manual de instrucciones que baja esas dos leyes al taller, al tubo y a la llave. Si en el examen te preguntan de qué leyes cuelga, ya lo tienes: hidrocarburos e industria. Y fíjate en el detalle, porque las sanciones tampoco las inventa el Reglamento: te remite a esas dos leyes.</a:t>
+              <a:t>N2: Porque un reglamento nunca nace solo; siempre desarrolla lo que una ley le ordena. Aquí hay dos leyes por encima. La Ley del sector de hidrocarburos manda en el negocio del gas: quién lo distribuye, quién lo comercializa, quién lo vende. Y la Ley de industria manda en la seguridad industrial. El Reglamento es el manual de instrucciones que baja esas dos leyes al taller, al tubo y a la llave. ¿Cómo se pregunta esto? Directo: 'de qué leyes cuelga el Reglamento', y ya lo tienes, hidrocarburos e industria. Guárdate además un detalle que ató luego: las sanciones tampoco las inventa el Reglamento, te remite a estas dos leyes. Todo empieza y acaba en ellas.</a:t>
             </a:r>
           </a:p>
         </p:txBody>
@@ -1356,7 +1356,7 @@
           </a:p>
           <a:p>
             <a:r>
-              <a:t>N2: El Reglamento cubre nueve tipos, que puedes agrupar así para no perderte. Uno, la red de la calle, o distribución por canalización, hasta dieciséis bar. Dos, todo el mundo del GLP: las bombonas, los depósitos fijos de los chalés y las plantas de gas natural licuado. Tres, las estaciones de servicio para repostar coches a gas. Cuatro, las instalaciones receptoras, tu terreno del día a día. Y cinco, los propios aparatos que queman el gas. De las nueve letras, la hache, las receptoras, es donde vas a vivir como gasista de categoría B.</a:t>
+              <a:t>N2: Prácticamente todo, sí. El Reglamento cubre nueve tipos, pero no te aprendas nueve cosas sueltas, agrúpalas en cinco ideas y las retienes. Una, la red de la calle, o distribución por canalización, con sus tuberías de la compañía hasta dieciséis bar. Dos, todo el mundo del GLP: las bombonas, los depósitos fijos de los chalés y las plantas de gas natural licuado. Tres, las estaciones de servicio para repostar coches a gas. Cuatro, las instalaciones receptoras, que son tu terreno del día a día. Y cinco, los propios aparatos que queman el gas. De esas nueve letras, retén la hache, las receptoras, porque es donde vas a vivir como gasista de categoría B. Las demás las reconoces, pero la tuya es la hache.</a:t>
             </a:r>
           </a:p>
         </p:txBody>
@@ -1431,7 +1431,7 @@
           </a:p>
           <a:p>
             <a:r>
-              <a:t>N2: El truco de 'incluida o excluida' se entiende con la llave del portal. La llave de acometida es como la llave del portal que pone la compañía: no es tuya, por eso va excluida. Desde ahí hacia dentro, hasta las llaves de conexión de cada aparato, sí es tuyo, por eso van incluidas. Regla de una frase: la receptora empieza donde acaba la acometida y termina en la llave del aparato; el aparato y su latiguillo, fuera. Y esto no es un tecnicismo: esa frontera marca qué tramo pruebas con la estanquidad y qué firmas en el boletín. Si dejas un tramo fuera sin probar, ahí es justo donde aparece la fuga que no viste.</a:t>
+              <a:t>N2: El truco del 'incluida' y 'excluida' se entiende con la llave del portal. La llave de acometida es como la llave del portal que pone la compañía: no es tuya, y por eso va excluida, se queda fuera de tu instalación. Desde ahí hacia dentro, hasta las llaves de conexión de cada aparato, sí es tuyo, y por eso esas llaves van incluidas. Resúmelo en una frase que puedas recitar: la receptora empieza donde acaba la acometida y termina en la llave del aparato; el aparato y su tubito flexible, fuera. Y esto no es un tecnicismo de examen: esa frontera marca justo qué tramo pruebas con la estanquidad y qué firmas en el boletín. Si dejas un tramo fuera de la frontera sin probar, ahí es exactamente donde aparece la fuga que no viste.</a:t>
             </a:r>
           </a:p>
         </p:txBody>
@@ -1506,7 +1506,7 @@
           </a:p>
           <a:p>
             <a:r>
-              <a:t>N2: El límite de quince kilos separa la instalación del cacharro suelto. La bombona pequeña, de menos de quince kilos, con su tubo flexible a un único aparato móvil, no es instalación receptora: es camping-gas y no se legaliza como tal. Pero en cuanto pones tubería fija, varios aparatos o una bombona más grande, ya es instalación receptora y entra el Reglamento entero: certificado y prueba de estanquidad. Muchas chapuzas de campo son exactamente esto, una instalación fija montada como si fuera camping-gas, sin boletín y sin prueba. Ahí tienes la avería esperando a que alguien la encienda.</a:t>
+              <a:t>N2: No, y ese límite de quince kilos es la línea que separa una instalación de un simple cacharro suelto. La bombona pequeña, de menos de quince kilos, con su tubo flexible conectada a un único aparato móvil, no es instalación receptora: es camping-gas y no hay que legalizarla como tal. Pero atento al cambio: en cuanto pones tubería fija, o varios aparatos, o una bombona más grande, ya es instalación receptora y le entra el Reglamento entero, con su certificado y su prueba de estanquidad. Piénsalo como una regla de dos casilleros: bombona pequeña más un aparato móvil, fuera; todo lo demás, dentro. Muchas chapuzas que te vas a encontrar en campo son exactamente esto: una instalación fija montada como si fuera camping-gas, sin boletín y sin prueba. Ahí tienes la avería esperando a que alguien encienda.</a:t>
             </a:r>
           </a:p>
         </p:txBody>
@@ -1581,7 +1581,7 @@
           </a:p>
           <a:p>
             <a:r>
-              <a:t>N2: No. Una instalación antigua no se rehace porque salga normativa nueva: se respeta como está, hasta que la tocas. En el momento en que la amplías o la modificas, lo que toques se pone al día con la norma actual. Y aunque no la toques, los controles periódicos, las inspecciones y las revisiones, le caen igual. Nadie se libra del control periódico por ser antiguo. Piensa en una vivienda de hace décadas: mientras no metas mano, vive con su reglamento de origen, pero su inspección le toca exactamente igual que a la de al lado.</a:t>
+              <a:t>N2: No, y esto tranquiliza a mucha gente. Una instalación antigua no se rehace porque salga normativa nueva; se respeta tal como está, hasta que la tocas. En el momento en que la amplías o la modificas, lo que toques se pone al día con la norma actual. Piensa que actualizas la parte en la que metes mano, no toda la casa. Ahora bien, hay algo de lo que nadie se libra por ser antiguo: los controles periódicos, es decir, las inspecciones y revisiones, le caen igual que a una instalación nueva. Ejemplo claro: una vivienda de hace décadas, mientras no le toques nada, vive con su reglamento de origen; pero su inspección le toca exactamente igual que a la del vecino de al lado. Antigüedad no es excusa para saltarse el control.</a:t>
             </a:r>
           </a:p>
         </p:txBody>
@@ -5458,7 +5458,7 @@
       </p:sp>
       <p:sp>
         <p:nvSpPr>
-          <p:cNvPr id="8" name="imgph" descr="IMGQ:single family house gas meter box"/>
+          <p:cNvPr id="8" name="imgph" descr="IMGQ:single family house gas meter box garden"/>
           <p:cNvSpPr/>
           <p:nvPr/>
         </p:nvSpPr>
@@ -5544,7 +5544,7 @@
                 </a:solidFill>
                 <a:latin typeface="Montserrat"/>
               </a:rPr>
-              <a:t>single family house gas meter box</a:t>
+              <a:t>single family house gas meter box garden</a:t>
             </a:r>
           </a:p>
         </p:txBody>
@@ -7067,7 +7067,7 @@
                 </a:solidFill>
                 <a:latin typeface="Montserrat"/>
               </a:rPr>
-              <a:t>El artículo 3 ya es tu diccionario</a:t>
+              <a:t>El artículo tercero ya es tu diccionario</a:t>
             </a:r>
           </a:p>
         </p:txBody>
@@ -7542,7 +7542,7 @@
                 </a:solidFill>
                 <a:latin typeface="Montserrat"/>
               </a:rPr>
-              <a:t>partes de la receptora</a:t>
+              <a:t>partes de la instalación receptora</a:t>
             </a:r>
           </a:p>
         </p:txBody>
@@ -7658,7 +7658,7 @@
                 </a:solidFill>
                 <a:latin typeface="Montserrat"/>
               </a:rPr>
-              <a:t>definiciones del artículo 3</a:t>
+              <a:t>definiciones del artículo tercero</a:t>
             </a:r>
           </a:p>
         </p:txBody>
@@ -7930,7 +7930,7 @@
                 </a:solidFill>
                 <a:latin typeface="Montserrat"/>
               </a:rPr>
-              <a:t>Instalaciones y aparatos de gas</a:t>
+              <a:t>Sobre instalaciones y aparatos de gas</a:t>
             </a:r>
           </a:p>
           <a:p>
@@ -7962,7 +7962,7 @@
       </p:sp>
       <p:sp>
         <p:nvSpPr>
-          <p:cNvPr id="8" name="imgph" descr="IMGQ:gas boiler installation kitchen"/>
+          <p:cNvPr id="8" name="imgph" descr="IMGQ:gas boiler installation kitchen wall"/>
           <p:cNvSpPr/>
           <p:nvPr/>
         </p:nvSpPr>
@@ -8048,7 +8048,7 @@
                 </a:solidFill>
                 <a:latin typeface="Montserrat"/>
               </a:rPr>
-              <a:t>gas boiler installation kitchen</a:t>
+              <a:t>gas boiler installation kitchen wall</a:t>
             </a:r>
           </a:p>
         </p:txBody>
@@ -9182,7 +9182,7 @@
       </p:sp>
       <p:sp>
         <p:nvSpPr>
-          <p:cNvPr id="8" name="imgph" descr="IMGQ:gas meter cabinet building street"/>
+          <p:cNvPr id="8" name="imgph" descr="IMGQ:gas meter cabinet building facade"/>
           <p:cNvSpPr/>
           <p:nvPr/>
         </p:nvSpPr>
@@ -9268,7 +9268,7 @@
                 </a:solidFill>
                 <a:latin typeface="Montserrat"/>
               </a:rPr>
-              <a:t>gas meter cabinet building street</a:t>
+              <a:t>gas meter cabinet building facade</a:t>
             </a:r>
           </a:p>
         </p:txBody>
@@ -9565,7 +9565,7 @@
                 </a:solidFill>
                 <a:latin typeface="Montserrat"/>
               </a:rPr>
-              <a:t>Aparato y latiguillo: fuera</a:t>
+              <a:t>El aparato y su latiguillo quedan fuera</a:t>
             </a:r>
           </a:p>
           <a:p>
@@ -9590,14 +9590,14 @@
                 </a:solidFill>
                 <a:latin typeface="Montserrat"/>
               </a:rPr>
-              <a:t>Incluida/excluida decide de qué respondes</a:t>
-            </a:r>
-          </a:p>
-        </p:txBody>
-      </p:sp>
-      <p:sp>
-        <p:nvSpPr>
-          <p:cNvPr id="8" name="imgph" descr="IMGQ:gas shut off valve copper pipe"/>
+              <a:t>Esa frontera decide de qué respondes</a:t>
+            </a:r>
+          </a:p>
+        </p:txBody>
+      </p:sp>
+      <p:sp>
+        <p:nvSpPr>
+          <p:cNvPr id="8" name="imgph" descr="IMGQ:gas shut off valve copper pipe wall"/>
           <p:cNvSpPr/>
           <p:nvPr/>
         </p:nvSpPr>
@@ -9683,7 +9683,7 @@
                 </a:solidFill>
                 <a:latin typeface="Montserrat"/>
               </a:rPr>
-              <a:t>gas shut off valve copper pipe</a:t>
+              <a:t>gas shut off valve copper pipe wall</a:t>
             </a:r>
           </a:p>
         </p:txBody>

</xml_diff>

<commit_message>
FASE 2: mas color (naranja en titulos/acentos) + diapositiva indice 'Partes de este video'; regenera 49 decks
Co-Authored-By: Claude Opus 4.8 <noreply@anthropic.com>
Claude-Session: https://claude.ai/code/session_01UvCPDpSUkU2UKG6kCugktD
</commit_message>
<xml_diff>
--- a/Curso Gas B/00 - El Reglamento de Gas - estructura, ambito y generalidades/00 - El Reglamento de Gas - Vídeo 1.pptx
+++ b/Curso Gas B/00 - El Reglamento de Gas - estructura, ambito y generalidades/00 - El Reglamento de Gas - Vídeo 1.pptx
@@ -20,6 +20,7 @@
     <p:sldId id="268" r:id="rId20"/>
     <p:sldId id="269" r:id="rId21"/>
     <p:sldId id="270" r:id="rId22"/>
+    <p:sldId id="271" r:id="rId23"/>
   </p:sldIdLst>
   <p:sldSz cx="12191695" cy="6858000" type="screen4x3"/>
   <p:notesSz cx="6858000" cy="9144000"/>
@@ -591,12 +592,12 @@
           <a:lstStyle/>
           <a:p>
             <a:r>
-              <a:t>N1: ¿Cómo coloco los tres tramos sin equivocarme nunca?</a:t>
-            </a:r>
-          </a:p>
-          <a:p>
-            <a:r>
-              <a:t>N2: Imagínate el gas entrando en un edificio y avanzando por tres tramos encajados, siempre en el mismo orden, como muñecas rusas que salen una de otra. Primero, la acometida interior, que va de la calle al edificio. Después, la instalación común, que es el montante que sube por el edificio y lo comparten los vecinos. Y por último, la instalación individual, lo que entra en cada vivienda y llega hasta cada aparato. La clave es que cada tramo empieza justo donde acaba el anterior, sin huecos ni solapes. Si te imaginas el gas subiendo por la escalera y entrando en tu piso, colocas los tres tramos sin fallar. Y esto sirve para algo muy práctico: saber en qué tramo estás decide quién lo mantiene y quién lo inspecciona, que no siempre es la misma persona.</a:t>
+              <a:t>N1: Sale un reglamento nuevo, ¿hay que rehacer lo viejo?</a:t>
+            </a:r>
+          </a:p>
+          <a:p>
+            <a:r>
+              <a:t>N2: No, y esto tranquiliza a mucha gente. Una instalación antigua no se rehace porque salga normativa nueva; se respeta tal como está, hasta que la tocas. En el momento en que la amplías o la modificas, lo que toques se pone al día con la norma actual. Piensa que actualizas la parte en la que metes mano, no toda la casa. Ahora bien, hay algo de lo que nadie se libra por ser antiguo: los controles periódicos, es decir, las inspecciones y revisiones, le caen igual que a una instalación nueva. Ejemplo claro: una vivienda de hace décadas, mientras no le toques nada, vive con su reglamento de origen; pero su inspección le toca exactamente igual que a la del vecino de al lado. Antigüedad no es excusa para saltarse el control.</a:t>
             </a:r>
           </a:p>
         </p:txBody>
@@ -666,12 +667,12 @@
           <a:lstStyle/>
           <a:p>
             <a:r>
-              <a:t>N1: ¿Siempre están los tres tramos?</a:t>
-            </a:r>
-          </a:p>
-          <a:p>
-            <a:r>
-              <a:t>N2: No siempre, y es normal que falte alguno. Fíjate en que la propia definición dice 'en su caso más general', y esa coletilla es una pista: significa que no todas las instalaciones tienen los tres tramos. En una vivienda unifamiliar, un chalé con el contador en la valla, no hay instalación común ni acometida interior; va casi todo directo a la instalación individual. Así que no te agobies si en una instalación real echas en falta un tramo, no es un error, es un caso más sencillo. Lo importante, y lo que de verdad te van a exigir, es reconocer qué tramo tienes delante para saber qué le corresponde y qué papel te toca firmar a ti.</a:t>
+              <a:t>N1: ¿Cómo coloco los tres tramos sin equivocarme nunca?</a:t>
+            </a:r>
+          </a:p>
+          <a:p>
+            <a:r>
+              <a:t>N2: Imagínate el gas entrando en un edificio y avanzando por tres tramos encajados, siempre en el mismo orden, como muñecas rusas que salen una de otra. Primero, la acometida interior, que va de la calle al edificio. Después, la instalación común, que es el montante que sube por el edificio y lo comparten los vecinos. Y por último, la instalación individual, lo que entra en cada vivienda y llega hasta cada aparato. La clave es que cada tramo empieza justo donde acaba el anterior, sin huecos ni solapes. Si te imaginas el gas subiendo por la escalera y entrando en tu piso, colocas los tres tramos sin fallar. Y esto sirve para algo muy práctico: saber en qué tramo estás decide quién lo mantiene y quién lo inspecciona, que no siempre es la misma persona.</a:t>
             </a:r>
           </a:p>
         </p:txBody>
@@ -741,12 +742,12 @@
           <a:lstStyle/>
           <a:p>
             <a:r>
-              <a:t>N1: ¿Sabría separar quién hace qué en una instalación?</a:t>
-            </a:r>
-          </a:p>
-          <a:p>
-            <a:r>
-              <a:t>N2: Aquí está la otra mitad del diccionario y la trampa clásica del examen: hasta ahora hablábamos de tuberías, ahora hablamos de personas, los agentes. Vamos a atar cabos uno a uno. El fabricante hace el producto. La empresa instaladora, que es la razón social, la empresa, monta y certifica. El instalador, que es la persona con carné, es quien ejecuta el trabajo. El distribuidor lleva el gas por la red de la calle. El comercializador es quien te lo vende, con quien tienes el contrato. El titular es el dueño, que responde del mantenimiento, y el usuario es simplemente quien lo gasta. El truco para no fallar es mental: separa siempre 'tuberías' de 'personas'. Cuando el examen te cruce una parte con un agente para liarte, tú ya sabes que son dos listas distintas. Y en obra esto es oro: sabes exactamente a quién firmas y a quién tienes que avisar.</a:t>
+              <a:t>N1: ¿Siempre están los tres tramos?</a:t>
+            </a:r>
+          </a:p>
+          <a:p>
+            <a:r>
+              <a:t>N2: No siempre, y es normal que falte alguno. Fíjate en que la propia definición dice 'en su caso más general', y esa coletilla es una pista: significa que no todas las instalaciones tienen los tres tramos. En una vivienda unifamiliar, un chalé con el contador en la valla, no hay instalación común ni acometida interior; va casi todo directo a la instalación individual. Así que no te agobies si en una instalación real echas en falta un tramo, no es un error, es un caso más sencillo. Lo importante, y lo que de verdad te van a exigir, es reconocer qué tramo tienes delante para saber qué le corresponde y qué papel te toca firmar a ti.</a:t>
             </a:r>
           </a:p>
         </p:txBody>
@@ -816,12 +817,12 @@
           <a:lstStyle/>
           <a:p>
             <a:r>
-              <a:t>N1: ¿Qué son las tres familias de la norma UNE-EN cuatrocientos treinta y siete?</a:t>
-            </a:r>
-          </a:p>
-          <a:p>
-            <a:r>
-              <a:t>N2: Es la forma de clasificar los combustibles gaseosos según cómo queman, y son tres familias. La primera son los gases manufacturados y el aire propanado, que hoy están casi en desuso. La segunda es el gas natural, el de la ciudad, el que llega por la tubería de la calle. Y la tercera es el GLP, es decir butano y propano. Esto no es un dato de relleno, atento a por qué importa: cada aparato viene tarado, ajustado, para su gas y su presión. Si le metes un gas de otra familia, o a otra presión, la combustión se estropea y aparece la llama amarilla, el ennegrecido y, lo peligroso, el monóxido de carbono. Aquí solo aprendes a clasificarlos; el ajuste fino vendrá más adelante en el curso. Pero grábate la idea: la causa de media avería de combustión empieza por confundir la familia de gas.</a:t>
+              <a:t>N1: ¿Sabría separar quién hace qué en una instalación?</a:t>
+            </a:r>
+          </a:p>
+          <a:p>
+            <a:r>
+              <a:t>N2: Aquí está la otra mitad del diccionario y la trampa clásica del examen: hasta ahora hablábamos de tuberías, ahora hablamos de personas, los agentes. Vamos a atar cabos uno a uno. El fabricante hace el producto. La empresa instaladora, que es la razón social, la empresa, monta y certifica. El instalador, que es la persona con carné, es quien ejecuta el trabajo. El distribuidor lleva el gas por la red de la calle. El comercializador es quien te lo vende, con quien tienes el contrato. El titular es el dueño, que responde del mantenimiento, y el usuario es simplemente quien lo gasta. El truco para no fallar es mental: separa siempre 'tuberías' de 'personas'. Cuando el examen te cruce una parte con un agente para liarte, tú ya sabes que son dos listas distintas. Y en obra esto es oro: sabes exactamente a quién firmas y a quién tienes que avisar.</a:t>
             </a:r>
           </a:p>
         </p:txBody>
@@ -891,12 +892,12 @@
           <a:lstStyle/>
           <a:p>
             <a:r>
-              <a:t>N1: Cerramos con un repaso rápido. ¿Me suenan ya los cuatro pilares?</a:t>
-            </a:r>
-          </a:p>
-          <a:p>
-            <a:r>
-              <a:t>N2: Vamos a fijarlos en treinta segundos, y te propongo que los repitas en voz alta conmigo. Uno, tronco y ramas: lo general vive en el Reglamento, el detalle en cada ITC. Dos, nueve tipos de instalación, y la letra hache, las receptoras, es tu terreno. Tres, la receptora va de la llave de acometida, que va excluida, a la llave del aparato, que va incluida. Y cuatro, el artículo tercero es tu diccionario, y tiene dos mitades: las tres partes encajadas por un lado y las personas del oficio por otro. Si eres capaz de recitar estos cuatro puntos de carrerilla, tienes el vídeo dominado. Hazlo una vez en voz alta antes de seguir, que lo que se dice se recuerda mejor que lo que solo se lee.</a:t>
+              <a:t>N1: ¿Qué son las tres familias de la norma UNE-EN cuatrocientos treinta y siete?</a:t>
+            </a:r>
+          </a:p>
+          <a:p>
+            <a:r>
+              <a:t>N2: Es la forma de clasificar los combustibles gaseosos según cómo queman, y son tres familias. La primera son los gases manufacturados y el aire propanado, que hoy están casi en desuso. La segunda es el gas natural, el de la ciudad, el que llega por la tubería de la calle. Y la tercera es el GLP, es decir butano y propano. Esto no es un dato de relleno, atento a por qué importa: cada aparato viene tarado, ajustado, para su gas y su presión. Si le metes un gas de otra familia, o a otra presión, la combustión se estropea y aparece la llama amarilla, el ennegrecido y, lo peligroso, el monóxido de carbono. Aquí solo aprendes a clasificarlos; el ajuste fino vendrá más adelante en el curso. Pero grábate la idea: la causa de media avería de combustión empieza por confundir la familia de gas.</a:t>
             </a:r>
           </a:p>
         </p:txBody>
@@ -966,6 +967,81 @@
           <a:lstStyle/>
           <a:p>
             <a:r>
+              <a:t>N1: Cerramos con un repaso rápido. ¿Me suenan ya los cuatro pilares?</a:t>
+            </a:r>
+          </a:p>
+          <a:p>
+            <a:r>
+              <a:t>N2: Vamos a fijarlos en treinta segundos, y te propongo que los repitas en voz alta conmigo. Uno, tronco y ramas: lo general vive en el Reglamento, el detalle en cada ITC. Dos, nueve tipos de instalación, y la letra hache, las receptoras, es tu terreno. Tres, la receptora va de la llave de acometida, que va excluida, a la llave del aparato, que va incluida. Y cuatro, el artículo tercero es tu diccionario, y tiene dos mitades: las tres partes encajadas por un lado y las personas del oficio por otro. Si eres capaz de recitar estos cuatro puntos de carrerilla, tienes el vídeo dominado. Hazlo una vez en voz alta antes de seguir, que lo que se dice se recuerda mejor que lo que solo se lee.</a:t>
+            </a:r>
+          </a:p>
+        </p:txBody>
+      </p:sp>
+      <p:sp>
+        <p:nvSpPr>
+          <p:cNvPr id="4" name="Slide Number Placeholder 3"/>
+          <p:cNvSpPr>
+            <a:spLocks noGrp="1"/>
+          </p:cNvSpPr>
+          <p:nvPr>
+            <p:ph type="sldNum" idx="5" sz="quarter"/>
+          </p:nvPr>
+        </p:nvSpPr>
+        <p:spPr/>
+      </p:sp>
+    </p:spTree>
+  </p:cSld>
+  <p:clrMapOvr>
+    <a:masterClrMapping/>
+  </p:clrMapOvr>
+</p:notes>
+</file>
+
+<file path=ppt/notesSlides/notesSlide16.xml><?xml version="1.0" encoding="utf-8"?>
+<p:notes xmlns:a="http://schemas.openxmlformats.org/drawingml/2006/main" xmlns:p="http://schemas.openxmlformats.org/presentationml/2006/main" xmlns:r="http://schemas.openxmlformats.org/officeDocument/2006/relationships">
+  <p:cSld>
+    <p:spTree>
+      <p:nvGrpSpPr>
+        <p:cNvPr id="1" name=""/>
+        <p:cNvGrpSpPr/>
+        <p:nvPr/>
+      </p:nvGrpSpPr>
+      <p:grpSpPr>
+        <a:xfrm>
+          <a:off x="0" y="0"/>
+          <a:ext cx="0" cy="0"/>
+          <a:chOff x="0" y="0"/>
+          <a:chExt cx="0" cy="0"/>
+        </a:xfrm>
+      </p:grpSpPr>
+      <p:sp>
+        <p:nvSpPr>
+          <p:cNvPr id="2" name="Slide Image Placeholder 1"/>
+          <p:cNvSpPr>
+            <a:spLocks noGrp="1"/>
+          </p:cNvSpPr>
+          <p:nvPr>
+            <p:ph type="sldImg" idx="2"/>
+          </p:nvPr>
+        </p:nvSpPr>
+        <p:spPr/>
+      </p:sp>
+      <p:sp>
+        <p:nvSpPr>
+          <p:cNvPr id="3" name="Notes Placeholder 2"/>
+          <p:cNvSpPr>
+            <a:spLocks noGrp="1"/>
+          </p:cNvSpPr>
+          <p:nvPr>
+            <p:ph type="body" idx="3" sz="quarter"/>
+          </p:nvPr>
+        </p:nvSpPr>
+        <p:spPr/>
+        <p:txBody>
+          <a:bodyPr/>
+          <a:lstStyle/>
+          <a:p>
+            <a:r>
               <a:t>N1: Cerramos fuerte. Si me quedo con lo esencial, ¿qué he conquistado hoy?</a:t>
             </a:r>
           </a:p>
@@ -1124,16 +1200,7 @@
         <p:txBody>
           <a:bodyPr/>
           <a:lstStyle/>
-          <a:p>
-            <a:r>
-              <a:t>N1: Si tuviera que resumir en una frase para qué existe este Reglamento, ¿qué diría?</a:t>
-            </a:r>
-          </a:p>
-          <a:p>
-            <a:r>
-              <a:t>N2: Piénsalo así: su objeto es fijar las condiciones técnicas y las garantías que deben reunir las instalaciones de gas y los aparatos que lo queman, con una única finalidad de fondo, que es proteger la seguridad de las personas y los bienes. Quédate con esa palabra, seguridad, porque es la brújula de todo. Cada distancia, cada prueba y cada certificado que verás en el curso nace de ahí. ¿Por qué importa esto en obra? Porque cuando dudes entre hacer algo de una manera o de otra, la respuesta correcta es casi siempre la más segura para quien vive en esa casa. Un ejemplo del día a día: ante una ventilación justita, el Reglamento nunca tira a lo cómodo, tira a proteger al usuario.</a:t>
-            </a:r>
-          </a:p>
+          <a:p/>
         </p:txBody>
       </p:sp>
       <p:sp>
@@ -1201,12 +1268,12 @@
           <a:lstStyle/>
           <a:p>
             <a:r>
-              <a:t>N1: Cuando dude de dónde sale una norma, ¿dónde miro?</a:t>
-            </a:r>
-          </a:p>
-          <a:p>
-            <a:r>
-              <a:t>N2: Usa una imagen que ya conoces: un árbol. El Reglamento es el tronco y las Instrucciones Técnicas Complementarias, que llamamos ITC, son las ramas. El tronco, que es el articulado, dice lo que vale para todos por igual. Cada rama, cada ITC, baja al detalle de un tipo concreto de instalación. Con esto tienes un método: cuando en obra te preguntes 'esto, ¿de dónde sale?', la respuesta casi siempre es lo general del tronco y el detalle de la rama que toque. Y un matiz que cae en el examen: cumplir el Reglamento no te libra de cumplir otras normas que regulan cosas distintas sobre esa misma instalación, por ejemplo las de electricidad o las de protección contra incendios. Esta lógica de tronco y ramas se repite en todo el curso, así que grábatela ya.</a:t>
+              <a:t>N1: Si tuviera que resumir en una frase para qué existe este Reglamento, ¿qué diría?</a:t>
+            </a:r>
+          </a:p>
+          <a:p>
+            <a:r>
+              <a:t>N2: Piénsalo así: su objeto es fijar las condiciones técnicas y las garantías que deben reunir las instalaciones de gas y los aparatos que lo queman, con una única finalidad de fondo, que es proteger la seguridad de las personas y los bienes. Quédate con esa palabra, seguridad, porque es la brújula de todo. Cada distancia, cada prueba y cada certificado que verás en el curso nace de ahí. ¿Por qué importa esto en obra? Porque cuando dudes entre hacer algo de una manera o de otra, la respuesta correcta es casi siempre la más segura para quien vive en esa casa. Un ejemplo del día a día: ante una ventilación justita, el Reglamento nunca tira a lo cómodo, tira a proteger al usuario.</a:t>
             </a:r>
           </a:p>
         </p:txBody>
@@ -1276,12 +1343,12 @@
           <a:lstStyle/>
           <a:p>
             <a:r>
-              <a:t>N1: ¿Por qué hay dos leyes por encima del Reglamento?</a:t>
-            </a:r>
-          </a:p>
-          <a:p>
-            <a:r>
-              <a:t>N2: Porque un reglamento nunca nace solo; siempre desarrolla lo que una ley le ordena. Aquí hay dos leyes por encima. La Ley del sector de hidrocarburos manda en el negocio del gas: quién lo distribuye, quién lo comercializa, quién lo vende. Y la Ley de industria manda en la seguridad industrial. El Reglamento es el manual de instrucciones que baja esas dos leyes al taller, al tubo y a la llave. ¿Cómo se pregunta esto? Directo: 'de qué leyes cuelga el Reglamento', y ya lo tienes, hidrocarburos e industria. Guárdate además un detalle que ató luego: las sanciones tampoco las inventa el Reglamento, te remite a estas dos leyes. Todo empieza y acaba en ellas.</a:t>
+              <a:t>N1: Cuando dude de dónde sale una norma, ¿dónde miro?</a:t>
+            </a:r>
+          </a:p>
+          <a:p>
+            <a:r>
+              <a:t>N2: Usa una imagen que ya conoces: un árbol. El Reglamento es el tronco y las Instrucciones Técnicas Complementarias, que llamamos ITC, son las ramas. El tronco, que es el articulado, dice lo que vale para todos por igual. Cada rama, cada ITC, baja al detalle de un tipo concreto de instalación. Con esto tienes un método: cuando en obra te preguntes 'esto, ¿de dónde sale?', la respuesta casi siempre es lo general del tronco y el detalle de la rama que toque. Y un matiz que cae en el examen: cumplir el Reglamento no te libra de cumplir otras normas que regulan cosas distintas sobre esa misma instalación, por ejemplo las de electricidad o las de protección contra incendios. Esta lógica de tronco y ramas se repite en todo el curso, así que grábatela ya.</a:t>
             </a:r>
           </a:p>
         </p:txBody>
@@ -1351,12 +1418,12 @@
           <a:lstStyle/>
           <a:p>
             <a:r>
-              <a:t>N1: ¿Todo lo que huele a gas entra aquí?</a:t>
-            </a:r>
-          </a:p>
-          <a:p>
-            <a:r>
-              <a:t>N2: Prácticamente todo, sí. El Reglamento cubre nueve tipos, pero no te aprendas nueve cosas sueltas, agrúpalas en cinco ideas y las retienes. Una, la red de la calle, o distribución por canalización, con sus tuberías de la compañía hasta dieciséis bar. Dos, todo el mundo del GLP: las bombonas, los depósitos fijos de los chalés y las plantas de gas natural licuado. Tres, las estaciones de servicio para repostar coches a gas. Cuatro, las instalaciones receptoras, que son tu terreno del día a día. Y cinco, los propios aparatos que queman el gas. De esas nueve letras, retén la hache, las receptoras, porque es donde vas a vivir como gasista de categoría B. Las demás las reconoces, pero la tuya es la hache.</a:t>
+              <a:t>N1: ¿Por qué hay dos leyes por encima del Reglamento?</a:t>
+            </a:r>
+          </a:p>
+          <a:p>
+            <a:r>
+              <a:t>N2: Porque un reglamento nunca nace solo; siempre desarrolla lo que una ley le ordena. Aquí hay dos leyes por encima. La Ley del sector de hidrocarburos manda en el negocio del gas: quién lo distribuye, quién lo comercializa, quién lo vende. Y la Ley de industria manda en la seguridad industrial. El Reglamento es el manual de instrucciones que baja esas dos leyes al taller, al tubo y a la llave. ¿Cómo se pregunta esto? Directo: 'de qué leyes cuelga el Reglamento', y ya lo tienes, hidrocarburos e industria. Guárdate además un detalle que ató luego: las sanciones tampoco las inventa el Reglamento, te remite a estas dos leyes. Todo empieza y acaba en ellas.</a:t>
             </a:r>
           </a:p>
         </p:txBody>
@@ -1426,12 +1493,12 @@
           <a:lstStyle/>
           <a:p>
             <a:r>
-              <a:t>N1: ¿Dónde está la frontera de lo que es tuyo?</a:t>
-            </a:r>
-          </a:p>
-          <a:p>
-            <a:r>
-              <a:t>N2: El truco del 'incluida' y 'excluida' se entiende con la llave del portal. La llave de acometida es como la llave del portal que pone la compañía: no es tuya, y por eso va excluida, se queda fuera de tu instalación. Desde ahí hacia dentro, hasta las llaves de conexión de cada aparato, sí es tuyo, y por eso esas llaves van incluidas. Resúmelo en una frase que puedas recitar: la receptora empieza donde acaba la acometida y termina en la llave del aparato; el aparato y su tubito flexible, fuera. Y esto no es un tecnicismo de examen: esa frontera marca justo qué tramo pruebas con la estanquidad y qué firmas en el boletín. Si dejas un tramo fuera de la frontera sin probar, ahí es exactamente donde aparece la fuga que no viste.</a:t>
+              <a:t>N1: ¿Todo lo que huele a gas entra aquí?</a:t>
+            </a:r>
+          </a:p>
+          <a:p>
+            <a:r>
+              <a:t>N2: Prácticamente todo, sí. El Reglamento cubre nueve tipos, pero no te aprendas nueve cosas sueltas, agrúpalas en cinco ideas y las retienes. Una, la red de la calle, o distribución por canalización, con sus tuberías de la compañía hasta dieciséis bar. Dos, todo el mundo del GLP: las bombonas, los depósitos fijos de los chalés y las plantas de gas natural licuado. Tres, las estaciones de servicio para repostar coches a gas. Cuatro, las instalaciones receptoras, que son tu terreno del día a día. Y cinco, los propios aparatos que queman el gas. De esas nueve letras, retén la hache, las receptoras, porque es donde vas a vivir como gasista de categoría B. Las demás las reconoces, pero la tuya es la hache.</a:t>
             </a:r>
           </a:p>
         </p:txBody>
@@ -1501,12 +1568,12 @@
           <a:lstStyle/>
           <a:p>
             <a:r>
-              <a:t>N1: Una bombona de camping con su hornillo, ¿es instalación receptora?</a:t>
-            </a:r>
-          </a:p>
-          <a:p>
-            <a:r>
-              <a:t>N2: No, y ese límite de quince kilos es la línea que separa una instalación de un simple cacharro suelto. La bombona pequeña, de menos de quince kilos, con su tubo flexible conectada a un único aparato móvil, no es instalación receptora: es camping-gas y no hay que legalizarla como tal. Pero atento al cambio: en cuanto pones tubería fija, o varios aparatos, o una bombona más grande, ya es instalación receptora y le entra el Reglamento entero, con su certificado y su prueba de estanquidad. Piénsalo como una regla de dos casilleros: bombona pequeña más un aparato móvil, fuera; todo lo demás, dentro. Muchas chapuzas que te vas a encontrar en campo son exactamente esto: una instalación fija montada como si fuera camping-gas, sin boletín y sin prueba. Ahí tienes la avería esperando a que alguien encienda.</a:t>
+              <a:t>N1: ¿Dónde está la frontera de lo que es tuyo?</a:t>
+            </a:r>
+          </a:p>
+          <a:p>
+            <a:r>
+              <a:t>N2: El truco del 'incluida' y 'excluida' se entiende con la llave del portal. La llave de acometida es como la llave del portal que pone la compañía: no es tuya, y por eso va excluida, se queda fuera de tu instalación. Desde ahí hacia dentro, hasta las llaves de conexión de cada aparato, sí es tuyo, y por eso esas llaves van incluidas. Resúmelo en una frase que puedas recitar: la receptora empieza donde acaba la acometida y termina en la llave del aparato; el aparato y su tubito flexible, fuera. Y esto no es un tecnicismo de examen: esa frontera marca justo qué tramo pruebas con la estanquidad y qué firmas en el boletín. Si dejas un tramo fuera de la frontera sin probar, ahí es exactamente donde aparece la fuga que no viste.</a:t>
             </a:r>
           </a:p>
         </p:txBody>
@@ -1576,12 +1643,12 @@
           <a:lstStyle/>
           <a:p>
             <a:r>
-              <a:t>N1: Sale un reglamento nuevo, ¿hay que rehacer lo viejo?</a:t>
-            </a:r>
-          </a:p>
-          <a:p>
-            <a:r>
-              <a:t>N2: No, y esto tranquiliza a mucha gente. Una instalación antigua no se rehace porque salga normativa nueva; se respeta tal como está, hasta que la tocas. En el momento en que la amplías o la modificas, lo que toques se pone al día con la norma actual. Piensa que actualizas la parte en la que metes mano, no toda la casa. Ahora bien, hay algo de lo que nadie se libra por ser antiguo: los controles periódicos, es decir, las inspecciones y revisiones, le caen igual que a una instalación nueva. Ejemplo claro: una vivienda de hace décadas, mientras no le toques nada, vive con su reglamento de origen; pero su inspección le toca exactamente igual que a la del vecino de al lado. Antigüedad no es excusa para saltarse el control.</a:t>
+              <a:t>N1: Una bombona de camping con su hornillo, ¿es instalación receptora?</a:t>
+            </a:r>
+          </a:p>
+          <a:p>
+            <a:r>
+              <a:t>N2: No, y ese límite de quince kilos es la línea que separa una instalación de un simple cacharro suelto. La bombona pequeña, de menos de quince kilos, con su tubo flexible conectada a un único aparato móvil, no es instalación receptora: es camping-gas y no hay que legalizarla como tal. Pero atento al cambio: en cuanto pones tubería fija, o varios aparatos, o una bombona más grande, ya es instalación receptora y le entra el Reglamento entero, con su certificado y su prueba de estanquidad. Piénsalo como una regla de dos casilleros: bombona pequeña más un aparato móvil, fuera; todo lo demás, dentro. Muchas chapuzas que te vas a encontrar en campo son exactamente esto: una instalación fija montada como si fuera camping-gas, sin boletín y sin prueba. Ahí tienes la avería esperando a que alguien encienda.</a:t>
             </a:r>
           </a:p>
         </p:txBody>
@@ -4656,7 +4723,7 @@
             <a:r>
               <a:rPr sz="1400" b="1" i="0">
                 <a:solidFill>
-                  <a:srgbClr val="CADCFC"/>
+                  <a:srgbClr val="F4A24C"/>
                 </a:solidFill>
                 <a:latin typeface="Montserrat"/>
               </a:rPr>
@@ -4667,13 +4734,57 @@
       </p:sp>
       <p:sp>
         <p:nvSpPr>
-          <p:cNvPr id="4" name="TextBox 3"/>
+          <p:cNvPr id="4" name="Rounded Rectangle 3"/>
+          <p:cNvSpPr/>
+          <p:nvPr/>
+        </p:nvSpPr>
+        <p:spPr>
+          <a:xfrm>
+            <a:off x="868680" y="2057400"/>
+            <a:ext cx="1463040" cy="82296"/>
+          </a:xfrm>
+          <a:prstGeom prst="roundRect">
+            <a:avLst/>
+          </a:prstGeom>
+          <a:solidFill>
+            <a:srgbClr val="E8801A"/>
+          </a:solidFill>
+          <a:ln>
+            <a:noFill/>
+          </a:ln>
+          <a:effectLst/>
+        </p:spPr>
+        <p:style>
+          <a:lnRef idx="1">
+            <a:schemeClr val="accent1"/>
+          </a:lnRef>
+          <a:fillRef idx="3">
+            <a:schemeClr val="accent1"/>
+          </a:fillRef>
+          <a:effectRef idx="2">
+            <a:schemeClr val="accent1"/>
+          </a:effectRef>
+          <a:fontRef idx="minor">
+            <a:schemeClr val="lt1"/>
+          </a:fontRef>
+        </p:style>
+        <p:txBody>
+          <a:bodyPr rtlCol="0" anchor="ctr"/>
+          <a:lstStyle/>
+          <a:p>
+            <a:pPr algn="ctr"/>
+          </a:p>
+        </p:txBody>
+      </p:sp>
+      <p:sp>
+        <p:nvSpPr>
+          <p:cNvPr id="5" name="TextBox 4"/>
           <p:cNvSpPr txBox="1"/>
           <p:nvPr/>
         </p:nvSpPr>
         <p:spPr>
           <a:xfrm>
-            <a:off x="822960" y="2194560"/>
+            <a:off x="822960" y="2286000"/>
             <a:ext cx="10515600" cy="2011680"/>
           </a:xfrm>
           <a:prstGeom prst="rect">
@@ -4712,7 +4823,7 @@
       </p:sp>
       <p:sp>
         <p:nvSpPr>
-          <p:cNvPr id="5" name="TextBox 4"/>
+          <p:cNvPr id="6" name="TextBox 5"/>
           <p:cNvSpPr txBox="1"/>
           <p:nvPr/>
         </p:nvSpPr>
@@ -4836,7 +4947,7 @@
                 </a:solidFill>
                 <a:latin typeface="Montserrat"/>
               </a:rPr>
-              <a:t>010 / 015</a:t>
+              <a:t>010 / 016</a:t>
             </a:r>
           </a:p>
         </p:txBody>
@@ -4884,7 +4995,7 @@
         <p:spPr>
           <a:xfrm>
             <a:off x="822960" y="457200"/>
-            <a:ext cx="8229600" cy="365760"/>
+            <a:ext cx="10058400" cy="365760"/>
           </a:xfrm>
           <a:prstGeom prst="rect">
             <a:avLst/>
@@ -4898,13 +5009,13 @@
           <a:lstStyle/>
           <a:p>
             <a:r>
-              <a:rPr sz="1200" b="1" i="0">
-                <a:solidFill>
-                  <a:srgbClr val="64748B"/>
-                </a:solidFill>
-                <a:latin typeface="Montserrat"/>
-              </a:rPr>
-              <a:t>ARTÍCULO 3 · LAS TRES PARTES</a:t>
+              <a:rPr sz="1300" b="1" i="0">
+                <a:solidFill>
+                  <a:srgbClr val="E8801A"/>
+                </a:solidFill>
+                <a:latin typeface="Montserrat"/>
+              </a:rPr>
+              <a:t>ARTÍCULO 2 · APLICACIÓN EN EL TIEMPO</a:t>
             </a:r>
           </a:p>
         </p:txBody>
@@ -4932,26 +5043,70 @@
           <a:lstStyle/>
           <a:p>
             <a:r>
-              <a:rPr sz="2700" b="1" i="0">
+              <a:rPr sz="2800" b="1" i="0">
                 <a:solidFill>
                   <a:srgbClr val="1E2761"/>
                 </a:solidFill>
                 <a:latin typeface="Montserrat"/>
               </a:rPr>
-              <a:t>Las muñecas rusas del gas</a:t>
-            </a:r>
-          </a:p>
-        </p:txBody>
-      </p:sp>
-      <p:sp>
-        <p:nvSpPr>
-          <p:cNvPr id="7" name="TextBox 6"/>
+              <a:t>¿Y las instalaciones viejas?</a:t>
+            </a:r>
+          </a:p>
+        </p:txBody>
+      </p:sp>
+      <p:sp>
+        <p:nvSpPr>
+          <p:cNvPr id="7" name="Rounded Rectangle 6"/>
+          <p:cNvSpPr/>
+          <p:nvPr/>
+        </p:nvSpPr>
+        <p:spPr>
+          <a:xfrm>
+            <a:off x="868680" y="1627632"/>
+            <a:ext cx="2011680" cy="73152"/>
+          </a:xfrm>
+          <a:prstGeom prst="roundRect">
+            <a:avLst/>
+          </a:prstGeom>
+          <a:solidFill>
+            <a:srgbClr val="E8801A"/>
+          </a:solidFill>
+          <a:ln>
+            <a:noFill/>
+          </a:ln>
+          <a:effectLst/>
+        </p:spPr>
+        <p:style>
+          <a:lnRef idx="1">
+            <a:schemeClr val="accent1"/>
+          </a:lnRef>
+          <a:fillRef idx="3">
+            <a:schemeClr val="accent1"/>
+          </a:fillRef>
+          <a:effectRef idx="2">
+            <a:schemeClr val="accent1"/>
+          </a:effectRef>
+          <a:fontRef idx="minor">
+            <a:schemeClr val="lt1"/>
+          </a:fontRef>
+        </p:style>
+        <p:txBody>
+          <a:bodyPr rtlCol="0" anchor="ctr"/>
+          <a:lstStyle/>
+          <a:p>
+            <a:pPr algn="ctr"/>
+          </a:p>
+        </p:txBody>
+      </p:sp>
+      <p:sp>
+        <p:nvSpPr>
+          <p:cNvPr id="8" name="TextBox 7"/>
           <p:cNvSpPr txBox="1"/>
           <p:nvPr/>
         </p:nvSpPr>
         <p:spPr>
           <a:xfrm>
-            <a:off x="822960" y="1920240"/>
+            <a:off x="822960" y="1965960"/>
             <a:ext cx="4983480" cy="4206240"/>
           </a:xfrm>
           <a:prstGeom prst="rect">
@@ -4967,17 +5122,17 @@
           <a:p>
             <a:pPr>
               <a:spcAft>
-                <a:spcPts val="1000"/>
+                <a:spcPts val="1100"/>
               </a:spcAft>
             </a:pPr>
             <a:r>
               <a:rPr sz="1600" b="1" i="0">
                 <a:solidFill>
-                  <a:srgbClr val="2E3A80"/>
-                </a:solidFill>
-                <a:latin typeface="Montserrat"/>
-              </a:rPr>
-              <a:t>•  </a:t>
+                  <a:srgbClr val="E8801A"/>
+                </a:solidFill>
+                <a:latin typeface="Montserrat"/>
+              </a:rPr>
+              <a:t>▸  </a:t>
             </a:r>
             <a:r>
               <a:rPr sz="1600" b="0" i="0">
@@ -4986,23 +5141,23 @@
                 </a:solidFill>
                 <a:latin typeface="Montserrat"/>
               </a:rPr>
-              <a:t>Acometida interior: de la calle al edificio</a:t>
+              <a:t>Nuevas, modificaciones y ampliaciones</a:t>
             </a:r>
           </a:p>
           <a:p>
             <a:pPr>
               <a:spcAft>
-                <a:spcPts val="1000"/>
+                <a:spcPts val="1100"/>
               </a:spcAft>
             </a:pPr>
             <a:r>
               <a:rPr sz="1600" b="1" i="0">
                 <a:solidFill>
-                  <a:srgbClr val="2E3A80"/>
-                </a:solidFill>
-                <a:latin typeface="Montserrat"/>
-              </a:rPr>
-              <a:t>•  </a:t>
+                  <a:srgbClr val="E8801A"/>
+                </a:solidFill>
+                <a:latin typeface="Montserrat"/>
+              </a:rPr>
+              <a:t>▸  </a:t>
             </a:r>
             <a:r>
               <a:rPr sz="1600" b="0" i="0">
@@ -5011,23 +5166,23 @@
                 </a:solidFill>
                 <a:latin typeface="Montserrat"/>
               </a:rPr>
-              <a:t>Instalación común: el montante compartido</a:t>
+              <a:t>Existentes: solo lo que tocas se actualiza</a:t>
             </a:r>
           </a:p>
           <a:p>
             <a:pPr>
               <a:spcAft>
-                <a:spcPts val="1000"/>
+                <a:spcPts val="1100"/>
               </a:spcAft>
             </a:pPr>
             <a:r>
               <a:rPr sz="1600" b="1" i="0">
                 <a:solidFill>
-                  <a:srgbClr val="2E3A80"/>
-                </a:solidFill>
-                <a:latin typeface="Montserrat"/>
-              </a:rPr>
-              <a:t>•  </a:t>
+                  <a:srgbClr val="E8801A"/>
+                </a:solidFill>
+                <a:latin typeface="Montserrat"/>
+              </a:rPr>
+              <a:t>▸  </a:t>
             </a:r>
             <a:r>
               <a:rPr sz="1600" b="0" i="0">
@@ -5036,39 +5191,14 @@
                 </a:solidFill>
                 <a:latin typeface="Montserrat"/>
               </a:rPr>
-              <a:t>Instalación individual: hasta cada aparato</a:t>
-            </a:r>
-          </a:p>
-          <a:p>
-            <a:pPr>
-              <a:spcAft>
-                <a:spcPts val="1000"/>
-              </a:spcAft>
-            </a:pPr>
-            <a:r>
-              <a:rPr sz="1600" b="1" i="0">
-                <a:solidFill>
-                  <a:srgbClr val="2E3A80"/>
-                </a:solidFill>
-                <a:latin typeface="Montserrat"/>
-              </a:rPr>
-              <a:t>•  </a:t>
-            </a:r>
-            <a:r>
-              <a:rPr sz="1600" b="0" i="0">
-                <a:solidFill>
-                  <a:srgbClr val="1B2330"/>
-                </a:solidFill>
-                <a:latin typeface="Montserrat"/>
-              </a:rPr>
-              <a:t>Cada tramo empieza donde acaba el anterior</a:t>
-            </a:r>
-          </a:p>
-        </p:txBody>
-      </p:sp>
-      <p:sp>
-        <p:nvSpPr>
-          <p:cNvPr id="8" name="imgph" descr="IMGQ:gas riser pipes building staircase"/>
+              <a:t>Controles periódicos: a todas, sin excepción</a:t>
+            </a:r>
+          </a:p>
+        </p:txBody>
+      </p:sp>
+      <p:sp>
+        <p:nvSpPr>
+          <p:cNvPr id="9" name="imgph" descr="IMGQ:old gas pipe brick wall"/>
           <p:cNvSpPr/>
           <p:nvPr/>
         </p:nvSpPr>
@@ -5114,7 +5244,7 @@
       </p:sp>
       <p:sp>
         <p:nvSpPr>
-          <p:cNvPr id="9" name="TextBox 8"/>
+          <p:cNvPr id="10" name="TextBox 9"/>
           <p:cNvSpPr txBox="1"/>
           <p:nvPr/>
         </p:nvSpPr>
@@ -5154,7 +5284,7 @@
                 </a:solidFill>
                 <a:latin typeface="Montserrat"/>
               </a:rPr>
-              <a:t>gas riser pipes building staircase</a:t>
+              <a:t>old gas pipe brick wall</a:t>
             </a:r>
           </a:p>
         </p:txBody>
@@ -5251,7 +5381,7 @@
                 </a:solidFill>
                 <a:latin typeface="Montserrat"/>
               </a:rPr>
-              <a:t>011 / 015</a:t>
+              <a:t>011 / 016</a:t>
             </a:r>
           </a:p>
         </p:txBody>
@@ -5299,7 +5429,7 @@
         <p:spPr>
           <a:xfrm>
             <a:off x="822960" y="457200"/>
-            <a:ext cx="8229600" cy="365760"/>
+            <a:ext cx="10058400" cy="365760"/>
           </a:xfrm>
           <a:prstGeom prst="rect">
             <a:avLst/>
@@ -5313,13 +5443,13 @@
           <a:lstStyle/>
           <a:p>
             <a:r>
-              <a:rPr sz="1200" b="1" i="0">
-                <a:solidFill>
-                  <a:srgbClr val="64748B"/>
-                </a:solidFill>
-                <a:latin typeface="Montserrat"/>
-              </a:rPr>
-              <a:t>ARTÍCULO 3 · CASOS REALES</a:t>
+              <a:rPr sz="1300" b="1" i="0">
+                <a:solidFill>
+                  <a:srgbClr val="E8801A"/>
+                </a:solidFill>
+                <a:latin typeface="Montserrat"/>
+              </a:rPr>
+              <a:t>ARTÍCULO 3 · LAS TRES PARTES</a:t>
             </a:r>
           </a:p>
         </p:txBody>
@@ -5347,26 +5477,70 @@
           <a:lstStyle/>
           <a:p>
             <a:r>
-              <a:rPr sz="2700" b="1" i="0">
+              <a:rPr sz="2800" b="1" i="0">
                 <a:solidFill>
                   <a:srgbClr val="1E2761"/>
                 </a:solidFill>
                 <a:latin typeface="Montserrat"/>
               </a:rPr>
-              <a:t>¿Y si es un chalé?</a:t>
-            </a:r>
-          </a:p>
-        </p:txBody>
-      </p:sp>
-      <p:sp>
-        <p:nvSpPr>
-          <p:cNvPr id="7" name="TextBox 6"/>
+              <a:t>Las muñecas rusas del gas</a:t>
+            </a:r>
+          </a:p>
+        </p:txBody>
+      </p:sp>
+      <p:sp>
+        <p:nvSpPr>
+          <p:cNvPr id="7" name="Rounded Rectangle 6"/>
+          <p:cNvSpPr/>
+          <p:nvPr/>
+        </p:nvSpPr>
+        <p:spPr>
+          <a:xfrm>
+            <a:off x="868680" y="1627632"/>
+            <a:ext cx="2011680" cy="73152"/>
+          </a:xfrm>
+          <a:prstGeom prst="roundRect">
+            <a:avLst/>
+          </a:prstGeom>
+          <a:solidFill>
+            <a:srgbClr val="E8801A"/>
+          </a:solidFill>
+          <a:ln>
+            <a:noFill/>
+          </a:ln>
+          <a:effectLst/>
+        </p:spPr>
+        <p:style>
+          <a:lnRef idx="1">
+            <a:schemeClr val="accent1"/>
+          </a:lnRef>
+          <a:fillRef idx="3">
+            <a:schemeClr val="accent1"/>
+          </a:fillRef>
+          <a:effectRef idx="2">
+            <a:schemeClr val="accent1"/>
+          </a:effectRef>
+          <a:fontRef idx="minor">
+            <a:schemeClr val="lt1"/>
+          </a:fontRef>
+        </p:style>
+        <p:txBody>
+          <a:bodyPr rtlCol="0" anchor="ctr"/>
+          <a:lstStyle/>
+          <a:p>
+            <a:pPr algn="ctr"/>
+          </a:p>
+        </p:txBody>
+      </p:sp>
+      <p:sp>
+        <p:nvSpPr>
+          <p:cNvPr id="8" name="TextBox 7"/>
           <p:cNvSpPr txBox="1"/>
           <p:nvPr/>
         </p:nvSpPr>
         <p:spPr>
           <a:xfrm>
-            <a:off x="822960" y="1920240"/>
+            <a:off x="822960" y="1965960"/>
             <a:ext cx="4983480" cy="4206240"/>
           </a:xfrm>
           <a:prstGeom prst="rect">
@@ -5382,17 +5556,17 @@
           <a:p>
             <a:pPr>
               <a:spcAft>
-                <a:spcPts val="1000"/>
+                <a:spcPts val="1100"/>
               </a:spcAft>
             </a:pPr>
             <a:r>
               <a:rPr sz="1600" b="1" i="0">
                 <a:solidFill>
-                  <a:srgbClr val="2E3A80"/>
-                </a:solidFill>
-                <a:latin typeface="Montserrat"/>
-              </a:rPr>
-              <a:t>•  </a:t>
+                  <a:srgbClr val="E8801A"/>
+                </a:solidFill>
+                <a:latin typeface="Montserrat"/>
+              </a:rPr>
+              <a:t>▸  </a:t>
             </a:r>
             <a:r>
               <a:rPr sz="1600" b="0" i="0">
@@ -5401,23 +5575,23 @@
                 </a:solidFill>
                 <a:latin typeface="Montserrat"/>
               </a:rPr>
-              <a:t>No siempre existen los tres tramos</a:t>
+              <a:t>Acometida interior: de la calle al edificio</a:t>
             </a:r>
           </a:p>
           <a:p>
             <a:pPr>
               <a:spcAft>
-                <a:spcPts val="1000"/>
+                <a:spcPts val="1100"/>
               </a:spcAft>
             </a:pPr>
             <a:r>
               <a:rPr sz="1600" b="1" i="0">
                 <a:solidFill>
-                  <a:srgbClr val="2E3A80"/>
-                </a:solidFill>
-                <a:latin typeface="Montserrat"/>
-              </a:rPr>
-              <a:t>•  </a:t>
+                  <a:srgbClr val="E8801A"/>
+                </a:solidFill>
+                <a:latin typeface="Montserrat"/>
+              </a:rPr>
+              <a:t>▸  </a:t>
             </a:r>
             <a:r>
               <a:rPr sz="1600" b="0" i="0">
@@ -5426,23 +5600,23 @@
                 </a:solidFill>
                 <a:latin typeface="Montserrat"/>
               </a:rPr>
-              <a:t>Contador en la valla: sin común</a:t>
+              <a:t>Instalación común: el montante compartido</a:t>
             </a:r>
           </a:p>
           <a:p>
             <a:pPr>
               <a:spcAft>
-                <a:spcPts val="1000"/>
+                <a:spcPts val="1100"/>
               </a:spcAft>
             </a:pPr>
             <a:r>
               <a:rPr sz="1600" b="1" i="0">
                 <a:solidFill>
-                  <a:srgbClr val="2E3A80"/>
-                </a:solidFill>
-                <a:latin typeface="Montserrat"/>
-              </a:rPr>
-              <a:t>•  </a:t>
+                  <a:srgbClr val="E8801A"/>
+                </a:solidFill>
+                <a:latin typeface="Montserrat"/>
+              </a:rPr>
+              <a:t>▸  </a:t>
             </a:r>
             <a:r>
               <a:rPr sz="1600" b="0" i="0">
@@ -5451,14 +5625,39 @@
                 </a:solidFill>
                 <a:latin typeface="Montserrat"/>
               </a:rPr>
-              <a:t>Casi todo va a la individual</a:t>
-            </a:r>
-          </a:p>
-        </p:txBody>
-      </p:sp>
-      <p:sp>
-        <p:nvSpPr>
-          <p:cNvPr id="8" name="imgph" descr="IMGQ:single family house gas meter box garden"/>
+              <a:t>Instalación individual: hasta cada aparato</a:t>
+            </a:r>
+          </a:p>
+          <a:p>
+            <a:pPr>
+              <a:spcAft>
+                <a:spcPts val="1100"/>
+              </a:spcAft>
+            </a:pPr>
+            <a:r>
+              <a:rPr sz="1600" b="1" i="0">
+                <a:solidFill>
+                  <a:srgbClr val="E8801A"/>
+                </a:solidFill>
+                <a:latin typeface="Montserrat"/>
+              </a:rPr>
+              <a:t>▸  </a:t>
+            </a:r>
+            <a:r>
+              <a:rPr sz="1600" b="0" i="0">
+                <a:solidFill>
+                  <a:srgbClr val="1B2330"/>
+                </a:solidFill>
+                <a:latin typeface="Montserrat"/>
+              </a:rPr>
+              <a:t>Cada tramo empieza donde acaba el anterior</a:t>
+            </a:r>
+          </a:p>
+        </p:txBody>
+      </p:sp>
+      <p:sp>
+        <p:nvSpPr>
+          <p:cNvPr id="9" name="imgph" descr="IMGQ:gas riser pipes building staircase"/>
           <p:cNvSpPr/>
           <p:nvPr/>
         </p:nvSpPr>
@@ -5504,7 +5703,7 @@
       </p:sp>
       <p:sp>
         <p:nvSpPr>
-          <p:cNvPr id="9" name="TextBox 8"/>
+          <p:cNvPr id="10" name="TextBox 9"/>
           <p:cNvSpPr txBox="1"/>
           <p:nvPr/>
         </p:nvSpPr>
@@ -5544,7 +5743,7 @@
                 </a:solidFill>
                 <a:latin typeface="Montserrat"/>
               </a:rPr>
-              <a:t>single family house gas meter box garden</a:t>
+              <a:t>gas riser pipes building staircase</a:t>
             </a:r>
           </a:p>
         </p:txBody>
@@ -5641,7 +5840,7 @@
                 </a:solidFill>
                 <a:latin typeface="Montserrat"/>
               </a:rPr>
-              <a:t>012 / 015</a:t>
+              <a:t>012 / 016</a:t>
             </a:r>
           </a:p>
         </p:txBody>
@@ -5689,7 +5888,7 @@
         <p:spPr>
           <a:xfrm>
             <a:off x="822960" y="457200"/>
-            <a:ext cx="8229600" cy="365760"/>
+            <a:ext cx="10058400" cy="365760"/>
           </a:xfrm>
           <a:prstGeom prst="rect">
             <a:avLst/>
@@ -5703,13 +5902,13 @@
           <a:lstStyle/>
           <a:p>
             <a:r>
-              <a:rPr sz="1200" b="1" i="0">
-                <a:solidFill>
-                  <a:srgbClr val="64748B"/>
-                </a:solidFill>
-                <a:latin typeface="Montserrat"/>
-              </a:rPr>
-              <a:t>ARTÍCULO 3 · QUIÉN ES QUIÉN</a:t>
+              <a:rPr sz="1300" b="1" i="0">
+                <a:solidFill>
+                  <a:srgbClr val="E8801A"/>
+                </a:solidFill>
+                <a:latin typeface="Montserrat"/>
+              </a:rPr>
+              <a:t>ARTÍCULO 3 · CASOS REALES</a:t>
             </a:r>
           </a:p>
         </p:txBody>
@@ -5737,26 +5936,70 @@
           <a:lstStyle/>
           <a:p>
             <a:r>
-              <a:rPr sz="2700" b="1" i="0">
+              <a:rPr sz="2800" b="1" i="0">
                 <a:solidFill>
                   <a:srgbClr val="1E2761"/>
                 </a:solidFill>
                 <a:latin typeface="Montserrat"/>
               </a:rPr>
-              <a:t>Personas, no tuberías</a:t>
-            </a:r>
-          </a:p>
-        </p:txBody>
-      </p:sp>
-      <p:sp>
-        <p:nvSpPr>
-          <p:cNvPr id="7" name="TextBox 6"/>
+              <a:t>¿Y si es un chalé?</a:t>
+            </a:r>
+          </a:p>
+        </p:txBody>
+      </p:sp>
+      <p:sp>
+        <p:nvSpPr>
+          <p:cNvPr id="7" name="Rounded Rectangle 6"/>
+          <p:cNvSpPr/>
+          <p:nvPr/>
+        </p:nvSpPr>
+        <p:spPr>
+          <a:xfrm>
+            <a:off x="868680" y="1627632"/>
+            <a:ext cx="2011680" cy="73152"/>
+          </a:xfrm>
+          <a:prstGeom prst="roundRect">
+            <a:avLst/>
+          </a:prstGeom>
+          <a:solidFill>
+            <a:srgbClr val="E8801A"/>
+          </a:solidFill>
+          <a:ln>
+            <a:noFill/>
+          </a:ln>
+          <a:effectLst/>
+        </p:spPr>
+        <p:style>
+          <a:lnRef idx="1">
+            <a:schemeClr val="accent1"/>
+          </a:lnRef>
+          <a:fillRef idx="3">
+            <a:schemeClr val="accent1"/>
+          </a:fillRef>
+          <a:effectRef idx="2">
+            <a:schemeClr val="accent1"/>
+          </a:effectRef>
+          <a:fontRef idx="minor">
+            <a:schemeClr val="lt1"/>
+          </a:fontRef>
+        </p:style>
+        <p:txBody>
+          <a:bodyPr rtlCol="0" anchor="ctr"/>
+          <a:lstStyle/>
+          <a:p>
+            <a:pPr algn="ctr"/>
+          </a:p>
+        </p:txBody>
+      </p:sp>
+      <p:sp>
+        <p:nvSpPr>
+          <p:cNvPr id="8" name="TextBox 7"/>
           <p:cNvSpPr txBox="1"/>
           <p:nvPr/>
         </p:nvSpPr>
         <p:spPr>
           <a:xfrm>
-            <a:off x="822960" y="1920240"/>
+            <a:off x="822960" y="1965960"/>
             <a:ext cx="4983480" cy="4206240"/>
           </a:xfrm>
           <a:prstGeom prst="rect">
@@ -5772,17 +6015,17 @@
           <a:p>
             <a:pPr>
               <a:spcAft>
-                <a:spcPts val="1000"/>
+                <a:spcPts val="1100"/>
               </a:spcAft>
             </a:pPr>
             <a:r>
               <a:rPr sz="1600" b="1" i="0">
                 <a:solidFill>
-                  <a:srgbClr val="2E3A80"/>
-                </a:solidFill>
-                <a:latin typeface="Montserrat"/>
-              </a:rPr>
-              <a:t>•  </a:t>
+                  <a:srgbClr val="E8801A"/>
+                </a:solidFill>
+                <a:latin typeface="Montserrat"/>
+              </a:rPr>
+              <a:t>▸  </a:t>
             </a:r>
             <a:r>
               <a:rPr sz="1600" b="0" i="0">
@@ -5791,23 +6034,23 @@
                 </a:solidFill>
                 <a:latin typeface="Montserrat"/>
               </a:rPr>
-              <a:t>Fabricante: hace el producto</a:t>
+              <a:t>No siempre existen los tres tramos</a:t>
             </a:r>
           </a:p>
           <a:p>
             <a:pPr>
               <a:spcAft>
-                <a:spcPts val="1000"/>
+                <a:spcPts val="1100"/>
               </a:spcAft>
             </a:pPr>
             <a:r>
               <a:rPr sz="1600" b="1" i="0">
                 <a:solidFill>
-                  <a:srgbClr val="2E3A80"/>
-                </a:solidFill>
-                <a:latin typeface="Montserrat"/>
-              </a:rPr>
-              <a:t>•  </a:t>
+                  <a:srgbClr val="E8801A"/>
+                </a:solidFill>
+                <a:latin typeface="Montserrat"/>
+              </a:rPr>
+              <a:t>▸  </a:t>
             </a:r>
             <a:r>
               <a:rPr sz="1600" b="0" i="0">
@@ -5816,23 +6059,23 @@
                 </a:solidFill>
                 <a:latin typeface="Montserrat"/>
               </a:rPr>
-              <a:t>Empresa instaladora: monta y certifica</a:t>
+              <a:t>Contador en la valla: sin común</a:t>
             </a:r>
           </a:p>
           <a:p>
             <a:pPr>
               <a:spcAft>
-                <a:spcPts val="1000"/>
+                <a:spcPts val="1100"/>
               </a:spcAft>
             </a:pPr>
             <a:r>
               <a:rPr sz="1600" b="1" i="0">
                 <a:solidFill>
-                  <a:srgbClr val="2E3A80"/>
-                </a:solidFill>
-                <a:latin typeface="Montserrat"/>
-              </a:rPr>
-              <a:t>•  </a:t>
+                  <a:srgbClr val="E8801A"/>
+                </a:solidFill>
+                <a:latin typeface="Montserrat"/>
+              </a:rPr>
+              <a:t>▸  </a:t>
             </a:r>
             <a:r>
               <a:rPr sz="1600" b="0" i="0">
@@ -5841,64 +6084,14 @@
                 </a:solidFill>
                 <a:latin typeface="Montserrat"/>
               </a:rPr>
-              <a:t>Instalador: la persona con carné</a:t>
-            </a:r>
-          </a:p>
-          <a:p>
-            <a:pPr>
-              <a:spcAft>
-                <a:spcPts val="1000"/>
-              </a:spcAft>
-            </a:pPr>
-            <a:r>
-              <a:rPr sz="1600" b="1" i="0">
-                <a:solidFill>
-                  <a:srgbClr val="2E3A80"/>
-                </a:solidFill>
-                <a:latin typeface="Montserrat"/>
-              </a:rPr>
-              <a:t>•  </a:t>
-            </a:r>
-            <a:r>
-              <a:rPr sz="1600" b="0" i="0">
-                <a:solidFill>
-                  <a:srgbClr val="1B2330"/>
-                </a:solidFill>
-                <a:latin typeface="Montserrat"/>
-              </a:rPr>
-              <a:t>Distribuidor da el gas; comercializador lo vende</a:t>
-            </a:r>
-          </a:p>
-          <a:p>
-            <a:pPr>
-              <a:spcAft>
-                <a:spcPts val="1000"/>
-              </a:spcAft>
-            </a:pPr>
-            <a:r>
-              <a:rPr sz="1600" b="1" i="0">
-                <a:solidFill>
-                  <a:srgbClr val="2E3A80"/>
-                </a:solidFill>
-                <a:latin typeface="Montserrat"/>
-              </a:rPr>
-              <a:t>•  </a:t>
-            </a:r>
-            <a:r>
-              <a:rPr sz="1600" b="0" i="0">
-                <a:solidFill>
-                  <a:srgbClr val="1B2330"/>
-                </a:solidFill>
-                <a:latin typeface="Montserrat"/>
-              </a:rPr>
-              <a:t>Titular es el dueño; usuario lo consume</a:t>
-            </a:r>
-          </a:p>
-        </p:txBody>
-      </p:sp>
-      <p:sp>
-        <p:nvSpPr>
-          <p:cNvPr id="8" name="imgph" descr="IMGQ:gas technician uniform clipboard"/>
+              <a:t>Casi todo va a la individual</a:t>
+            </a:r>
+          </a:p>
+        </p:txBody>
+      </p:sp>
+      <p:sp>
+        <p:nvSpPr>
+          <p:cNvPr id="9" name="imgph" descr="IMGQ:single family house gas meter box garden"/>
           <p:cNvSpPr/>
           <p:nvPr/>
         </p:nvSpPr>
@@ -5944,7 +6137,7 @@
       </p:sp>
       <p:sp>
         <p:nvSpPr>
-          <p:cNvPr id="9" name="TextBox 8"/>
+          <p:cNvPr id="10" name="TextBox 9"/>
           <p:cNvSpPr txBox="1"/>
           <p:nvPr/>
         </p:nvSpPr>
@@ -5984,7 +6177,7 @@
                 </a:solidFill>
                 <a:latin typeface="Montserrat"/>
               </a:rPr>
-              <a:t>gas technician uniform clipboard</a:t>
+              <a:t>single family house gas meter box garden</a:t>
             </a:r>
           </a:p>
         </p:txBody>
@@ -6081,7 +6274,7 @@
                 </a:solidFill>
                 <a:latin typeface="Montserrat"/>
               </a:rPr>
-              <a:t>013 / 015</a:t>
+              <a:t>013 / 016</a:t>
             </a:r>
           </a:p>
         </p:txBody>
@@ -6129,7 +6322,7 @@
         <p:spPr>
           <a:xfrm>
             <a:off x="822960" y="457200"/>
-            <a:ext cx="8229600" cy="365760"/>
+            <a:ext cx="10058400" cy="365760"/>
           </a:xfrm>
           <a:prstGeom prst="rect">
             <a:avLst/>
@@ -6143,13 +6336,13 @@
           <a:lstStyle/>
           <a:p>
             <a:r>
-              <a:rPr sz="1200" b="1" i="0">
-                <a:solidFill>
-                  <a:srgbClr val="64748B"/>
-                </a:solidFill>
-                <a:latin typeface="Montserrat"/>
-              </a:rPr>
-              <a:t>ARTÍCULO 3 · COMBUSTIBLES GASEOSOS</a:t>
+              <a:rPr sz="1300" b="1" i="0">
+                <a:solidFill>
+                  <a:srgbClr val="E8801A"/>
+                </a:solidFill>
+                <a:latin typeface="Montserrat"/>
+              </a:rPr>
+              <a:t>ARTÍCULO 3 · QUIÉN ES QUIÉN</a:t>
             </a:r>
           </a:p>
         </p:txBody>
@@ -6177,26 +6370,70 @@
           <a:lstStyle/>
           <a:p>
             <a:r>
-              <a:rPr sz="2700" b="1" i="0">
+              <a:rPr sz="2800" b="1" i="0">
                 <a:solidFill>
                   <a:srgbClr val="1E2761"/>
                 </a:solidFill>
                 <a:latin typeface="Montserrat"/>
               </a:rPr>
-              <a:t>Las tres familias de gas</a:t>
-            </a:r>
-          </a:p>
-        </p:txBody>
-      </p:sp>
-      <p:sp>
-        <p:nvSpPr>
-          <p:cNvPr id="7" name="TextBox 6"/>
+              <a:t>Personas, no tuberías</a:t>
+            </a:r>
+          </a:p>
+        </p:txBody>
+      </p:sp>
+      <p:sp>
+        <p:nvSpPr>
+          <p:cNvPr id="7" name="Rounded Rectangle 6"/>
+          <p:cNvSpPr/>
+          <p:nvPr/>
+        </p:nvSpPr>
+        <p:spPr>
+          <a:xfrm>
+            <a:off x="868680" y="1627632"/>
+            <a:ext cx="2011680" cy="73152"/>
+          </a:xfrm>
+          <a:prstGeom prst="roundRect">
+            <a:avLst/>
+          </a:prstGeom>
+          <a:solidFill>
+            <a:srgbClr val="E8801A"/>
+          </a:solidFill>
+          <a:ln>
+            <a:noFill/>
+          </a:ln>
+          <a:effectLst/>
+        </p:spPr>
+        <p:style>
+          <a:lnRef idx="1">
+            <a:schemeClr val="accent1"/>
+          </a:lnRef>
+          <a:fillRef idx="3">
+            <a:schemeClr val="accent1"/>
+          </a:fillRef>
+          <a:effectRef idx="2">
+            <a:schemeClr val="accent1"/>
+          </a:effectRef>
+          <a:fontRef idx="minor">
+            <a:schemeClr val="lt1"/>
+          </a:fontRef>
+        </p:style>
+        <p:txBody>
+          <a:bodyPr rtlCol="0" anchor="ctr"/>
+          <a:lstStyle/>
+          <a:p>
+            <a:pPr algn="ctr"/>
+          </a:p>
+        </p:txBody>
+      </p:sp>
+      <p:sp>
+        <p:nvSpPr>
+          <p:cNvPr id="8" name="TextBox 7"/>
           <p:cNvSpPr txBox="1"/>
           <p:nvPr/>
         </p:nvSpPr>
         <p:spPr>
           <a:xfrm>
-            <a:off x="822960" y="1920240"/>
+            <a:off x="822960" y="1965960"/>
             <a:ext cx="4983480" cy="4206240"/>
           </a:xfrm>
           <a:prstGeom prst="rect">
@@ -6212,17 +6449,17 @@
           <a:p>
             <a:pPr>
               <a:spcAft>
-                <a:spcPts val="1000"/>
+                <a:spcPts val="1100"/>
               </a:spcAft>
             </a:pPr>
             <a:r>
               <a:rPr sz="1600" b="1" i="0">
                 <a:solidFill>
-                  <a:srgbClr val="2E3A80"/>
-                </a:solidFill>
-                <a:latin typeface="Montserrat"/>
-              </a:rPr>
-              <a:t>•  </a:t>
+                  <a:srgbClr val="E8801A"/>
+                </a:solidFill>
+                <a:latin typeface="Montserrat"/>
+              </a:rPr>
+              <a:t>▸  </a:t>
             </a:r>
             <a:r>
               <a:rPr sz="1600" b="0" i="0">
@@ -6231,23 +6468,23 @@
                 </a:solidFill>
                 <a:latin typeface="Montserrat"/>
               </a:rPr>
-              <a:t>1.ª familia: manufacturados (en desuso)</a:t>
+              <a:t>Fabricante: hace el producto</a:t>
             </a:r>
           </a:p>
           <a:p>
             <a:pPr>
               <a:spcAft>
-                <a:spcPts val="1000"/>
+                <a:spcPts val="1100"/>
               </a:spcAft>
             </a:pPr>
             <a:r>
               <a:rPr sz="1600" b="1" i="0">
                 <a:solidFill>
-                  <a:srgbClr val="2E3A80"/>
-                </a:solidFill>
-                <a:latin typeface="Montserrat"/>
-              </a:rPr>
-              <a:t>•  </a:t>
+                  <a:srgbClr val="E8801A"/>
+                </a:solidFill>
+                <a:latin typeface="Montserrat"/>
+              </a:rPr>
+              <a:t>▸  </a:t>
             </a:r>
             <a:r>
               <a:rPr sz="1600" b="0" i="0">
@@ -6256,23 +6493,23 @@
                 </a:solidFill>
                 <a:latin typeface="Montserrat"/>
               </a:rPr>
-              <a:t>2.ª familia: gas natural</a:t>
+              <a:t>Empresa instaladora: monta y certifica</a:t>
             </a:r>
           </a:p>
           <a:p>
             <a:pPr>
               <a:spcAft>
-                <a:spcPts val="1000"/>
+                <a:spcPts val="1100"/>
               </a:spcAft>
             </a:pPr>
             <a:r>
               <a:rPr sz="1600" b="1" i="0">
                 <a:solidFill>
-                  <a:srgbClr val="2E3A80"/>
-                </a:solidFill>
-                <a:latin typeface="Montserrat"/>
-              </a:rPr>
-              <a:t>•  </a:t>
+                  <a:srgbClr val="E8801A"/>
+                </a:solidFill>
+                <a:latin typeface="Montserrat"/>
+              </a:rPr>
+              <a:t>▸  </a:t>
             </a:r>
             <a:r>
               <a:rPr sz="1600" b="0" i="0">
@@ -6281,23 +6518,23 @@
                 </a:solidFill>
                 <a:latin typeface="Montserrat"/>
               </a:rPr>
-              <a:t>3.ª familia: GLP, butano y propano</a:t>
+              <a:t>Instalador: la persona con carné</a:t>
             </a:r>
           </a:p>
           <a:p>
             <a:pPr>
               <a:spcAft>
-                <a:spcPts val="1000"/>
+                <a:spcPts val="1100"/>
               </a:spcAft>
             </a:pPr>
             <a:r>
               <a:rPr sz="1600" b="1" i="0">
                 <a:solidFill>
-                  <a:srgbClr val="2E3A80"/>
-                </a:solidFill>
-                <a:latin typeface="Montserrat"/>
-              </a:rPr>
-              <a:t>•  </a:t>
+                  <a:srgbClr val="E8801A"/>
+                </a:solidFill>
+                <a:latin typeface="Montserrat"/>
+              </a:rPr>
+              <a:t>▸  </a:t>
             </a:r>
             <a:r>
               <a:rPr sz="1600" b="0" i="0">
@@ -6306,14 +6543,39 @@
                 </a:solidFill>
                 <a:latin typeface="Montserrat"/>
               </a:rPr>
-              <a:t>Cada aparato, tarado para su gas</a:t>
-            </a:r>
-          </a:p>
-        </p:txBody>
-      </p:sp>
-      <p:sp>
-        <p:nvSpPr>
-          <p:cNvPr id="8" name="imgph" descr="IMGQ:blue gas flame stove burner"/>
+              <a:t>Distribuidor da el gas; comercializador lo vende</a:t>
+            </a:r>
+          </a:p>
+          <a:p>
+            <a:pPr>
+              <a:spcAft>
+                <a:spcPts val="1100"/>
+              </a:spcAft>
+            </a:pPr>
+            <a:r>
+              <a:rPr sz="1600" b="1" i="0">
+                <a:solidFill>
+                  <a:srgbClr val="E8801A"/>
+                </a:solidFill>
+                <a:latin typeface="Montserrat"/>
+              </a:rPr>
+              <a:t>▸  </a:t>
+            </a:r>
+            <a:r>
+              <a:rPr sz="1600" b="0" i="0">
+                <a:solidFill>
+                  <a:srgbClr val="1B2330"/>
+                </a:solidFill>
+                <a:latin typeface="Montserrat"/>
+              </a:rPr>
+              <a:t>Titular es el dueño; usuario lo consume</a:t>
+            </a:r>
+          </a:p>
+        </p:txBody>
+      </p:sp>
+      <p:sp>
+        <p:nvSpPr>
+          <p:cNvPr id="9" name="imgph" descr="IMGQ:gas technician uniform clipboard"/>
           <p:cNvSpPr/>
           <p:nvPr/>
         </p:nvSpPr>
@@ -6359,7 +6621,7 @@
       </p:sp>
       <p:sp>
         <p:nvSpPr>
-          <p:cNvPr id="9" name="TextBox 8"/>
+          <p:cNvPr id="10" name="TextBox 9"/>
           <p:cNvSpPr txBox="1"/>
           <p:nvPr/>
         </p:nvSpPr>
@@ -6399,7 +6661,7 @@
                 </a:solidFill>
                 <a:latin typeface="Montserrat"/>
               </a:rPr>
-              <a:t>blue gas flame stove burner</a:t>
+              <a:t>gas technician uniform clipboard</a:t>
             </a:r>
           </a:p>
         </p:txBody>
@@ -6496,7 +6758,7 @@
                 </a:solidFill>
                 <a:latin typeface="Montserrat"/>
               </a:rPr>
-              <a:t>014 / 015</a:t>
+              <a:t>014 / 016</a:t>
             </a:r>
           </a:p>
         </p:txBody>
@@ -6544,7 +6806,7 @@
         <p:spPr>
           <a:xfrm>
             <a:off x="822960" y="457200"/>
-            <a:ext cx="8229600" cy="365760"/>
+            <a:ext cx="10058400" cy="365760"/>
           </a:xfrm>
           <a:prstGeom prst="rect">
             <a:avLst/>
@@ -6558,13 +6820,13 @@
           <a:lstStyle/>
           <a:p>
             <a:r>
-              <a:rPr sz="1200" b="1" i="0">
-                <a:solidFill>
-                  <a:srgbClr val="64748B"/>
-                </a:solidFill>
-                <a:latin typeface="Montserrat"/>
-              </a:rPr>
-              <a:t>REPASO RELÁMPAGO</a:t>
+              <a:rPr sz="1300" b="1" i="0">
+                <a:solidFill>
+                  <a:srgbClr val="E8801A"/>
+                </a:solidFill>
+                <a:latin typeface="Montserrat"/>
+              </a:rPr>
+              <a:t>ARTÍCULO 3 · COMBUSTIBLES GASEOSOS</a:t>
             </a:r>
           </a:p>
         </p:txBody>
@@ -6592,26 +6854,70 @@
           <a:lstStyle/>
           <a:p>
             <a:r>
-              <a:rPr sz="2700" b="1" i="0">
+              <a:rPr sz="2800" b="1" i="0">
                 <a:solidFill>
                   <a:srgbClr val="1E2761"/>
                 </a:solidFill>
                 <a:latin typeface="Montserrat"/>
               </a:rPr>
-              <a:t>Fíjalo en treinta segundos</a:t>
-            </a:r>
-          </a:p>
-        </p:txBody>
-      </p:sp>
-      <p:sp>
-        <p:nvSpPr>
-          <p:cNvPr id="7" name="TextBox 6"/>
+              <a:t>Las tres familias de gas</a:t>
+            </a:r>
+          </a:p>
+        </p:txBody>
+      </p:sp>
+      <p:sp>
+        <p:nvSpPr>
+          <p:cNvPr id="7" name="Rounded Rectangle 6"/>
+          <p:cNvSpPr/>
+          <p:nvPr/>
+        </p:nvSpPr>
+        <p:spPr>
+          <a:xfrm>
+            <a:off x="868680" y="1627632"/>
+            <a:ext cx="2011680" cy="73152"/>
+          </a:xfrm>
+          <a:prstGeom prst="roundRect">
+            <a:avLst/>
+          </a:prstGeom>
+          <a:solidFill>
+            <a:srgbClr val="E8801A"/>
+          </a:solidFill>
+          <a:ln>
+            <a:noFill/>
+          </a:ln>
+          <a:effectLst/>
+        </p:spPr>
+        <p:style>
+          <a:lnRef idx="1">
+            <a:schemeClr val="accent1"/>
+          </a:lnRef>
+          <a:fillRef idx="3">
+            <a:schemeClr val="accent1"/>
+          </a:fillRef>
+          <a:effectRef idx="2">
+            <a:schemeClr val="accent1"/>
+          </a:effectRef>
+          <a:fontRef idx="minor">
+            <a:schemeClr val="lt1"/>
+          </a:fontRef>
+        </p:style>
+        <p:txBody>
+          <a:bodyPr rtlCol="0" anchor="ctr"/>
+          <a:lstStyle/>
+          <a:p>
+            <a:pPr algn="ctr"/>
+          </a:p>
+        </p:txBody>
+      </p:sp>
+      <p:sp>
+        <p:nvSpPr>
+          <p:cNvPr id="8" name="TextBox 7"/>
           <p:cNvSpPr txBox="1"/>
           <p:nvPr/>
         </p:nvSpPr>
         <p:spPr>
           <a:xfrm>
-            <a:off x="822960" y="1920240"/>
+            <a:off x="822960" y="1965960"/>
             <a:ext cx="4983480" cy="4206240"/>
           </a:xfrm>
           <a:prstGeom prst="rect">
@@ -6627,17 +6933,17 @@
           <a:p>
             <a:pPr>
               <a:spcAft>
-                <a:spcPts val="1000"/>
+                <a:spcPts val="1100"/>
               </a:spcAft>
             </a:pPr>
             <a:r>
               <a:rPr sz="1600" b="1" i="0">
                 <a:solidFill>
-                  <a:srgbClr val="2E3A80"/>
-                </a:solidFill>
-                <a:latin typeface="Montserrat"/>
-              </a:rPr>
-              <a:t>•  </a:t>
+                  <a:srgbClr val="E8801A"/>
+                </a:solidFill>
+                <a:latin typeface="Montserrat"/>
+              </a:rPr>
+              <a:t>▸  </a:t>
             </a:r>
             <a:r>
               <a:rPr sz="1600" b="0" i="0">
@@ -6646,23 +6952,23 @@
                 </a:solidFill>
                 <a:latin typeface="Montserrat"/>
               </a:rPr>
-              <a:t>Reglamento = tronco; ITC = ramas</a:t>
+              <a:t>1.ª familia: manufacturados (en desuso)</a:t>
             </a:r>
           </a:p>
           <a:p>
             <a:pPr>
               <a:spcAft>
-                <a:spcPts val="1000"/>
+                <a:spcPts val="1100"/>
               </a:spcAft>
             </a:pPr>
             <a:r>
               <a:rPr sz="1600" b="1" i="0">
                 <a:solidFill>
-                  <a:srgbClr val="2E3A80"/>
-                </a:solidFill>
-                <a:latin typeface="Montserrat"/>
-              </a:rPr>
-              <a:t>•  </a:t>
+                  <a:srgbClr val="E8801A"/>
+                </a:solidFill>
+                <a:latin typeface="Montserrat"/>
+              </a:rPr>
+              <a:t>▸  </a:t>
             </a:r>
             <a:r>
               <a:rPr sz="1600" b="0" i="0">
@@ -6671,23 +6977,23 @@
                 </a:solidFill>
                 <a:latin typeface="Montserrat"/>
               </a:rPr>
-              <a:t>Nueve tipos; la h son tus receptoras</a:t>
+              <a:t>2.ª familia: gas natural</a:t>
             </a:r>
           </a:p>
           <a:p>
             <a:pPr>
               <a:spcAft>
-                <a:spcPts val="1000"/>
+                <a:spcPts val="1100"/>
               </a:spcAft>
             </a:pPr>
             <a:r>
               <a:rPr sz="1600" b="1" i="0">
                 <a:solidFill>
-                  <a:srgbClr val="2E3A80"/>
-                </a:solidFill>
-                <a:latin typeface="Montserrat"/>
-              </a:rPr>
-              <a:t>•  </a:t>
+                  <a:srgbClr val="E8801A"/>
+                </a:solidFill>
+                <a:latin typeface="Montserrat"/>
+              </a:rPr>
+              <a:t>▸  </a:t>
             </a:r>
             <a:r>
               <a:rPr sz="1600" b="0" i="0">
@@ -6696,23 +7002,23 @@
                 </a:solidFill>
                 <a:latin typeface="Montserrat"/>
               </a:rPr>
-              <a:t>Receptora: de acometida a llave de aparato</a:t>
+              <a:t>3.ª familia: GLP, butano y propano</a:t>
             </a:r>
           </a:p>
           <a:p>
             <a:pPr>
               <a:spcAft>
-                <a:spcPts val="1000"/>
+                <a:spcPts val="1100"/>
               </a:spcAft>
             </a:pPr>
             <a:r>
               <a:rPr sz="1600" b="1" i="0">
                 <a:solidFill>
-                  <a:srgbClr val="2E3A80"/>
-                </a:solidFill>
-                <a:latin typeface="Montserrat"/>
-              </a:rPr>
-              <a:t>•  </a:t>
+                  <a:srgbClr val="E8801A"/>
+                </a:solidFill>
+                <a:latin typeface="Montserrat"/>
+              </a:rPr>
+              <a:t>▸  </a:t>
             </a:r>
             <a:r>
               <a:rPr sz="1600" b="0" i="0">
@@ -6721,14 +7027,14 @@
                 </a:solidFill>
                 <a:latin typeface="Montserrat"/>
               </a:rPr>
-              <a:t>Artículo 3: tres partes + los agentes</a:t>
-            </a:r>
-          </a:p>
-        </p:txBody>
-      </p:sp>
-      <p:sp>
-        <p:nvSpPr>
-          <p:cNvPr id="8" name="imgph" descr="IMGQ:gas pipe wall bracket detail"/>
+              <a:t>Cada aparato, tarado para su gas</a:t>
+            </a:r>
+          </a:p>
+        </p:txBody>
+      </p:sp>
+      <p:sp>
+        <p:nvSpPr>
+          <p:cNvPr id="9" name="imgph" descr="IMGQ:blue gas flame stove burner"/>
           <p:cNvSpPr/>
           <p:nvPr/>
         </p:nvSpPr>
@@ -6774,7 +7080,7 @@
       </p:sp>
       <p:sp>
         <p:nvSpPr>
-          <p:cNvPr id="9" name="TextBox 8"/>
+          <p:cNvPr id="10" name="TextBox 9"/>
           <p:cNvSpPr txBox="1"/>
           <p:nvPr/>
         </p:nvSpPr>
@@ -6814,7 +7120,7 @@
                 </a:solidFill>
                 <a:latin typeface="Montserrat"/>
               </a:rPr>
-              <a:t>gas pipe wall bracket detail</a:t>
+              <a:t>blue gas flame stove burner</a:t>
             </a:r>
           </a:p>
         </p:txBody>
@@ -6852,6 +7158,465 @@
             <a:avLst/>
           </a:prstGeom>
           <a:solidFill>
+            <a:srgbClr val="FFFFFF"/>
+          </a:solidFill>
+          <a:ln>
+            <a:noFill/>
+          </a:ln>
+          <a:effectLst/>
+        </p:spPr>
+        <p:style>
+          <a:lnRef idx="1">
+            <a:schemeClr val="accent1"/>
+          </a:lnRef>
+          <a:fillRef idx="3">
+            <a:schemeClr val="accent1"/>
+          </a:fillRef>
+          <a:effectRef idx="2">
+            <a:schemeClr val="accent1"/>
+          </a:effectRef>
+          <a:fontRef idx="minor">
+            <a:schemeClr val="lt1"/>
+          </a:fontRef>
+        </p:style>
+        <p:txBody>
+          <a:bodyPr rtlCol="0" anchor="ctr"/>
+          <a:lstStyle/>
+          <a:p>
+            <a:pPr algn="ctr"/>
+          </a:p>
+        </p:txBody>
+      </p:sp>
+      <p:sp>
+        <p:nvSpPr>
+          <p:cNvPr id="3" name="TextBox 2"/>
+          <p:cNvSpPr txBox="1"/>
+          <p:nvPr/>
+        </p:nvSpPr>
+        <p:spPr>
+          <a:xfrm>
+            <a:off x="10607040" y="320040"/>
+            <a:ext cx="1371600" cy="365760"/>
+          </a:xfrm>
+          <a:prstGeom prst="rect">
+            <a:avLst/>
+          </a:prstGeom>
+          <a:noFill/>
+        </p:spPr>
+        <p:txBody>
+          <a:bodyPr wrap="square">
+            <a:spAutoFit/>
+          </a:bodyPr>
+          <a:lstStyle/>
+          <a:p>
+            <a:pPr algn="r"/>
+            <a:r>
+              <a:rPr sz="1000" b="1" i="0">
+                <a:solidFill>
+                  <a:srgbClr val="64748B"/>
+                </a:solidFill>
+                <a:latin typeface="Montserrat"/>
+              </a:rPr>
+              <a:t>015 / 016</a:t>
+            </a:r>
+          </a:p>
+        </p:txBody>
+      </p:sp>
+      <p:sp>
+        <p:nvSpPr>
+          <p:cNvPr id="4" name="TextBox 3"/>
+          <p:cNvSpPr txBox="1"/>
+          <p:nvPr/>
+        </p:nvSpPr>
+        <p:spPr>
+          <a:xfrm>
+            <a:off x="457200" y="6419088"/>
+            <a:ext cx="8229600" cy="365760"/>
+          </a:xfrm>
+          <a:prstGeom prst="rect">
+            <a:avLst/>
+          </a:prstGeom>
+          <a:noFill/>
+        </p:spPr>
+        <p:txBody>
+          <a:bodyPr wrap="square">
+            <a:spAutoFit/>
+          </a:bodyPr>
+          <a:lstStyle/>
+          <a:p>
+            <a:r>
+              <a:rPr sz="900" b="0" i="0">
+                <a:solidFill>
+                  <a:srgbClr val="64748B"/>
+                </a:solidFill>
+                <a:latin typeface="Montserrat"/>
+              </a:rPr>
+              <a:t>Curso Gas B · Tema 00 · El Reglamento de Gas</a:t>
+            </a:r>
+          </a:p>
+        </p:txBody>
+      </p:sp>
+      <p:sp>
+        <p:nvSpPr>
+          <p:cNvPr id="5" name="TextBox 4"/>
+          <p:cNvSpPr txBox="1"/>
+          <p:nvPr/>
+        </p:nvSpPr>
+        <p:spPr>
+          <a:xfrm>
+            <a:off x="822960" y="457200"/>
+            <a:ext cx="10058400" cy="365760"/>
+          </a:xfrm>
+          <a:prstGeom prst="rect">
+            <a:avLst/>
+          </a:prstGeom>
+          <a:noFill/>
+        </p:spPr>
+        <p:txBody>
+          <a:bodyPr wrap="square">
+            <a:spAutoFit/>
+          </a:bodyPr>
+          <a:lstStyle/>
+          <a:p>
+            <a:r>
+              <a:rPr sz="1300" b="1" i="0">
+                <a:solidFill>
+                  <a:srgbClr val="E8801A"/>
+                </a:solidFill>
+                <a:latin typeface="Montserrat"/>
+              </a:rPr>
+              <a:t>REPASO RELÁMPAGO</a:t>
+            </a:r>
+          </a:p>
+        </p:txBody>
+      </p:sp>
+      <p:sp>
+        <p:nvSpPr>
+          <p:cNvPr id="6" name="TextBox 5"/>
+          <p:cNvSpPr txBox="1"/>
+          <p:nvPr/>
+        </p:nvSpPr>
+        <p:spPr>
+          <a:xfrm>
+            <a:off x="822960" y="868680"/>
+            <a:ext cx="10515600" cy="914400"/>
+          </a:xfrm>
+          <a:prstGeom prst="rect">
+            <a:avLst/>
+          </a:prstGeom>
+          <a:noFill/>
+        </p:spPr>
+        <p:txBody>
+          <a:bodyPr wrap="square">
+            <a:spAutoFit/>
+          </a:bodyPr>
+          <a:lstStyle/>
+          <a:p>
+            <a:r>
+              <a:rPr sz="2800" b="1" i="0">
+                <a:solidFill>
+                  <a:srgbClr val="1E2761"/>
+                </a:solidFill>
+                <a:latin typeface="Montserrat"/>
+              </a:rPr>
+              <a:t>Fíjalo en treinta segundos</a:t>
+            </a:r>
+          </a:p>
+        </p:txBody>
+      </p:sp>
+      <p:sp>
+        <p:nvSpPr>
+          <p:cNvPr id="7" name="Rounded Rectangle 6"/>
+          <p:cNvSpPr/>
+          <p:nvPr/>
+        </p:nvSpPr>
+        <p:spPr>
+          <a:xfrm>
+            <a:off x="868680" y="1627632"/>
+            <a:ext cx="2011680" cy="73152"/>
+          </a:xfrm>
+          <a:prstGeom prst="roundRect">
+            <a:avLst/>
+          </a:prstGeom>
+          <a:solidFill>
+            <a:srgbClr val="E8801A"/>
+          </a:solidFill>
+          <a:ln>
+            <a:noFill/>
+          </a:ln>
+          <a:effectLst/>
+        </p:spPr>
+        <p:style>
+          <a:lnRef idx="1">
+            <a:schemeClr val="accent1"/>
+          </a:lnRef>
+          <a:fillRef idx="3">
+            <a:schemeClr val="accent1"/>
+          </a:fillRef>
+          <a:effectRef idx="2">
+            <a:schemeClr val="accent1"/>
+          </a:effectRef>
+          <a:fontRef idx="minor">
+            <a:schemeClr val="lt1"/>
+          </a:fontRef>
+        </p:style>
+        <p:txBody>
+          <a:bodyPr rtlCol="0" anchor="ctr"/>
+          <a:lstStyle/>
+          <a:p>
+            <a:pPr algn="ctr"/>
+          </a:p>
+        </p:txBody>
+      </p:sp>
+      <p:sp>
+        <p:nvSpPr>
+          <p:cNvPr id="8" name="TextBox 7"/>
+          <p:cNvSpPr txBox="1"/>
+          <p:nvPr/>
+        </p:nvSpPr>
+        <p:spPr>
+          <a:xfrm>
+            <a:off x="822960" y="1965960"/>
+            <a:ext cx="4983480" cy="4206240"/>
+          </a:xfrm>
+          <a:prstGeom prst="rect">
+            <a:avLst/>
+          </a:prstGeom>
+          <a:noFill/>
+        </p:spPr>
+        <p:txBody>
+          <a:bodyPr wrap="square">
+            <a:spAutoFit/>
+          </a:bodyPr>
+          <a:lstStyle/>
+          <a:p>
+            <a:pPr>
+              <a:spcAft>
+                <a:spcPts val="1100"/>
+              </a:spcAft>
+            </a:pPr>
+            <a:r>
+              <a:rPr sz="1600" b="1" i="0">
+                <a:solidFill>
+                  <a:srgbClr val="E8801A"/>
+                </a:solidFill>
+                <a:latin typeface="Montserrat"/>
+              </a:rPr>
+              <a:t>▸  </a:t>
+            </a:r>
+            <a:r>
+              <a:rPr sz="1600" b="0" i="0">
+                <a:solidFill>
+                  <a:srgbClr val="1B2330"/>
+                </a:solidFill>
+                <a:latin typeface="Montserrat"/>
+              </a:rPr>
+              <a:t>Reglamento = tronco; ITC = ramas</a:t>
+            </a:r>
+          </a:p>
+          <a:p>
+            <a:pPr>
+              <a:spcAft>
+                <a:spcPts val="1100"/>
+              </a:spcAft>
+            </a:pPr>
+            <a:r>
+              <a:rPr sz="1600" b="1" i="0">
+                <a:solidFill>
+                  <a:srgbClr val="E8801A"/>
+                </a:solidFill>
+                <a:latin typeface="Montserrat"/>
+              </a:rPr>
+              <a:t>▸  </a:t>
+            </a:r>
+            <a:r>
+              <a:rPr sz="1600" b="0" i="0">
+                <a:solidFill>
+                  <a:srgbClr val="1B2330"/>
+                </a:solidFill>
+                <a:latin typeface="Montserrat"/>
+              </a:rPr>
+              <a:t>Nueve tipos; la h son tus receptoras</a:t>
+            </a:r>
+          </a:p>
+          <a:p>
+            <a:pPr>
+              <a:spcAft>
+                <a:spcPts val="1100"/>
+              </a:spcAft>
+            </a:pPr>
+            <a:r>
+              <a:rPr sz="1600" b="1" i="0">
+                <a:solidFill>
+                  <a:srgbClr val="E8801A"/>
+                </a:solidFill>
+                <a:latin typeface="Montserrat"/>
+              </a:rPr>
+              <a:t>▸  </a:t>
+            </a:r>
+            <a:r>
+              <a:rPr sz="1600" b="0" i="0">
+                <a:solidFill>
+                  <a:srgbClr val="1B2330"/>
+                </a:solidFill>
+                <a:latin typeface="Montserrat"/>
+              </a:rPr>
+              <a:t>Receptora: de acometida a llave de aparato</a:t>
+            </a:r>
+          </a:p>
+          <a:p>
+            <a:pPr>
+              <a:spcAft>
+                <a:spcPts val="1100"/>
+              </a:spcAft>
+            </a:pPr>
+            <a:r>
+              <a:rPr sz="1600" b="1" i="0">
+                <a:solidFill>
+                  <a:srgbClr val="E8801A"/>
+                </a:solidFill>
+                <a:latin typeface="Montserrat"/>
+              </a:rPr>
+              <a:t>▸  </a:t>
+            </a:r>
+            <a:r>
+              <a:rPr sz="1600" b="0" i="0">
+                <a:solidFill>
+                  <a:srgbClr val="1B2330"/>
+                </a:solidFill>
+                <a:latin typeface="Montserrat"/>
+              </a:rPr>
+              <a:t>Artículo 3: tres partes + los agentes</a:t>
+            </a:r>
+          </a:p>
+        </p:txBody>
+      </p:sp>
+      <p:sp>
+        <p:nvSpPr>
+          <p:cNvPr id="9" name="imgph" descr="IMGQ:gas pipe wall bracket detail"/>
+          <p:cNvSpPr/>
+          <p:nvPr/>
+        </p:nvSpPr>
+        <p:spPr>
+          <a:xfrm>
+            <a:off x="5806440" y="1051560"/>
+            <a:ext cx="5298947" cy="4629150"/>
+          </a:xfrm>
+          <a:prstGeom prst="roundRect">
+            <a:avLst/>
+          </a:prstGeom>
+          <a:solidFill>
+            <a:srgbClr val="F3F6FB"/>
+          </a:solidFill>
+          <a:ln w="12700">
+            <a:solidFill>
+              <a:srgbClr val="C7D2E6"/>
+            </a:solidFill>
+          </a:ln>
+          <a:effectLst/>
+        </p:spPr>
+        <p:style>
+          <a:lnRef idx="1">
+            <a:schemeClr val="accent1"/>
+          </a:lnRef>
+          <a:fillRef idx="3">
+            <a:schemeClr val="accent1"/>
+          </a:fillRef>
+          <a:effectRef idx="2">
+            <a:schemeClr val="accent1"/>
+          </a:effectRef>
+          <a:fontRef idx="minor">
+            <a:schemeClr val="lt1"/>
+          </a:fontRef>
+        </p:style>
+        <p:txBody>
+          <a:bodyPr rtlCol="0" anchor="ctr"/>
+          <a:lstStyle/>
+          <a:p>
+            <a:pPr algn="ctr"/>
+          </a:p>
+        </p:txBody>
+      </p:sp>
+      <p:sp>
+        <p:nvSpPr>
+          <p:cNvPr id="10" name="TextBox 9"/>
+          <p:cNvSpPr txBox="1"/>
+          <p:nvPr/>
+        </p:nvSpPr>
+        <p:spPr>
+          <a:xfrm>
+            <a:off x="6080760" y="2726055"/>
+            <a:ext cx="4750307" cy="1280160"/>
+          </a:xfrm>
+          <a:prstGeom prst="rect">
+            <a:avLst/>
+          </a:prstGeom>
+          <a:noFill/>
+        </p:spPr>
+        <p:txBody>
+          <a:bodyPr wrap="square">
+            <a:spAutoFit/>
+          </a:bodyPr>
+          <a:lstStyle/>
+          <a:p>
+            <a:pPr algn="ctr"/>
+            <a:r>
+              <a:rPr sz="1400" b="1" i="0">
+                <a:solidFill>
+                  <a:srgbClr val="64748B"/>
+                </a:solidFill>
+                <a:latin typeface="Montserrat"/>
+              </a:rPr>
+              <a:t>IMAGEN REALISTA</a:t>
+            </a:r>
+          </a:p>
+          <a:p>
+            <a:pPr algn="ctr"/>
+            <a:r>
+              <a:rPr sz="1100" b="0" i="1">
+                <a:solidFill>
+                  <a:srgbClr val="64748B"/>
+                </a:solidFill>
+                <a:latin typeface="Montserrat"/>
+              </a:rPr>
+              <a:t>gas pipe wall bracket detail</a:t>
+            </a:r>
+          </a:p>
+        </p:txBody>
+      </p:sp>
+    </p:spTree>
+  </p:cSld>
+  <p:clrMapOvr>
+    <a:masterClrMapping/>
+  </p:clrMapOvr>
+</p:sld>
+</file>
+
+<file path=ppt/slides/slide16.xml><?xml version="1.0" encoding="utf-8"?>
+<p:sld xmlns:a="http://schemas.openxmlformats.org/drawingml/2006/main" xmlns:p="http://schemas.openxmlformats.org/presentationml/2006/main" xmlns:r="http://schemas.openxmlformats.org/officeDocument/2006/relationships">
+  <p:cSld>
+    <p:spTree>
+      <p:nvGrpSpPr>
+        <p:cNvPr id="1" name=""/>
+        <p:cNvGrpSpPr/>
+        <p:nvPr/>
+      </p:nvGrpSpPr>
+      <p:grpSpPr/>
+      <p:sp>
+        <p:nvSpPr>
+          <p:cNvPr id="2" name="Rectangle 1"/>
+          <p:cNvSpPr/>
+          <p:nvPr/>
+        </p:nvSpPr>
+        <p:spPr>
+          <a:xfrm>
+            <a:off x="0" y="0"/>
+            <a:ext cx="12191695" cy="6858000"/>
+          </a:xfrm>
+          <a:prstGeom prst="rect">
+            <a:avLst/>
+          </a:prstGeom>
+          <a:solidFill>
             <a:srgbClr val="1E2761"/>
           </a:solidFill>
           <a:ln>
@@ -6906,7 +7671,7 @@
             <a:r>
               <a:rPr sz="1400" b="1" i="0">
                 <a:solidFill>
-                  <a:srgbClr val="CADCFC"/>
+                  <a:srgbClr val="F4A24C"/>
                 </a:solidFill>
                 <a:latin typeface="Montserrat"/>
               </a:rPr>
@@ -6917,13 +7682,57 @@
       </p:sp>
       <p:sp>
         <p:nvSpPr>
-          <p:cNvPr id="4" name="TextBox 3"/>
+          <p:cNvPr id="4" name="Rounded Rectangle 3"/>
+          <p:cNvSpPr/>
+          <p:nvPr/>
+        </p:nvSpPr>
+        <p:spPr>
+          <a:xfrm>
+            <a:off x="868680" y="1051560"/>
+            <a:ext cx="1463040" cy="82296"/>
+          </a:xfrm>
+          <a:prstGeom prst="roundRect">
+            <a:avLst/>
+          </a:prstGeom>
+          <a:solidFill>
+            <a:srgbClr val="E8801A"/>
+          </a:solidFill>
+          <a:ln>
+            <a:noFill/>
+          </a:ln>
+          <a:effectLst/>
+        </p:spPr>
+        <p:style>
+          <a:lnRef idx="1">
+            <a:schemeClr val="accent1"/>
+          </a:lnRef>
+          <a:fillRef idx="3">
+            <a:schemeClr val="accent1"/>
+          </a:fillRef>
+          <a:effectRef idx="2">
+            <a:schemeClr val="accent1"/>
+          </a:effectRef>
+          <a:fontRef idx="minor">
+            <a:schemeClr val="lt1"/>
+          </a:fontRef>
+        </p:style>
+        <p:txBody>
+          <a:bodyPr rtlCol="0" anchor="ctr"/>
+          <a:lstStyle/>
+          <a:p>
+            <a:pPr algn="ctr"/>
+          </a:p>
+        </p:txBody>
+      </p:sp>
+      <p:sp>
+        <p:nvSpPr>
+          <p:cNvPr id="5" name="TextBox 4"/>
           <p:cNvSpPr txBox="1"/>
           <p:nvPr/>
         </p:nvSpPr>
         <p:spPr>
           <a:xfrm>
-            <a:off x="822960" y="1143000"/>
+            <a:off x="822960" y="1234440"/>
             <a:ext cx="10515600" cy="1097280"/>
           </a:xfrm>
           <a:prstGeom prst="rect">
@@ -6951,14 +7760,14 @@
       </p:sp>
       <p:sp>
         <p:nvSpPr>
-          <p:cNvPr id="5" name="TextBox 4"/>
+          <p:cNvPr id="6" name="TextBox 5"/>
           <p:cNvSpPr txBox="1"/>
           <p:nvPr/>
         </p:nvSpPr>
         <p:spPr>
           <a:xfrm>
-            <a:off x="822960" y="2514600"/>
-            <a:ext cx="10515600" cy="2834640"/>
+            <a:off x="822960" y="2606040"/>
+            <a:ext cx="10515600" cy="2743200"/>
           </a:xfrm>
           <a:prstGeom prst="rect">
             <a:avLst/>
@@ -6979,7 +7788,7 @@
             <a:r>
               <a:rPr sz="2000" b="1" i="0">
                 <a:solidFill>
-                  <a:srgbClr val="CADCFC"/>
+                  <a:srgbClr val="F4A24C"/>
                 </a:solidFill>
                 <a:latin typeface="Montserrat"/>
               </a:rPr>
@@ -7004,7 +7813,7 @@
             <a:r>
               <a:rPr sz="2000" b="1" i="0">
                 <a:solidFill>
-                  <a:srgbClr val="CADCFC"/>
+                  <a:srgbClr val="F4A24C"/>
                 </a:solidFill>
                 <a:latin typeface="Montserrat"/>
               </a:rPr>
@@ -7029,7 +7838,7 @@
             <a:r>
               <a:rPr sz="2000" b="1" i="0">
                 <a:solidFill>
-                  <a:srgbClr val="CADCFC"/>
+                  <a:srgbClr val="F4A24C"/>
                 </a:solidFill>
                 <a:latin typeface="Montserrat"/>
               </a:rPr>
@@ -7054,7 +7863,7 @@
             <a:r>
               <a:rPr sz="2000" b="1" i="0">
                 <a:solidFill>
-                  <a:srgbClr val="CADCFC"/>
+                  <a:srgbClr val="F4A24C"/>
                 </a:solidFill>
                 <a:latin typeface="Montserrat"/>
               </a:rPr>
@@ -7074,20 +7883,20 @@
       </p:sp>
       <p:sp>
         <p:nvSpPr>
-          <p:cNvPr id="6" name="Rounded Rectangle 5"/>
+          <p:cNvPr id="7" name="Rounded Rectangle 6"/>
           <p:cNvSpPr/>
           <p:nvPr/>
         </p:nvSpPr>
         <p:spPr>
           <a:xfrm>
             <a:off x="822960" y="5532120"/>
-            <a:ext cx="10515600" cy="777240"/>
+            <a:ext cx="10515600" cy="822960"/>
           </a:xfrm>
           <a:prstGeom prst="roundRect">
             <a:avLst/>
           </a:prstGeom>
           <a:solidFill>
-            <a:srgbClr val="2E3A80"/>
+            <a:srgbClr val="E8801A"/>
           </a:solidFill>
           <a:ln>
             <a:noFill/>
@@ -7118,13 +7927,13 @@
       </p:sp>
       <p:sp>
         <p:nvSpPr>
-          <p:cNvPr id="7" name="TextBox 6"/>
+          <p:cNvPr id="8" name="TextBox 7"/>
           <p:cNvSpPr txBox="1"/>
           <p:nvPr/>
         </p:nvSpPr>
         <p:spPr>
           <a:xfrm>
-            <a:off x="1051560" y="5605272"/>
+            <a:off x="1051560" y="5623560"/>
             <a:ext cx="10058400" cy="640080"/>
           </a:xfrm>
           <a:prstGeom prst="rect">
@@ -7141,7 +7950,7 @@
             <a:r>
               <a:rPr sz="1500" b="1" i="1">
                 <a:solidFill>
-                  <a:srgbClr val="CADCFC"/>
+                  <a:srgbClr val="1E2761"/>
                 </a:solidFill>
                 <a:latin typeface="Montserrat"/>
               </a:rPr>
@@ -7242,7 +8051,7 @@
                 </a:solidFill>
                 <a:latin typeface="Montserrat"/>
               </a:rPr>
-              <a:t>002 / 015</a:t>
+              <a:t>002 / 016</a:t>
             </a:r>
           </a:p>
         </p:txBody>
@@ -7306,7 +8115,7 @@
             <a:r>
               <a:rPr sz="2700" b="1" i="0">
                 <a:solidFill>
-                  <a:srgbClr val="1E2761"/>
+                  <a:srgbClr val="E8801A"/>
                 </a:solidFill>
                 <a:latin typeface="Montserrat"/>
               </a:rPr>
@@ -7318,6 +8127,50 @@
       <p:sp>
         <p:nvSpPr>
           <p:cNvPr id="6" name="Rounded Rectangle 5"/>
+          <p:cNvSpPr/>
+          <p:nvPr/>
+        </p:nvSpPr>
+        <p:spPr>
+          <a:xfrm>
+            <a:off x="868680" y="1234440"/>
+            <a:ext cx="1463040" cy="73152"/>
+          </a:xfrm>
+          <a:prstGeom prst="roundRect">
+            <a:avLst/>
+          </a:prstGeom>
+          <a:solidFill>
+            <a:srgbClr val="1E2761"/>
+          </a:solidFill>
+          <a:ln>
+            <a:noFill/>
+          </a:ln>
+          <a:effectLst/>
+        </p:spPr>
+        <p:style>
+          <a:lnRef idx="1">
+            <a:schemeClr val="accent1"/>
+          </a:lnRef>
+          <a:fillRef idx="3">
+            <a:schemeClr val="accent1"/>
+          </a:fillRef>
+          <a:effectRef idx="2">
+            <a:schemeClr val="accent1"/>
+          </a:effectRef>
+          <a:fontRef idx="minor">
+            <a:schemeClr val="lt1"/>
+          </a:fontRef>
+        </p:style>
+        <p:txBody>
+          <a:bodyPr rtlCol="0" anchor="ctr"/>
+          <a:lstStyle/>
+          <a:p>
+            <a:pPr algn="ctr"/>
+          </a:p>
+        </p:txBody>
+      </p:sp>
+      <p:sp>
+        <p:nvSpPr>
+          <p:cNvPr id="7" name="Rounded Rectangle 6"/>
           <p:cNvSpPr/>
           <p:nvPr/>
         </p:nvSpPr>
@@ -7363,7 +8216,7 @@
       </p:sp>
       <p:sp>
         <p:nvSpPr>
-          <p:cNvPr id="7" name="TextBox 6"/>
+          <p:cNvPr id="8" name="TextBox 7"/>
           <p:cNvSpPr txBox="1"/>
           <p:nvPr/>
         </p:nvSpPr>
@@ -7398,7 +8251,7 @@
       </p:sp>
       <p:sp>
         <p:nvSpPr>
-          <p:cNvPr id="8" name="TextBox 7"/>
+          <p:cNvPr id="9" name="TextBox 8"/>
           <p:cNvSpPr txBox="1"/>
           <p:nvPr/>
         </p:nvSpPr>
@@ -7433,7 +8286,7 @@
       </p:sp>
       <p:sp>
         <p:nvSpPr>
-          <p:cNvPr id="9" name="Rounded Rectangle 8"/>
+          <p:cNvPr id="10" name="Rounded Rectangle 9"/>
           <p:cNvSpPr/>
           <p:nvPr/>
         </p:nvSpPr>
@@ -7479,7 +8332,7 @@
       </p:sp>
       <p:sp>
         <p:nvSpPr>
-          <p:cNvPr id="10" name="TextBox 9"/>
+          <p:cNvPr id="11" name="TextBox 10"/>
           <p:cNvSpPr txBox="1"/>
           <p:nvPr/>
         </p:nvSpPr>
@@ -7514,7 +8367,7 @@
       </p:sp>
       <p:sp>
         <p:nvSpPr>
-          <p:cNvPr id="11" name="TextBox 10"/>
+          <p:cNvPr id="12" name="TextBox 11"/>
           <p:cNvSpPr txBox="1"/>
           <p:nvPr/>
         </p:nvSpPr>
@@ -7549,7 +8402,7 @@
       </p:sp>
       <p:sp>
         <p:nvSpPr>
-          <p:cNvPr id="12" name="Rounded Rectangle 11"/>
+          <p:cNvPr id="13" name="Rounded Rectangle 12"/>
           <p:cNvSpPr/>
           <p:nvPr/>
         </p:nvSpPr>
@@ -7595,7 +8448,7 @@
       </p:sp>
       <p:sp>
         <p:nvSpPr>
-          <p:cNvPr id="13" name="TextBox 12"/>
+          <p:cNvPr id="14" name="TextBox 13"/>
           <p:cNvSpPr txBox="1"/>
           <p:nvPr/>
         </p:nvSpPr>
@@ -7630,7 +8483,7 @@
       </p:sp>
       <p:sp>
         <p:nvSpPr>
-          <p:cNvPr id="14" name="TextBox 13"/>
+          <p:cNvPr id="15" name="TextBox 14"/>
           <p:cNvSpPr txBox="1"/>
           <p:nvPr/>
         </p:nvSpPr>
@@ -7755,7 +8608,7 @@
                 </a:solidFill>
                 <a:latin typeface="Montserrat"/>
               </a:rPr>
-              <a:t>003 / 015</a:t>
+              <a:t>003 / 016</a:t>
             </a:r>
           </a:p>
         </p:txBody>
@@ -7802,7 +8655,7 @@
         </p:nvSpPr>
         <p:spPr>
           <a:xfrm>
-            <a:off x="822960" y="457200"/>
+            <a:off x="822960" y="502920"/>
             <a:ext cx="8229600" cy="365760"/>
           </a:xfrm>
           <a:prstGeom prst="rect">
@@ -7817,13 +8670,13 @@
           <a:lstStyle/>
           <a:p>
             <a:r>
-              <a:rPr sz="1200" b="1" i="0">
-                <a:solidFill>
-                  <a:srgbClr val="64748B"/>
-                </a:solidFill>
-                <a:latin typeface="Montserrat"/>
-              </a:rPr>
-              <a:t>ARTÍCULO 1 · OBJETO</a:t>
+              <a:rPr sz="1300" b="1" i="0">
+                <a:solidFill>
+                  <a:srgbClr val="E8801A"/>
+                </a:solidFill>
+                <a:latin typeface="Montserrat"/>
+              </a:rPr>
+              <a:t>PARTES DE ESTE VÍDEO</a:t>
             </a:r>
           </a:p>
         </p:txBody>
@@ -7836,7 +8689,7 @@
         </p:nvSpPr>
         <p:spPr>
           <a:xfrm>
-            <a:off x="822960" y="868680"/>
+            <a:off x="822960" y="914400"/>
             <a:ext cx="10515600" cy="914400"/>
           </a:xfrm>
           <a:prstGeom prst="rect">
@@ -7857,130 +8710,30 @@
                 </a:solidFill>
                 <a:latin typeface="Montserrat"/>
               </a:rPr>
-              <a:t>¿Para qué existe el Reglamento?</a:t>
-            </a:r>
-          </a:p>
-        </p:txBody>
-      </p:sp>
-      <p:sp>
-        <p:nvSpPr>
-          <p:cNvPr id="7" name="TextBox 6"/>
-          <p:cNvSpPr txBox="1"/>
-          <p:nvPr/>
-        </p:nvSpPr>
-        <p:spPr>
-          <a:xfrm>
-            <a:off x="822960" y="1920240"/>
-            <a:ext cx="4983480" cy="4206240"/>
-          </a:xfrm>
-          <a:prstGeom prst="rect">
-            <a:avLst/>
-          </a:prstGeom>
-          <a:noFill/>
-        </p:spPr>
-        <p:txBody>
-          <a:bodyPr wrap="square">
-            <a:spAutoFit/>
-          </a:bodyPr>
-          <a:lstStyle/>
-          <a:p>
-            <a:pPr>
-              <a:spcAft>
-                <a:spcPts val="1000"/>
-              </a:spcAft>
-            </a:pPr>
-            <a:r>
-              <a:rPr sz="1600" b="1" i="0">
-                <a:solidFill>
-                  <a:srgbClr val="2E3A80"/>
-                </a:solidFill>
-                <a:latin typeface="Montserrat"/>
-              </a:rPr>
-              <a:t>•  </a:t>
-            </a:r>
-            <a:r>
-              <a:rPr sz="1600" b="0" i="0">
-                <a:solidFill>
-                  <a:srgbClr val="1B2330"/>
-                </a:solidFill>
-                <a:latin typeface="Montserrat"/>
-              </a:rPr>
-              <a:t>Fija condiciones técnicas y garantías</a:t>
-            </a:r>
-          </a:p>
-          <a:p>
-            <a:pPr>
-              <a:spcAft>
-                <a:spcPts val="1000"/>
-              </a:spcAft>
-            </a:pPr>
-            <a:r>
-              <a:rPr sz="1600" b="1" i="0">
-                <a:solidFill>
-                  <a:srgbClr val="2E3A80"/>
-                </a:solidFill>
-                <a:latin typeface="Montserrat"/>
-              </a:rPr>
-              <a:t>•  </a:t>
-            </a:r>
-            <a:r>
-              <a:rPr sz="1600" b="0" i="0">
-                <a:solidFill>
-                  <a:srgbClr val="1B2330"/>
-                </a:solidFill>
-                <a:latin typeface="Montserrat"/>
-              </a:rPr>
-              <a:t>Sobre instalaciones y aparatos de gas</a:t>
-            </a:r>
-          </a:p>
-          <a:p>
-            <a:pPr>
-              <a:spcAft>
-                <a:spcPts val="1000"/>
-              </a:spcAft>
-            </a:pPr>
-            <a:r>
-              <a:rPr sz="1600" b="1" i="0">
-                <a:solidFill>
-                  <a:srgbClr val="2E3A80"/>
-                </a:solidFill>
-                <a:latin typeface="Montserrat"/>
-              </a:rPr>
-              <a:t>•  </a:t>
-            </a:r>
-            <a:r>
-              <a:rPr sz="1600" b="0" i="0">
-                <a:solidFill>
-                  <a:srgbClr val="1B2330"/>
-                </a:solidFill>
-                <a:latin typeface="Montserrat"/>
-              </a:rPr>
-              <a:t>Fin único: seguridad de personas y bienes</a:t>
-            </a:r>
-          </a:p>
-        </p:txBody>
-      </p:sp>
-      <p:sp>
-        <p:nvSpPr>
-          <p:cNvPr id="8" name="imgph" descr="IMGQ:gas boiler installation kitchen wall"/>
+              <a:t>En este vídeo</a:t>
+            </a:r>
+          </a:p>
+        </p:txBody>
+      </p:sp>
+      <p:sp>
+        <p:nvSpPr>
+          <p:cNvPr id="7" name="Rounded Rectangle 6"/>
           <p:cNvSpPr/>
           <p:nvPr/>
         </p:nvSpPr>
         <p:spPr>
           <a:xfrm>
-            <a:off x="5806440" y="1051560"/>
-            <a:ext cx="5298947" cy="4629150"/>
+            <a:off x="868680" y="1673352"/>
+            <a:ext cx="2011680" cy="73152"/>
           </a:xfrm>
           <a:prstGeom prst="roundRect">
             <a:avLst/>
           </a:prstGeom>
           <a:solidFill>
-            <a:srgbClr val="F3F6FB"/>
+            <a:srgbClr val="E8801A"/>
           </a:solidFill>
-          <a:ln w="12700">
-            <a:solidFill>
-              <a:srgbClr val="C7D2E6"/>
-            </a:solidFill>
+          <a:ln>
+            <a:noFill/>
           </a:ln>
           <a:effectLst/>
         </p:spPr>
@@ -8008,14 +8761,14 @@
       </p:sp>
       <p:sp>
         <p:nvSpPr>
-          <p:cNvPr id="9" name="TextBox 8"/>
+          <p:cNvPr id="8" name="TextBox 7"/>
           <p:cNvSpPr txBox="1"/>
           <p:nvPr/>
         </p:nvSpPr>
         <p:spPr>
           <a:xfrm>
-            <a:off x="6080760" y="2726055"/>
-            <a:ext cx="4750307" cy="1280160"/>
+            <a:off x="822960" y="2103120"/>
+            <a:ext cx="10515600" cy="4023360"/>
           </a:xfrm>
           <a:prstGeom prst="rect">
             <a:avLst/>
@@ -8028,27 +8781,103 @@
           </a:bodyPr>
           <a:lstStyle/>
           <a:p>
-            <a:pPr algn="ctr"/>
-            <a:r>
-              <a:rPr sz="1400" b="1" i="0">
-                <a:solidFill>
-                  <a:srgbClr val="64748B"/>
-                </a:solidFill>
-                <a:latin typeface="Montserrat"/>
-              </a:rPr>
-              <a:t>IMAGEN REALISTA</a:t>
-            </a:r>
-          </a:p>
-          <a:p>
-            <a:pPr algn="ctr"/>
-            <a:r>
-              <a:rPr sz="1100" b="0" i="1">
-                <a:solidFill>
-                  <a:srgbClr val="64748B"/>
-                </a:solidFill>
-                <a:latin typeface="Montserrat"/>
-              </a:rPr>
-              <a:t>gas boiler installation kitchen wall</a:t>
+            <a:pPr>
+              <a:spcAft>
+                <a:spcPts val="900"/>
+              </a:spcAft>
+            </a:pPr>
+            <a:r>
+              <a:rPr sz="1800" b="1" i="0">
+                <a:solidFill>
+                  <a:srgbClr val="E8801A"/>
+                </a:solidFill>
+                <a:latin typeface="Montserrat"/>
+              </a:rPr>
+              <a:t>01   </a:t>
+            </a:r>
+            <a:r>
+              <a:rPr sz="1700" b="0" i="0">
+                <a:solidFill>
+                  <a:srgbClr val="1B2330"/>
+                </a:solidFill>
+                <a:latin typeface="Montserrat"/>
+              </a:rPr>
+              <a:t>Artículo 1</a:t>
+            </a:r>
+          </a:p>
+          <a:p>
+            <a:pPr>
+              <a:spcAft>
+                <a:spcPts val="900"/>
+              </a:spcAft>
+            </a:pPr>
+            <a:r>
+              <a:rPr sz="1800" b="1" i="0">
+                <a:solidFill>
+                  <a:srgbClr val="E8801A"/>
+                </a:solidFill>
+                <a:latin typeface="Montserrat"/>
+              </a:rPr>
+              <a:t>02   </a:t>
+            </a:r>
+            <a:r>
+              <a:rPr sz="1700" b="0" i="0">
+                <a:solidFill>
+                  <a:srgbClr val="1B2330"/>
+                </a:solidFill>
+                <a:latin typeface="Montserrat"/>
+              </a:rPr>
+              <a:t>Artículo 2</a:t>
+            </a:r>
+          </a:p>
+          <a:p>
+            <a:pPr>
+              <a:spcAft>
+                <a:spcPts val="900"/>
+              </a:spcAft>
+            </a:pPr>
+            <a:r>
+              <a:rPr sz="1800" b="1" i="0">
+                <a:solidFill>
+                  <a:srgbClr val="E8801A"/>
+                </a:solidFill>
+                <a:latin typeface="Montserrat"/>
+              </a:rPr>
+              <a:t>03   </a:t>
+            </a:r>
+            <a:r>
+              <a:rPr sz="1700" b="0" i="0">
+                <a:solidFill>
+                  <a:srgbClr val="1B2330"/>
+                </a:solidFill>
+                <a:latin typeface="Montserrat"/>
+              </a:rPr>
+              <a:t>Artículo 3</a:t>
+            </a:r>
+          </a:p>
+          <a:p>
+            <a:pPr>
+              <a:spcAft>
+                <a:spcPts val="900"/>
+              </a:spcAft>
+            </a:pPr>
+            <a:r>
+              <a:rPr sz="1800" b="1" i="0">
+                <a:solidFill>
+                  <a:srgbClr val="E8801A"/>
+                </a:solidFill>
+                <a:latin typeface="Montserrat"/>
+              </a:rPr>
+              <a:t>04   </a:t>
+            </a:r>
+            <a:r>
+              <a:rPr sz="1700" b="0" i="0">
+                <a:solidFill>
+                  <a:srgbClr val="1B2330"/>
+                </a:solidFill>
+                <a:latin typeface="Montserrat"/>
+              </a:rPr>
+              <a:t>Repaso relámpago</a:t>
             </a:r>
           </a:p>
         </p:txBody>
@@ -8145,7 +8974,7 @@
                 </a:solidFill>
                 <a:latin typeface="Montserrat"/>
               </a:rPr>
-              <a:t>004 / 015</a:t>
+              <a:t>004 / 016</a:t>
             </a:r>
           </a:p>
         </p:txBody>
@@ -8193,7 +9022,7 @@
         <p:spPr>
           <a:xfrm>
             <a:off x="822960" y="457200"/>
-            <a:ext cx="8229600" cy="365760"/>
+            <a:ext cx="10058400" cy="365760"/>
           </a:xfrm>
           <a:prstGeom prst="rect">
             <a:avLst/>
@@ -8207,13 +9036,13 @@
           <a:lstStyle/>
           <a:p>
             <a:r>
-              <a:rPr sz="1200" b="1" i="0">
-                <a:solidFill>
-                  <a:srgbClr val="64748B"/>
-                </a:solidFill>
-                <a:latin typeface="Montserrat"/>
-              </a:rPr>
-              <a:t>ARTÍCULO 1 · ESTRUCTURA</a:t>
+              <a:rPr sz="1300" b="1" i="0">
+                <a:solidFill>
+                  <a:srgbClr val="E8801A"/>
+                </a:solidFill>
+                <a:latin typeface="Montserrat"/>
+              </a:rPr>
+              <a:t>ARTÍCULO 1 · OBJETO</a:t>
             </a:r>
           </a:p>
         </p:txBody>
@@ -8241,26 +9070,70 @@
           <a:lstStyle/>
           <a:p>
             <a:r>
-              <a:rPr sz="2700" b="1" i="0">
+              <a:rPr sz="2800" b="1" i="0">
                 <a:solidFill>
                   <a:srgbClr val="1E2761"/>
                 </a:solidFill>
                 <a:latin typeface="Montserrat"/>
               </a:rPr>
-              <a:t>El tronco y las ramas</a:t>
-            </a:r>
-          </a:p>
-        </p:txBody>
-      </p:sp>
-      <p:sp>
-        <p:nvSpPr>
-          <p:cNvPr id="7" name="TextBox 6"/>
+              <a:t>¿Para qué existe el Reglamento?</a:t>
+            </a:r>
+          </a:p>
+        </p:txBody>
+      </p:sp>
+      <p:sp>
+        <p:nvSpPr>
+          <p:cNvPr id="7" name="Rounded Rectangle 6"/>
+          <p:cNvSpPr/>
+          <p:nvPr/>
+        </p:nvSpPr>
+        <p:spPr>
+          <a:xfrm>
+            <a:off x="868680" y="1627632"/>
+            <a:ext cx="2011680" cy="73152"/>
+          </a:xfrm>
+          <a:prstGeom prst="roundRect">
+            <a:avLst/>
+          </a:prstGeom>
+          <a:solidFill>
+            <a:srgbClr val="E8801A"/>
+          </a:solidFill>
+          <a:ln>
+            <a:noFill/>
+          </a:ln>
+          <a:effectLst/>
+        </p:spPr>
+        <p:style>
+          <a:lnRef idx="1">
+            <a:schemeClr val="accent1"/>
+          </a:lnRef>
+          <a:fillRef idx="3">
+            <a:schemeClr val="accent1"/>
+          </a:fillRef>
+          <a:effectRef idx="2">
+            <a:schemeClr val="accent1"/>
+          </a:effectRef>
+          <a:fontRef idx="minor">
+            <a:schemeClr val="lt1"/>
+          </a:fontRef>
+        </p:style>
+        <p:txBody>
+          <a:bodyPr rtlCol="0" anchor="ctr"/>
+          <a:lstStyle/>
+          <a:p>
+            <a:pPr algn="ctr"/>
+          </a:p>
+        </p:txBody>
+      </p:sp>
+      <p:sp>
+        <p:nvSpPr>
+          <p:cNvPr id="8" name="TextBox 7"/>
           <p:cNvSpPr txBox="1"/>
           <p:nvPr/>
         </p:nvSpPr>
         <p:spPr>
           <a:xfrm>
-            <a:off x="822960" y="1920240"/>
+            <a:off x="822960" y="1965960"/>
             <a:ext cx="4983480" cy="4206240"/>
           </a:xfrm>
           <a:prstGeom prst="rect">
@@ -8276,17 +9149,17 @@
           <a:p>
             <a:pPr>
               <a:spcAft>
-                <a:spcPts val="1000"/>
+                <a:spcPts val="1100"/>
               </a:spcAft>
             </a:pPr>
             <a:r>
               <a:rPr sz="1600" b="1" i="0">
                 <a:solidFill>
-                  <a:srgbClr val="2E3A80"/>
-                </a:solidFill>
-                <a:latin typeface="Montserrat"/>
-              </a:rPr>
-              <a:t>•  </a:t>
+                  <a:srgbClr val="E8801A"/>
+                </a:solidFill>
+                <a:latin typeface="Montserrat"/>
+              </a:rPr>
+              <a:t>▸  </a:t>
             </a:r>
             <a:r>
               <a:rPr sz="1600" b="0" i="0">
@@ -8295,23 +9168,23 @@
                 </a:solidFill>
                 <a:latin typeface="Montserrat"/>
               </a:rPr>
-              <a:t>Reglamento: lo general, para todos</a:t>
+              <a:t>Fija condiciones técnicas y garantías</a:t>
             </a:r>
           </a:p>
           <a:p>
             <a:pPr>
               <a:spcAft>
-                <a:spcPts val="1000"/>
+                <a:spcPts val="1100"/>
               </a:spcAft>
             </a:pPr>
             <a:r>
               <a:rPr sz="1600" b="1" i="0">
                 <a:solidFill>
-                  <a:srgbClr val="2E3A80"/>
-                </a:solidFill>
-                <a:latin typeface="Montserrat"/>
-              </a:rPr>
-              <a:t>•  </a:t>
+                  <a:srgbClr val="E8801A"/>
+                </a:solidFill>
+                <a:latin typeface="Montserrat"/>
+              </a:rPr>
+              <a:t>▸  </a:t>
             </a:r>
             <a:r>
               <a:rPr sz="1600" b="0" i="0">
@@ -8320,23 +9193,23 @@
                 </a:solidFill>
                 <a:latin typeface="Montserrat"/>
               </a:rPr>
-              <a:t>ITC: el detalle de cada instalación</a:t>
+              <a:t>Sobre instalaciones y aparatos de gas</a:t>
             </a:r>
           </a:p>
           <a:p>
             <a:pPr>
               <a:spcAft>
-                <a:spcPts val="1000"/>
+                <a:spcPts val="1100"/>
               </a:spcAft>
             </a:pPr>
             <a:r>
               <a:rPr sz="1600" b="1" i="0">
                 <a:solidFill>
-                  <a:srgbClr val="2E3A80"/>
-                </a:solidFill>
-                <a:latin typeface="Montserrat"/>
-              </a:rPr>
-              <a:t>•  </a:t>
+                  <a:srgbClr val="E8801A"/>
+                </a:solidFill>
+                <a:latin typeface="Montserrat"/>
+              </a:rPr>
+              <a:t>▸  </a:t>
             </a:r>
             <a:r>
               <a:rPr sz="1600" b="0" i="0">
@@ -8345,14 +9218,14 @@
                 </a:solidFill>
                 <a:latin typeface="Montserrat"/>
               </a:rPr>
-              <a:t>Cumplirlo no exime de otras normas</a:t>
-            </a:r>
-          </a:p>
-        </p:txBody>
-      </p:sp>
-      <p:sp>
-        <p:nvSpPr>
-          <p:cNvPr id="8" name="imgph" descr="IMGQ:large tree trunk branches sky"/>
+              <a:t>Fin único: seguridad de personas y bienes</a:t>
+            </a:r>
+          </a:p>
+        </p:txBody>
+      </p:sp>
+      <p:sp>
+        <p:nvSpPr>
+          <p:cNvPr id="9" name="imgph" descr="IMGQ:gas boiler installation kitchen wall"/>
           <p:cNvSpPr/>
           <p:nvPr/>
         </p:nvSpPr>
@@ -8398,7 +9271,7 @@
       </p:sp>
       <p:sp>
         <p:nvSpPr>
-          <p:cNvPr id="9" name="TextBox 8"/>
+          <p:cNvPr id="10" name="TextBox 9"/>
           <p:cNvSpPr txBox="1"/>
           <p:nvPr/>
         </p:nvSpPr>
@@ -8438,7 +9311,7 @@
                 </a:solidFill>
                 <a:latin typeface="Montserrat"/>
               </a:rPr>
-              <a:t>large tree trunk branches sky</a:t>
+              <a:t>gas boiler installation kitchen wall</a:t>
             </a:r>
           </a:p>
         </p:txBody>
@@ -8535,7 +9408,7 @@
                 </a:solidFill>
                 <a:latin typeface="Montserrat"/>
               </a:rPr>
-              <a:t>005 / 015</a:t>
+              <a:t>005 / 016</a:t>
             </a:r>
           </a:p>
         </p:txBody>
@@ -8583,7 +9456,7 @@
         <p:spPr>
           <a:xfrm>
             <a:off x="822960" y="457200"/>
-            <a:ext cx="8229600" cy="365760"/>
+            <a:ext cx="10058400" cy="365760"/>
           </a:xfrm>
           <a:prstGeom prst="rect">
             <a:avLst/>
@@ -8597,13 +9470,13 @@
           <a:lstStyle/>
           <a:p>
             <a:r>
-              <a:rPr sz="1200" b="1" i="0">
-                <a:solidFill>
-                  <a:srgbClr val="64748B"/>
-                </a:solidFill>
-                <a:latin typeface="Montserrat"/>
-              </a:rPr>
-              <a:t>ARTÍCULO 1 · MARCO LEGAL</a:t>
+              <a:rPr sz="1300" b="1" i="0">
+                <a:solidFill>
+                  <a:srgbClr val="E8801A"/>
+                </a:solidFill>
+                <a:latin typeface="Montserrat"/>
+              </a:rPr>
+              <a:t>ARTÍCULO 1 · ESTRUCTURA</a:t>
             </a:r>
           </a:p>
         </p:txBody>
@@ -8631,26 +9504,70 @@
           <a:lstStyle/>
           <a:p>
             <a:r>
-              <a:rPr sz="2700" b="1" i="0">
+              <a:rPr sz="2800" b="1" i="0">
                 <a:solidFill>
                   <a:srgbClr val="1E2761"/>
                 </a:solidFill>
                 <a:latin typeface="Montserrat"/>
               </a:rPr>
-              <a:t>¿De qué leyes cuelga?</a:t>
-            </a:r>
-          </a:p>
-        </p:txBody>
-      </p:sp>
-      <p:sp>
-        <p:nvSpPr>
-          <p:cNvPr id="7" name="TextBox 6"/>
+              <a:t>El tronco y las ramas</a:t>
+            </a:r>
+          </a:p>
+        </p:txBody>
+      </p:sp>
+      <p:sp>
+        <p:nvSpPr>
+          <p:cNvPr id="7" name="Rounded Rectangle 6"/>
+          <p:cNvSpPr/>
+          <p:nvPr/>
+        </p:nvSpPr>
+        <p:spPr>
+          <a:xfrm>
+            <a:off x="868680" y="1627632"/>
+            <a:ext cx="2011680" cy="73152"/>
+          </a:xfrm>
+          <a:prstGeom prst="roundRect">
+            <a:avLst/>
+          </a:prstGeom>
+          <a:solidFill>
+            <a:srgbClr val="E8801A"/>
+          </a:solidFill>
+          <a:ln>
+            <a:noFill/>
+          </a:ln>
+          <a:effectLst/>
+        </p:spPr>
+        <p:style>
+          <a:lnRef idx="1">
+            <a:schemeClr val="accent1"/>
+          </a:lnRef>
+          <a:fillRef idx="3">
+            <a:schemeClr val="accent1"/>
+          </a:fillRef>
+          <a:effectRef idx="2">
+            <a:schemeClr val="accent1"/>
+          </a:effectRef>
+          <a:fontRef idx="minor">
+            <a:schemeClr val="lt1"/>
+          </a:fontRef>
+        </p:style>
+        <p:txBody>
+          <a:bodyPr rtlCol="0" anchor="ctr"/>
+          <a:lstStyle/>
+          <a:p>
+            <a:pPr algn="ctr"/>
+          </a:p>
+        </p:txBody>
+      </p:sp>
+      <p:sp>
+        <p:nvSpPr>
+          <p:cNvPr id="8" name="TextBox 7"/>
           <p:cNvSpPr txBox="1"/>
           <p:nvPr/>
         </p:nvSpPr>
         <p:spPr>
           <a:xfrm>
-            <a:off x="822960" y="1920240"/>
+            <a:off x="822960" y="1965960"/>
             <a:ext cx="4983480" cy="4206240"/>
           </a:xfrm>
           <a:prstGeom prst="rect">
@@ -8666,17 +9583,17 @@
           <a:p>
             <a:pPr>
               <a:spcAft>
-                <a:spcPts val="1000"/>
+                <a:spcPts val="1100"/>
               </a:spcAft>
             </a:pPr>
             <a:r>
               <a:rPr sz="1600" b="1" i="0">
                 <a:solidFill>
-                  <a:srgbClr val="2E3A80"/>
-                </a:solidFill>
-                <a:latin typeface="Montserrat"/>
-              </a:rPr>
-              <a:t>•  </a:t>
+                  <a:srgbClr val="E8801A"/>
+                </a:solidFill>
+                <a:latin typeface="Montserrat"/>
+              </a:rPr>
+              <a:t>▸  </a:t>
             </a:r>
             <a:r>
               <a:rPr sz="1600" b="0" i="0">
@@ -8685,23 +9602,23 @@
                 </a:solidFill>
                 <a:latin typeface="Montserrat"/>
               </a:rPr>
-              <a:t>Ley de hidrocarburos: el negocio del gas</a:t>
+              <a:t>Reglamento: lo general, para todos</a:t>
             </a:r>
           </a:p>
           <a:p>
             <a:pPr>
               <a:spcAft>
-                <a:spcPts val="1000"/>
+                <a:spcPts val="1100"/>
               </a:spcAft>
             </a:pPr>
             <a:r>
               <a:rPr sz="1600" b="1" i="0">
                 <a:solidFill>
-                  <a:srgbClr val="2E3A80"/>
-                </a:solidFill>
-                <a:latin typeface="Montserrat"/>
-              </a:rPr>
-              <a:t>•  </a:t>
+                  <a:srgbClr val="E8801A"/>
+                </a:solidFill>
+                <a:latin typeface="Montserrat"/>
+              </a:rPr>
+              <a:t>▸  </a:t>
             </a:r>
             <a:r>
               <a:rPr sz="1600" b="0" i="0">
@@ -8710,23 +9627,23 @@
                 </a:solidFill>
                 <a:latin typeface="Montserrat"/>
               </a:rPr>
-              <a:t>Ley de industria: la seguridad industrial</a:t>
+              <a:t>ITC: el detalle de cada instalación</a:t>
             </a:r>
           </a:p>
           <a:p>
             <a:pPr>
               <a:spcAft>
-                <a:spcPts val="1000"/>
+                <a:spcPts val="1100"/>
               </a:spcAft>
             </a:pPr>
             <a:r>
               <a:rPr sz="1600" b="1" i="0">
                 <a:solidFill>
-                  <a:srgbClr val="2E3A80"/>
-                </a:solidFill>
-                <a:latin typeface="Montserrat"/>
-              </a:rPr>
-              <a:t>•  </a:t>
+                  <a:srgbClr val="E8801A"/>
+                </a:solidFill>
+                <a:latin typeface="Montserrat"/>
+              </a:rPr>
+              <a:t>▸  </a:t>
             </a:r>
             <a:r>
               <a:rPr sz="1600" b="0" i="0">
@@ -8735,14 +9652,14 @@
                 </a:solidFill>
                 <a:latin typeface="Montserrat"/>
               </a:rPr>
-              <a:t>El Reglamento las baja al taller</a:t>
-            </a:r>
-          </a:p>
-        </p:txBody>
-      </p:sp>
-      <p:sp>
-        <p:nvSpPr>
-          <p:cNvPr id="8" name="imgph" descr="IMGQ:law books stacked wooden desk"/>
+              <a:t>Cumplirlo no exime de otras normas</a:t>
+            </a:r>
+          </a:p>
+        </p:txBody>
+      </p:sp>
+      <p:sp>
+        <p:nvSpPr>
+          <p:cNvPr id="9" name="imgph" descr="IMGQ:large tree trunk branches sky"/>
           <p:cNvSpPr/>
           <p:nvPr/>
         </p:nvSpPr>
@@ -8788,7 +9705,7 @@
       </p:sp>
       <p:sp>
         <p:nvSpPr>
-          <p:cNvPr id="9" name="TextBox 8"/>
+          <p:cNvPr id="10" name="TextBox 9"/>
           <p:cNvSpPr txBox="1"/>
           <p:nvPr/>
         </p:nvSpPr>
@@ -8828,7 +9745,7 @@
                 </a:solidFill>
                 <a:latin typeface="Montserrat"/>
               </a:rPr>
-              <a:t>law books stacked wooden desk</a:t>
+              <a:t>large tree trunk branches sky</a:t>
             </a:r>
           </a:p>
         </p:txBody>
@@ -8925,7 +9842,7 @@
                 </a:solidFill>
                 <a:latin typeface="Montserrat"/>
               </a:rPr>
-              <a:t>006 / 015</a:t>
+              <a:t>006 / 016</a:t>
             </a:r>
           </a:p>
         </p:txBody>
@@ -8973,7 +9890,7 @@
         <p:spPr>
           <a:xfrm>
             <a:off x="822960" y="457200"/>
-            <a:ext cx="8229600" cy="365760"/>
+            <a:ext cx="10058400" cy="365760"/>
           </a:xfrm>
           <a:prstGeom prst="rect">
             <a:avLst/>
@@ -8987,13 +9904,13 @@
           <a:lstStyle/>
           <a:p>
             <a:r>
-              <a:rPr sz="1200" b="1" i="0">
-                <a:solidFill>
-                  <a:srgbClr val="64748B"/>
-                </a:solidFill>
-                <a:latin typeface="Montserrat"/>
-              </a:rPr>
-              <a:t>ARTÍCULO 2 · CAMPO DE APLICACIÓN</a:t>
+              <a:rPr sz="1300" b="1" i="0">
+                <a:solidFill>
+                  <a:srgbClr val="E8801A"/>
+                </a:solidFill>
+                <a:latin typeface="Montserrat"/>
+              </a:rPr>
+              <a:t>ARTÍCULO 1 · MARCO LEGAL</a:t>
             </a:r>
           </a:p>
         </p:txBody>
@@ -9021,26 +9938,70 @@
           <a:lstStyle/>
           <a:p>
             <a:r>
-              <a:rPr sz="2700" b="1" i="0">
+              <a:rPr sz="2800" b="1" i="0">
                 <a:solidFill>
                   <a:srgbClr val="1E2761"/>
                 </a:solidFill>
                 <a:latin typeface="Montserrat"/>
               </a:rPr>
-              <a:t>¿A qué se aplica?</a:t>
-            </a:r>
-          </a:p>
-        </p:txBody>
-      </p:sp>
-      <p:sp>
-        <p:nvSpPr>
-          <p:cNvPr id="7" name="TextBox 6"/>
+              <a:t>¿De qué leyes cuelga?</a:t>
+            </a:r>
+          </a:p>
+        </p:txBody>
+      </p:sp>
+      <p:sp>
+        <p:nvSpPr>
+          <p:cNvPr id="7" name="Rounded Rectangle 6"/>
+          <p:cNvSpPr/>
+          <p:nvPr/>
+        </p:nvSpPr>
+        <p:spPr>
+          <a:xfrm>
+            <a:off x="868680" y="1627632"/>
+            <a:ext cx="2011680" cy="73152"/>
+          </a:xfrm>
+          <a:prstGeom prst="roundRect">
+            <a:avLst/>
+          </a:prstGeom>
+          <a:solidFill>
+            <a:srgbClr val="E8801A"/>
+          </a:solidFill>
+          <a:ln>
+            <a:noFill/>
+          </a:ln>
+          <a:effectLst/>
+        </p:spPr>
+        <p:style>
+          <a:lnRef idx="1">
+            <a:schemeClr val="accent1"/>
+          </a:lnRef>
+          <a:fillRef idx="3">
+            <a:schemeClr val="accent1"/>
+          </a:fillRef>
+          <a:effectRef idx="2">
+            <a:schemeClr val="accent1"/>
+          </a:effectRef>
+          <a:fontRef idx="minor">
+            <a:schemeClr val="lt1"/>
+          </a:fontRef>
+        </p:style>
+        <p:txBody>
+          <a:bodyPr rtlCol="0" anchor="ctr"/>
+          <a:lstStyle/>
+          <a:p>
+            <a:pPr algn="ctr"/>
+          </a:p>
+        </p:txBody>
+      </p:sp>
+      <p:sp>
+        <p:nvSpPr>
+          <p:cNvPr id="8" name="TextBox 7"/>
           <p:cNvSpPr txBox="1"/>
           <p:nvPr/>
         </p:nvSpPr>
         <p:spPr>
           <a:xfrm>
-            <a:off x="822960" y="1920240"/>
+            <a:off x="822960" y="1965960"/>
             <a:ext cx="4983480" cy="4206240"/>
           </a:xfrm>
           <a:prstGeom prst="rect">
@@ -9056,17 +10017,17 @@
           <a:p>
             <a:pPr>
               <a:spcAft>
-                <a:spcPts val="1000"/>
+                <a:spcPts val="1100"/>
               </a:spcAft>
             </a:pPr>
             <a:r>
               <a:rPr sz="1600" b="1" i="0">
                 <a:solidFill>
-                  <a:srgbClr val="2E3A80"/>
-                </a:solidFill>
-                <a:latin typeface="Montserrat"/>
-              </a:rPr>
-              <a:t>•  </a:t>
+                  <a:srgbClr val="E8801A"/>
+                </a:solidFill>
+                <a:latin typeface="Montserrat"/>
+              </a:rPr>
+              <a:t>▸  </a:t>
             </a:r>
             <a:r>
               <a:rPr sz="1600" b="0" i="0">
@@ -9075,23 +10036,23 @@
                 </a:solidFill>
                 <a:latin typeface="Montserrat"/>
               </a:rPr>
-              <a:t>Distribución por canalización (red de calle)</a:t>
+              <a:t>Ley de hidrocarburos: el negocio del gas</a:t>
             </a:r>
           </a:p>
           <a:p>
             <a:pPr>
               <a:spcAft>
-                <a:spcPts val="1000"/>
+                <a:spcPts val="1100"/>
               </a:spcAft>
             </a:pPr>
             <a:r>
               <a:rPr sz="1600" b="1" i="0">
                 <a:solidFill>
-                  <a:srgbClr val="2E3A80"/>
-                </a:solidFill>
-                <a:latin typeface="Montserrat"/>
-              </a:rPr>
-              <a:t>•  </a:t>
+                  <a:srgbClr val="E8801A"/>
+                </a:solidFill>
+                <a:latin typeface="Montserrat"/>
+              </a:rPr>
+              <a:t>▸  </a:t>
             </a:r>
             <a:r>
               <a:rPr sz="1600" b="0" i="0">
@@ -9100,23 +10061,23 @@
                 </a:solidFill>
                 <a:latin typeface="Montserrat"/>
               </a:rPr>
-              <a:t>GLP: envases, depósitos fijos, GNL</a:t>
+              <a:t>Ley de industria: la seguridad industrial</a:t>
             </a:r>
           </a:p>
           <a:p>
             <a:pPr>
               <a:spcAft>
-                <a:spcPts val="1000"/>
+                <a:spcPts val="1100"/>
               </a:spcAft>
             </a:pPr>
             <a:r>
               <a:rPr sz="1600" b="1" i="0">
                 <a:solidFill>
-                  <a:srgbClr val="2E3A80"/>
-                </a:solidFill>
-                <a:latin typeface="Montserrat"/>
-              </a:rPr>
-              <a:t>•  </a:t>
+                  <a:srgbClr val="E8801A"/>
+                </a:solidFill>
+                <a:latin typeface="Montserrat"/>
+              </a:rPr>
+              <a:t>▸  </a:t>
             </a:r>
             <a:r>
               <a:rPr sz="1600" b="0" i="0">
@@ -9125,64 +10086,14 @@
                 </a:solidFill>
                 <a:latin typeface="Montserrat"/>
               </a:rPr>
-              <a:t>Estaciones de servicio de gas</a:t>
-            </a:r>
-          </a:p>
-          <a:p>
-            <a:pPr>
-              <a:spcAft>
-                <a:spcPts val="1000"/>
-              </a:spcAft>
-            </a:pPr>
-            <a:r>
-              <a:rPr sz="1600" b="1" i="0">
-                <a:solidFill>
-                  <a:srgbClr val="2E3A80"/>
-                </a:solidFill>
-                <a:latin typeface="Montserrat"/>
-              </a:rPr>
-              <a:t>•  </a:t>
-            </a:r>
-            <a:r>
-              <a:rPr sz="1600" b="0" i="0">
-                <a:solidFill>
-                  <a:srgbClr val="1B2330"/>
-                </a:solidFill>
-                <a:latin typeface="Montserrat"/>
-              </a:rPr>
-              <a:t>Instalaciones receptoras: tu terreno</a:t>
-            </a:r>
-          </a:p>
-          <a:p>
-            <a:pPr>
-              <a:spcAft>
-                <a:spcPts val="1000"/>
-              </a:spcAft>
-            </a:pPr>
-            <a:r>
-              <a:rPr sz="1600" b="1" i="0">
-                <a:solidFill>
-                  <a:srgbClr val="2E3A80"/>
-                </a:solidFill>
-                <a:latin typeface="Montserrat"/>
-              </a:rPr>
-              <a:t>•  </a:t>
-            </a:r>
-            <a:r>
-              <a:rPr sz="1600" b="0" i="0">
-                <a:solidFill>
-                  <a:srgbClr val="1B2330"/>
-                </a:solidFill>
-                <a:latin typeface="Montserrat"/>
-              </a:rPr>
-              <a:t>Aparatos de gas</a:t>
-            </a:r>
-          </a:p>
-        </p:txBody>
-      </p:sp>
-      <p:sp>
-        <p:nvSpPr>
-          <p:cNvPr id="8" name="imgph" descr="IMGQ:gas meter cabinet building facade"/>
+              <a:t>El Reglamento las baja al taller</a:t>
+            </a:r>
+          </a:p>
+        </p:txBody>
+      </p:sp>
+      <p:sp>
+        <p:nvSpPr>
+          <p:cNvPr id="9" name="imgph" descr="IMGQ:law books stacked wooden desk"/>
           <p:cNvSpPr/>
           <p:nvPr/>
         </p:nvSpPr>
@@ -9228,7 +10139,7 @@
       </p:sp>
       <p:sp>
         <p:nvSpPr>
-          <p:cNvPr id="9" name="TextBox 8"/>
+          <p:cNvPr id="10" name="TextBox 9"/>
           <p:cNvSpPr txBox="1"/>
           <p:nvPr/>
         </p:nvSpPr>
@@ -9268,7 +10179,7 @@
                 </a:solidFill>
                 <a:latin typeface="Montserrat"/>
               </a:rPr>
-              <a:t>gas meter cabinet building facade</a:t>
+              <a:t>law books stacked wooden desk</a:t>
             </a:r>
           </a:p>
         </p:txBody>
@@ -9365,7 +10276,7 @@
                 </a:solidFill>
                 <a:latin typeface="Montserrat"/>
               </a:rPr>
-              <a:t>007 / 015</a:t>
+              <a:t>007 / 016</a:t>
             </a:r>
           </a:p>
         </p:txBody>
@@ -9413,7 +10324,7 @@
         <p:spPr>
           <a:xfrm>
             <a:off x="822960" y="457200"/>
-            <a:ext cx="8229600" cy="365760"/>
+            <a:ext cx="10058400" cy="365760"/>
           </a:xfrm>
           <a:prstGeom prst="rect">
             <a:avLst/>
@@ -9427,13 +10338,13 @@
           <a:lstStyle/>
           <a:p>
             <a:r>
-              <a:rPr sz="1200" b="1" i="0">
-                <a:solidFill>
-                  <a:srgbClr val="64748B"/>
-                </a:solidFill>
-                <a:latin typeface="Montserrat"/>
-              </a:rPr>
-              <a:t>ARTÍCULO 2 · INSTALACIÓN RECEPTORA</a:t>
+              <a:rPr sz="1300" b="1" i="0">
+                <a:solidFill>
+                  <a:srgbClr val="E8801A"/>
+                </a:solidFill>
+                <a:latin typeface="Montserrat"/>
+              </a:rPr>
+              <a:t>ARTÍCULO 2 · CAMPO DE APLICACIÓN</a:t>
             </a:r>
           </a:p>
         </p:txBody>
@@ -9461,26 +10372,70 @@
           <a:lstStyle/>
           <a:p>
             <a:r>
-              <a:rPr sz="2700" b="1" i="0">
+              <a:rPr sz="2800" b="1" i="0">
                 <a:solidFill>
                   <a:srgbClr val="1E2761"/>
                 </a:solidFill>
                 <a:latin typeface="Montserrat"/>
               </a:rPr>
-              <a:t>¿Dónde empieza y dónde acaba?</a:t>
-            </a:r>
-          </a:p>
-        </p:txBody>
-      </p:sp>
-      <p:sp>
-        <p:nvSpPr>
-          <p:cNvPr id="7" name="TextBox 6"/>
+              <a:t>¿A qué se aplica?</a:t>
+            </a:r>
+          </a:p>
+        </p:txBody>
+      </p:sp>
+      <p:sp>
+        <p:nvSpPr>
+          <p:cNvPr id="7" name="Rounded Rectangle 6"/>
+          <p:cNvSpPr/>
+          <p:nvPr/>
+        </p:nvSpPr>
+        <p:spPr>
+          <a:xfrm>
+            <a:off x="868680" y="1627632"/>
+            <a:ext cx="2011680" cy="73152"/>
+          </a:xfrm>
+          <a:prstGeom prst="roundRect">
+            <a:avLst/>
+          </a:prstGeom>
+          <a:solidFill>
+            <a:srgbClr val="E8801A"/>
+          </a:solidFill>
+          <a:ln>
+            <a:noFill/>
+          </a:ln>
+          <a:effectLst/>
+        </p:spPr>
+        <p:style>
+          <a:lnRef idx="1">
+            <a:schemeClr val="accent1"/>
+          </a:lnRef>
+          <a:fillRef idx="3">
+            <a:schemeClr val="accent1"/>
+          </a:fillRef>
+          <a:effectRef idx="2">
+            <a:schemeClr val="accent1"/>
+          </a:effectRef>
+          <a:fontRef idx="minor">
+            <a:schemeClr val="lt1"/>
+          </a:fontRef>
+        </p:style>
+        <p:txBody>
+          <a:bodyPr rtlCol="0" anchor="ctr"/>
+          <a:lstStyle/>
+          <a:p>
+            <a:pPr algn="ctr"/>
+          </a:p>
+        </p:txBody>
+      </p:sp>
+      <p:sp>
+        <p:nvSpPr>
+          <p:cNvPr id="8" name="TextBox 7"/>
           <p:cNvSpPr txBox="1"/>
           <p:nvPr/>
         </p:nvSpPr>
         <p:spPr>
           <a:xfrm>
-            <a:off x="822960" y="1920240"/>
+            <a:off x="822960" y="1965960"/>
             <a:ext cx="4983480" cy="4206240"/>
           </a:xfrm>
           <a:prstGeom prst="rect">
@@ -9496,17 +10451,17 @@
           <a:p>
             <a:pPr>
               <a:spcAft>
-                <a:spcPts val="1000"/>
+                <a:spcPts val="1100"/>
               </a:spcAft>
             </a:pPr>
             <a:r>
               <a:rPr sz="1600" b="1" i="0">
                 <a:solidFill>
-                  <a:srgbClr val="2E3A80"/>
-                </a:solidFill>
-                <a:latin typeface="Montserrat"/>
-              </a:rPr>
-              <a:t>•  </a:t>
+                  <a:srgbClr val="E8801A"/>
+                </a:solidFill>
+                <a:latin typeface="Montserrat"/>
+              </a:rPr>
+              <a:t>▸  </a:t>
             </a:r>
             <a:r>
               <a:rPr sz="1600" b="0" i="0">
@@ -9515,23 +10470,23 @@
                 </a:solidFill>
                 <a:latin typeface="Montserrat"/>
               </a:rPr>
-              <a:t>Desde la llave de acometida (excluida)</a:t>
+              <a:t>Distribución por canalización (red de calle)</a:t>
             </a:r>
           </a:p>
           <a:p>
             <a:pPr>
               <a:spcAft>
-                <a:spcPts val="1000"/>
+                <a:spcPts val="1100"/>
               </a:spcAft>
             </a:pPr>
             <a:r>
               <a:rPr sz="1600" b="1" i="0">
                 <a:solidFill>
-                  <a:srgbClr val="2E3A80"/>
-                </a:solidFill>
-                <a:latin typeface="Montserrat"/>
-              </a:rPr>
-              <a:t>•  </a:t>
+                  <a:srgbClr val="E8801A"/>
+                </a:solidFill>
+                <a:latin typeface="Montserrat"/>
+              </a:rPr>
+              <a:t>▸  </a:t>
             </a:r>
             <a:r>
               <a:rPr sz="1600" b="0" i="0">
@@ -9540,23 +10495,23 @@
                 </a:solidFill>
                 <a:latin typeface="Montserrat"/>
               </a:rPr>
-              <a:t>Hasta la llave de aparato (incluida)</a:t>
+              <a:t>GLP: envases, depósitos fijos, GNL</a:t>
             </a:r>
           </a:p>
           <a:p>
             <a:pPr>
               <a:spcAft>
-                <a:spcPts val="1000"/>
+                <a:spcPts val="1100"/>
               </a:spcAft>
             </a:pPr>
             <a:r>
               <a:rPr sz="1600" b="1" i="0">
                 <a:solidFill>
-                  <a:srgbClr val="2E3A80"/>
-                </a:solidFill>
-                <a:latin typeface="Montserrat"/>
-              </a:rPr>
-              <a:t>•  </a:t>
+                  <a:srgbClr val="E8801A"/>
+                </a:solidFill>
+                <a:latin typeface="Montserrat"/>
+              </a:rPr>
+              <a:t>▸  </a:t>
             </a:r>
             <a:r>
               <a:rPr sz="1600" b="0" i="0">
@@ -9565,23 +10520,23 @@
                 </a:solidFill>
                 <a:latin typeface="Montserrat"/>
               </a:rPr>
-              <a:t>El aparato y su latiguillo quedan fuera</a:t>
+              <a:t>Estaciones de servicio de gas</a:t>
             </a:r>
           </a:p>
           <a:p>
             <a:pPr>
               <a:spcAft>
-                <a:spcPts val="1000"/>
+                <a:spcPts val="1100"/>
               </a:spcAft>
             </a:pPr>
             <a:r>
               <a:rPr sz="1600" b="1" i="0">
                 <a:solidFill>
-                  <a:srgbClr val="2E3A80"/>
-                </a:solidFill>
-                <a:latin typeface="Montserrat"/>
-              </a:rPr>
-              <a:t>•  </a:t>
+                  <a:srgbClr val="E8801A"/>
+                </a:solidFill>
+                <a:latin typeface="Montserrat"/>
+              </a:rPr>
+              <a:t>▸  </a:t>
             </a:r>
             <a:r>
               <a:rPr sz="1600" b="0" i="0">
@@ -9590,14 +10545,39 @@
                 </a:solidFill>
                 <a:latin typeface="Montserrat"/>
               </a:rPr>
-              <a:t>Esa frontera decide de qué respondes</a:t>
-            </a:r>
-          </a:p>
-        </p:txBody>
-      </p:sp>
-      <p:sp>
-        <p:nvSpPr>
-          <p:cNvPr id="8" name="imgph" descr="IMGQ:gas shut off valve copper pipe wall"/>
+              <a:t>Instalaciones receptoras: tu terreno</a:t>
+            </a:r>
+          </a:p>
+          <a:p>
+            <a:pPr>
+              <a:spcAft>
+                <a:spcPts val="1100"/>
+              </a:spcAft>
+            </a:pPr>
+            <a:r>
+              <a:rPr sz="1600" b="1" i="0">
+                <a:solidFill>
+                  <a:srgbClr val="E8801A"/>
+                </a:solidFill>
+                <a:latin typeface="Montserrat"/>
+              </a:rPr>
+              <a:t>▸  </a:t>
+            </a:r>
+            <a:r>
+              <a:rPr sz="1600" b="0" i="0">
+                <a:solidFill>
+                  <a:srgbClr val="1B2330"/>
+                </a:solidFill>
+                <a:latin typeface="Montserrat"/>
+              </a:rPr>
+              <a:t>Aparatos de gas</a:t>
+            </a:r>
+          </a:p>
+        </p:txBody>
+      </p:sp>
+      <p:sp>
+        <p:nvSpPr>
+          <p:cNvPr id="9" name="imgph" descr="IMGQ:gas meter cabinet building facade"/>
           <p:cNvSpPr/>
           <p:nvPr/>
         </p:nvSpPr>
@@ -9643,7 +10623,7 @@
       </p:sp>
       <p:sp>
         <p:nvSpPr>
-          <p:cNvPr id="9" name="TextBox 8"/>
+          <p:cNvPr id="10" name="TextBox 9"/>
           <p:cNvSpPr txBox="1"/>
           <p:nvPr/>
         </p:nvSpPr>
@@ -9683,7 +10663,7 @@
                 </a:solidFill>
                 <a:latin typeface="Montserrat"/>
               </a:rPr>
-              <a:t>gas shut off valve copper pipe wall</a:t>
+              <a:t>gas meter cabinet building facade</a:t>
             </a:r>
           </a:p>
         </p:txBody>
@@ -9780,7 +10760,7 @@
                 </a:solidFill>
                 <a:latin typeface="Montserrat"/>
               </a:rPr>
-              <a:t>008 / 015</a:t>
+              <a:t>008 / 016</a:t>
             </a:r>
           </a:p>
         </p:txBody>
@@ -9828,7 +10808,7 @@
         <p:spPr>
           <a:xfrm>
             <a:off x="822960" y="457200"/>
-            <a:ext cx="8229600" cy="365760"/>
+            <a:ext cx="10058400" cy="365760"/>
           </a:xfrm>
           <a:prstGeom prst="rect">
             <a:avLst/>
@@ -9842,13 +10822,13 @@
           <a:lstStyle/>
           <a:p>
             <a:r>
-              <a:rPr sz="1200" b="1" i="0">
-                <a:solidFill>
-                  <a:srgbClr val="64748B"/>
-                </a:solidFill>
-                <a:latin typeface="Montserrat"/>
-              </a:rPr>
-              <a:t>ARTÍCULO 2 · EL LÍMITE DE 15 KG</a:t>
+              <a:rPr sz="1300" b="1" i="0">
+                <a:solidFill>
+                  <a:srgbClr val="E8801A"/>
+                </a:solidFill>
+                <a:latin typeface="Montserrat"/>
+              </a:rPr>
+              <a:t>ARTÍCULO 2 · INSTALACIÓN RECEPTORA</a:t>
             </a:r>
           </a:p>
         </p:txBody>
@@ -9876,26 +10856,70 @@
           <a:lstStyle/>
           <a:p>
             <a:r>
-              <a:rPr sz="2700" b="1" i="0">
+              <a:rPr sz="2800" b="1" i="0">
                 <a:solidFill>
                   <a:srgbClr val="1E2761"/>
                 </a:solidFill>
                 <a:latin typeface="Montserrat"/>
               </a:rPr>
-              <a:t>¿Instalación o cacharro suelto?</a:t>
-            </a:r>
-          </a:p>
-        </p:txBody>
-      </p:sp>
-      <p:sp>
-        <p:nvSpPr>
-          <p:cNvPr id="7" name="TextBox 6"/>
+              <a:t>¿Dónde empieza y dónde acaba?</a:t>
+            </a:r>
+          </a:p>
+        </p:txBody>
+      </p:sp>
+      <p:sp>
+        <p:nvSpPr>
+          <p:cNvPr id="7" name="Rounded Rectangle 6"/>
+          <p:cNvSpPr/>
+          <p:nvPr/>
+        </p:nvSpPr>
+        <p:spPr>
+          <a:xfrm>
+            <a:off x="868680" y="1627632"/>
+            <a:ext cx="2011680" cy="73152"/>
+          </a:xfrm>
+          <a:prstGeom prst="roundRect">
+            <a:avLst/>
+          </a:prstGeom>
+          <a:solidFill>
+            <a:srgbClr val="E8801A"/>
+          </a:solidFill>
+          <a:ln>
+            <a:noFill/>
+          </a:ln>
+          <a:effectLst/>
+        </p:spPr>
+        <p:style>
+          <a:lnRef idx="1">
+            <a:schemeClr val="accent1"/>
+          </a:lnRef>
+          <a:fillRef idx="3">
+            <a:schemeClr val="accent1"/>
+          </a:fillRef>
+          <a:effectRef idx="2">
+            <a:schemeClr val="accent1"/>
+          </a:effectRef>
+          <a:fontRef idx="minor">
+            <a:schemeClr val="lt1"/>
+          </a:fontRef>
+        </p:style>
+        <p:txBody>
+          <a:bodyPr rtlCol="0" anchor="ctr"/>
+          <a:lstStyle/>
+          <a:p>
+            <a:pPr algn="ctr"/>
+          </a:p>
+        </p:txBody>
+      </p:sp>
+      <p:sp>
+        <p:nvSpPr>
+          <p:cNvPr id="8" name="TextBox 7"/>
           <p:cNvSpPr txBox="1"/>
           <p:nvPr/>
         </p:nvSpPr>
         <p:spPr>
           <a:xfrm>
-            <a:off x="822960" y="1920240"/>
+            <a:off x="822960" y="1965960"/>
             <a:ext cx="4983480" cy="4206240"/>
           </a:xfrm>
           <a:prstGeom prst="rect">
@@ -9911,17 +10935,17 @@
           <a:p>
             <a:pPr>
               <a:spcAft>
-                <a:spcPts val="1000"/>
+                <a:spcPts val="1100"/>
               </a:spcAft>
             </a:pPr>
             <a:r>
               <a:rPr sz="1600" b="1" i="0">
                 <a:solidFill>
-                  <a:srgbClr val="2E3A80"/>
-                </a:solidFill>
-                <a:latin typeface="Montserrat"/>
-              </a:rPr>
-              <a:t>•  </a:t>
+                  <a:srgbClr val="E8801A"/>
+                </a:solidFill>
+                <a:latin typeface="Montserrat"/>
+              </a:rPr>
+              <a:t>▸  </a:t>
             </a:r>
             <a:r>
               <a:rPr sz="1600" b="0" i="0">
@@ -9930,23 +10954,23 @@
                 </a:solidFill>
                 <a:latin typeface="Montserrat"/>
               </a:rPr>
-              <a:t>Bombona &lt;15 kg + un aparato móvil: fuera</a:t>
+              <a:t>Desde la llave de acometida (excluida)</a:t>
             </a:r>
           </a:p>
           <a:p>
             <a:pPr>
               <a:spcAft>
-                <a:spcPts val="1000"/>
+                <a:spcPts val="1100"/>
               </a:spcAft>
             </a:pPr>
             <a:r>
               <a:rPr sz="1600" b="1" i="0">
                 <a:solidFill>
-                  <a:srgbClr val="2E3A80"/>
-                </a:solidFill>
-                <a:latin typeface="Montserrat"/>
-              </a:rPr>
-              <a:t>•  </a:t>
+                  <a:srgbClr val="E8801A"/>
+                </a:solidFill>
+                <a:latin typeface="Montserrat"/>
+              </a:rPr>
+              <a:t>▸  </a:t>
             </a:r>
             <a:r>
               <a:rPr sz="1600" b="0" i="0">
@@ -9955,23 +10979,23 @@
                 </a:solidFill>
                 <a:latin typeface="Montserrat"/>
               </a:rPr>
-              <a:t>Tubería fija o varios aparatos: dentro</a:t>
+              <a:t>Hasta la llave de aparato (incluida)</a:t>
             </a:r>
           </a:p>
           <a:p>
             <a:pPr>
               <a:spcAft>
-                <a:spcPts val="1000"/>
+                <a:spcPts val="1100"/>
               </a:spcAft>
             </a:pPr>
             <a:r>
               <a:rPr sz="1600" b="1" i="0">
                 <a:solidFill>
-                  <a:srgbClr val="2E3A80"/>
-                </a:solidFill>
-                <a:latin typeface="Montserrat"/>
-              </a:rPr>
-              <a:t>•  </a:t>
+                  <a:srgbClr val="E8801A"/>
+                </a:solidFill>
+                <a:latin typeface="Montserrat"/>
+              </a:rPr>
+              <a:t>▸  </a:t>
             </a:r>
             <a:r>
               <a:rPr sz="1600" b="0" i="0">
@@ -9980,14 +11004,39 @@
                 </a:solidFill>
                 <a:latin typeface="Montserrat"/>
               </a:rPr>
-              <a:t>Dentro = boletín y prueba de estanquidad</a:t>
-            </a:r>
-          </a:p>
-        </p:txBody>
-      </p:sp>
-      <p:sp>
-        <p:nvSpPr>
-          <p:cNvPr id="8" name="imgph" descr="IMGQ:small gas cylinder camping stove"/>
+              <a:t>El aparato y su latiguillo quedan fuera</a:t>
+            </a:r>
+          </a:p>
+          <a:p>
+            <a:pPr>
+              <a:spcAft>
+                <a:spcPts val="1100"/>
+              </a:spcAft>
+            </a:pPr>
+            <a:r>
+              <a:rPr sz="1600" b="1" i="0">
+                <a:solidFill>
+                  <a:srgbClr val="E8801A"/>
+                </a:solidFill>
+                <a:latin typeface="Montserrat"/>
+              </a:rPr>
+              <a:t>▸  </a:t>
+            </a:r>
+            <a:r>
+              <a:rPr sz="1600" b="0" i="0">
+                <a:solidFill>
+                  <a:srgbClr val="1B2330"/>
+                </a:solidFill>
+                <a:latin typeface="Montserrat"/>
+              </a:rPr>
+              <a:t>Esa frontera decide de qué respondes</a:t>
+            </a:r>
+          </a:p>
+        </p:txBody>
+      </p:sp>
+      <p:sp>
+        <p:nvSpPr>
+          <p:cNvPr id="9" name="imgph" descr="IMGQ:gas shut off valve copper pipe wall"/>
           <p:cNvSpPr/>
           <p:nvPr/>
         </p:nvSpPr>
@@ -10033,7 +11082,7 @@
       </p:sp>
       <p:sp>
         <p:nvSpPr>
-          <p:cNvPr id="9" name="TextBox 8"/>
+          <p:cNvPr id="10" name="TextBox 9"/>
           <p:cNvSpPr txBox="1"/>
           <p:nvPr/>
         </p:nvSpPr>
@@ -10073,7 +11122,7 @@
                 </a:solidFill>
                 <a:latin typeface="Montserrat"/>
               </a:rPr>
-              <a:t>small gas cylinder camping stove</a:t>
+              <a:t>gas shut off valve copper pipe wall</a:t>
             </a:r>
           </a:p>
         </p:txBody>
@@ -10170,7 +11219,7 @@
                 </a:solidFill>
                 <a:latin typeface="Montserrat"/>
               </a:rPr>
-              <a:t>009 / 015</a:t>
+              <a:t>009 / 016</a:t>
             </a:r>
           </a:p>
         </p:txBody>
@@ -10218,7 +11267,7 @@
         <p:spPr>
           <a:xfrm>
             <a:off x="822960" y="457200"/>
-            <a:ext cx="8229600" cy="365760"/>
+            <a:ext cx="10058400" cy="365760"/>
           </a:xfrm>
           <a:prstGeom prst="rect">
             <a:avLst/>
@@ -10232,13 +11281,13 @@
           <a:lstStyle/>
           <a:p>
             <a:r>
-              <a:rPr sz="1200" b="1" i="0">
-                <a:solidFill>
-                  <a:srgbClr val="64748B"/>
-                </a:solidFill>
-                <a:latin typeface="Montserrat"/>
-              </a:rPr>
-              <a:t>ARTÍCULO 2 · APLICACIÓN EN EL TIEMPO</a:t>
+              <a:rPr sz="1300" b="1" i="0">
+                <a:solidFill>
+                  <a:srgbClr val="E8801A"/>
+                </a:solidFill>
+                <a:latin typeface="Montserrat"/>
+              </a:rPr>
+              <a:t>ARTÍCULO 2 · EL LÍMITE DE 15 KG</a:t>
             </a:r>
           </a:p>
         </p:txBody>
@@ -10266,26 +11315,70 @@
           <a:lstStyle/>
           <a:p>
             <a:r>
-              <a:rPr sz="2700" b="1" i="0">
+              <a:rPr sz="2800" b="1" i="0">
                 <a:solidFill>
                   <a:srgbClr val="1E2761"/>
                 </a:solidFill>
                 <a:latin typeface="Montserrat"/>
               </a:rPr>
-              <a:t>¿Y las instalaciones viejas?</a:t>
-            </a:r>
-          </a:p>
-        </p:txBody>
-      </p:sp>
-      <p:sp>
-        <p:nvSpPr>
-          <p:cNvPr id="7" name="TextBox 6"/>
+              <a:t>¿Instalación o cacharro suelto?</a:t>
+            </a:r>
+          </a:p>
+        </p:txBody>
+      </p:sp>
+      <p:sp>
+        <p:nvSpPr>
+          <p:cNvPr id="7" name="Rounded Rectangle 6"/>
+          <p:cNvSpPr/>
+          <p:nvPr/>
+        </p:nvSpPr>
+        <p:spPr>
+          <a:xfrm>
+            <a:off x="868680" y="1627632"/>
+            <a:ext cx="2011680" cy="73152"/>
+          </a:xfrm>
+          <a:prstGeom prst="roundRect">
+            <a:avLst/>
+          </a:prstGeom>
+          <a:solidFill>
+            <a:srgbClr val="E8801A"/>
+          </a:solidFill>
+          <a:ln>
+            <a:noFill/>
+          </a:ln>
+          <a:effectLst/>
+        </p:spPr>
+        <p:style>
+          <a:lnRef idx="1">
+            <a:schemeClr val="accent1"/>
+          </a:lnRef>
+          <a:fillRef idx="3">
+            <a:schemeClr val="accent1"/>
+          </a:fillRef>
+          <a:effectRef idx="2">
+            <a:schemeClr val="accent1"/>
+          </a:effectRef>
+          <a:fontRef idx="minor">
+            <a:schemeClr val="lt1"/>
+          </a:fontRef>
+        </p:style>
+        <p:txBody>
+          <a:bodyPr rtlCol="0" anchor="ctr"/>
+          <a:lstStyle/>
+          <a:p>
+            <a:pPr algn="ctr"/>
+          </a:p>
+        </p:txBody>
+      </p:sp>
+      <p:sp>
+        <p:nvSpPr>
+          <p:cNvPr id="8" name="TextBox 7"/>
           <p:cNvSpPr txBox="1"/>
           <p:nvPr/>
         </p:nvSpPr>
         <p:spPr>
           <a:xfrm>
-            <a:off x="822960" y="1920240"/>
+            <a:off x="822960" y="1965960"/>
             <a:ext cx="4983480" cy="4206240"/>
           </a:xfrm>
           <a:prstGeom prst="rect">
@@ -10301,17 +11394,17 @@
           <a:p>
             <a:pPr>
               <a:spcAft>
-                <a:spcPts val="1000"/>
+                <a:spcPts val="1100"/>
               </a:spcAft>
             </a:pPr>
             <a:r>
               <a:rPr sz="1600" b="1" i="0">
                 <a:solidFill>
-                  <a:srgbClr val="2E3A80"/>
-                </a:solidFill>
-                <a:latin typeface="Montserrat"/>
-              </a:rPr>
-              <a:t>•  </a:t>
+                  <a:srgbClr val="E8801A"/>
+                </a:solidFill>
+                <a:latin typeface="Montserrat"/>
+              </a:rPr>
+              <a:t>▸  </a:t>
             </a:r>
             <a:r>
               <a:rPr sz="1600" b="0" i="0">
@@ -10320,23 +11413,23 @@
                 </a:solidFill>
                 <a:latin typeface="Montserrat"/>
               </a:rPr>
-              <a:t>Nuevas, modificaciones y ampliaciones</a:t>
+              <a:t>Bombona &lt;15 kg + un aparato móvil: fuera</a:t>
             </a:r>
           </a:p>
           <a:p>
             <a:pPr>
               <a:spcAft>
-                <a:spcPts val="1000"/>
+                <a:spcPts val="1100"/>
               </a:spcAft>
             </a:pPr>
             <a:r>
               <a:rPr sz="1600" b="1" i="0">
                 <a:solidFill>
-                  <a:srgbClr val="2E3A80"/>
-                </a:solidFill>
-                <a:latin typeface="Montserrat"/>
-              </a:rPr>
-              <a:t>•  </a:t>
+                  <a:srgbClr val="E8801A"/>
+                </a:solidFill>
+                <a:latin typeface="Montserrat"/>
+              </a:rPr>
+              <a:t>▸  </a:t>
             </a:r>
             <a:r>
               <a:rPr sz="1600" b="0" i="0">
@@ -10345,23 +11438,23 @@
                 </a:solidFill>
                 <a:latin typeface="Montserrat"/>
               </a:rPr>
-              <a:t>Existentes: solo lo que tocas se actualiza</a:t>
+              <a:t>Tubería fija o varios aparatos: dentro</a:t>
             </a:r>
           </a:p>
           <a:p>
             <a:pPr>
               <a:spcAft>
-                <a:spcPts val="1000"/>
+                <a:spcPts val="1100"/>
               </a:spcAft>
             </a:pPr>
             <a:r>
               <a:rPr sz="1600" b="1" i="0">
                 <a:solidFill>
-                  <a:srgbClr val="2E3A80"/>
-                </a:solidFill>
-                <a:latin typeface="Montserrat"/>
-              </a:rPr>
-              <a:t>•  </a:t>
+                  <a:srgbClr val="E8801A"/>
+                </a:solidFill>
+                <a:latin typeface="Montserrat"/>
+              </a:rPr>
+              <a:t>▸  </a:t>
             </a:r>
             <a:r>
               <a:rPr sz="1600" b="0" i="0">
@@ -10370,14 +11463,14 @@
                 </a:solidFill>
                 <a:latin typeface="Montserrat"/>
               </a:rPr>
-              <a:t>Controles periódicos: a todas, sin excepción</a:t>
-            </a:r>
-          </a:p>
-        </p:txBody>
-      </p:sp>
-      <p:sp>
-        <p:nvSpPr>
-          <p:cNvPr id="8" name="imgph" descr="IMGQ:old gas pipe brick wall"/>
+              <a:t>Dentro = boletín y prueba de estanquidad</a:t>
+            </a:r>
+          </a:p>
+        </p:txBody>
+      </p:sp>
+      <p:sp>
+        <p:nvSpPr>
+          <p:cNvPr id="9" name="imgph" descr="IMGQ:small gas cylinder camping stove"/>
           <p:cNvSpPr/>
           <p:nvPr/>
         </p:nvSpPr>
@@ -10423,7 +11516,7 @@
       </p:sp>
       <p:sp>
         <p:nvSpPr>
-          <p:cNvPr id="9" name="TextBox 8"/>
+          <p:cNvPr id="10" name="TextBox 9"/>
           <p:cNvSpPr txBox="1"/>
           <p:nvPr/>
         </p:nvSpPr>
@@ -10463,7 +11556,7 @@
                 </a:solidFill>
                 <a:latin typeface="Montserrat"/>
               </a:rPr>
-              <a:t>old gas pipe brick wall</a:t>
+              <a:t>small gas cylinder camping stove</a:t>
             </a:r>
           </a:p>
         </p:txBody>

</xml_diff>

<commit_message>
FASE 2: notas N1/N2 audio-first (podcast); quiz locutados (pregunta+opciones y respuesta) en los 49
Co-Authored-By: Claude Opus 4.8 <noreply@anthropic.com>
Claude-Session: https://claude.ai/code/session_01UvCPDpSUkU2UKG6kCugktD
</commit_message>
<xml_diff>
--- a/Curso Gas B/00 - El Reglamento de Gas - estructura, ambito y generalidades/00 - El Reglamento de Gas - Vídeo 1.pptx
+++ b/Curso Gas B/00 - El Reglamento de Gas - estructura, ambito y generalidades/00 - El Reglamento de Gas - Vídeo 1.pptx
@@ -598,12 +598,12 @@
           <a:lstStyle/>
           <a:p>
             <a:r>
-              <a:t>N1: Va la primera y es de tu terreno, así que no deberías fallarla. ¿Qué letra son las receptoras?</a:t>
-            </a:r>
-          </a:p>
-          <a:p>
-            <a:r>
-              <a:t>N2: Piensa en cuál de las nueve letras es la que vas a pisar cada día dentro de las viviendas.</a:t>
+              <a:t>N1: Vamos con la primera pregunta, y es de tu terreno, así que no deberías fallarla. Escucha bien: ¿qué letra del campo de aplicación corresponde a las instalaciones receptoras? Te leo las cuatro opciones. Opción A, la letra a, distribución por canalización. Opción B, la letra efe, instalaciones de envases de GLP. Opción C, la letra hache, instalaciones receptoras. Opción D, la letra i, aparatos de gas. Párala un momento si quieres y elige tu letra.</a:t>
+            </a:r>
+          </a:p>
+          <a:p>
+            <a:r>
+              <a:t>N2: Piensa en cuál de las nueve letras es la que vas a pisar cada día dentro de las viviendas; esa es tu respuesta.</a:t>
             </a:r>
           </a:p>
         </p:txBody>
@@ -673,12 +673,12 @@
           <a:lstStyle/>
           <a:p>
             <a:r>
-              <a:t>N1: ¿Por qué la hache?</a:t>
-            </a:r>
-          </a:p>
-          <a:p>
-            <a:r>
-              <a:t>N2: Porque el artículo segundo ordena los tipos por letras y reserva la hache a las instalaciones receptoras. El truco es asociar 'mi terreno' con la hache: la a es la red de la calle y la i son los aparatos, y ninguna de esas es la receptora.</a:t>
+              <a:t>N2: La respuesta correcta es la opción C: la letra hache, instalaciones receptoras. El artículo segundo ordena los tipos por letras y reserva la hache justamente a las receptoras, que son el terreno propio del gasista de categoría B. El truco para no fallar es asociar 'mi terreno' con la hache: la opción A, la letra a, es la red de la calle, y la opción D, la letra i, son los aparatos; ninguna de esas es la receptora.</a:t>
+            </a:r>
+          </a:p>
+          <a:p>
+            <a:r>
+              <a:t>N1: Hache de 'hogar', si te ayuda a recordarlo.</a:t>
             </a:r>
           </a:p>
         </p:txBody>
@@ -823,12 +823,12 @@
           <a:lstStyle/>
           <a:p>
             <a:r>
-              <a:t>N1: Una que cae fijo. ¿Dónde empieza y dónde acaba lo que es tuyo?</a:t>
-            </a:r>
-          </a:p>
-          <a:p>
-            <a:r>
-              <a:t>N2: Acuérdate del truco de la llave del portal: lo que pone la compañía no es tuyo.</a:t>
+              <a:t>N1: Esta cae fijo, presta atención. La pregunta es: ¿entre qué elementos está comprendida la instalación receptora? Escucha las cuatro opciones. Opción A, de la llave de acometida incluida a la llave de aparato incluida. Opción B, de la llave de acometida excluida a la llave de conexión de aparato incluida. Opción C, del contador hasta los propios aparatos, ambos incluidos. Opción D, de la llave de aparato excluida hasta el propio aparato. Tómate un segundo y decide.</a:t>
+            </a:r>
+          </a:p>
+          <a:p>
+            <a:r>
+              <a:t>N2: Acuérdate del truco de la llave del portal: lo que pone la compañía no es tuyo, va fuera.</a:t>
             </a:r>
           </a:p>
         </p:txBody>
@@ -898,12 +898,12 @@
           <a:lstStyle/>
           <a:p>
             <a:r>
-              <a:t>N1: ¿Por qué esa opción y no otra?</a:t>
-            </a:r>
-          </a:p>
-          <a:p>
-            <a:r>
-              <a:t>N2: La acometida va excluida porque la pone la compañía, como la llave del portal; y la llave del aparato va incluida porque es lo último que es tuyo. El fallo típico es meter la acometida dentro o quedarse el aparato: ni una ni otra.</a:t>
+              <a:t>N2: La respuesta correcta es la opción B: de la llave de acometida excluida a la llave de conexión de aparato incluida. La acometida va excluida porque la pone la compañía, como la llave del portal; y la llave del aparato va incluida porque es lo último que es tuyo. El fallo típico es la opción A, que mete la acometida dentro, o la opción D, que se queda el aparato; ni una ni otra. La opción C se inventa el contador como frontera, y tampoco.</a:t>
+            </a:r>
+          </a:p>
+          <a:p>
+            <a:r>
+              <a:t>N1: Acometida fuera, llave del aparato dentro; con eso la clavas.</a:t>
             </a:r>
           </a:p>
         </p:txBody>

</xml_diff>